<commit_message>
Week 1: rebuild all four lectures to full standard (objectives, quiz, summary, real examples)
</commit_message>
<xml_diff>
--- a/courses/z2005/00-oop-then-algorithms/lecture-1.pptx
+++ b/courses/z2005/00-oop-then-algorithms/lecture-1.pptx
@@ -5,7 +5,7 @@
     <p:sldMasterId id="2147483648" r:id="rId1"/>
   </p:sldMasterIdLst>
   <p:notesMasterIdLst>
-    <p:notesMasterId r:id="rId12"/>
+    <p:notesMasterId r:id="rId16"/>
   </p:notesMasterIdLst>
   <p:sldIdLst>
     <p:sldId id="256" r:id="rId2"/>
@@ -18,6 +18,10 @@
     <p:sldId id="263" r:id="rId9"/>
     <p:sldId id="264" r:id="rId10"/>
     <p:sldId id="265" r:id="rId11"/>
+    <p:sldId id="266" r:id="rId12"/>
+    <p:sldId id="267" r:id="rId13"/>
+    <p:sldId id="268" r:id="rId14"/>
+    <p:sldId id="269" r:id="rId15"/>
   </p:sldIdLst>
   <p:sldSz cx="9144000" cy="5143500" type="screen16x9"/>
   <p:notesSz cx="6858000" cy="9144000"/>
@@ -555,7 +559,7 @@
           <a:p>
             <a:fld id="{18BDFEC3-8487-43E8-A154-7C12CBC1FFF2}" type="slidenum">
               <a:rPr lang="en-US"/>
-              <a:t>2</a:t>
+              <a:t>4</a:t>
             </a:fld>
             <a:endParaRPr lang="en-US"/>
           </a:p>
@@ -647,7 +651,7 @@
           <a:p>
             <a:fld id="{18BDFEC3-8487-43E8-A154-7C12CBC1FFF2}" type="slidenum">
               <a:rPr lang="en-US"/>
-              <a:t>9</a:t>
+              <a:t>11</a:t>
             </a:fld>
             <a:endParaRPr lang="en-US"/>
           </a:p>
@@ -3733,7 +3737,937 @@
             </a:pPr>
             <a:r>
               <a:rPr/>
-              <a:t>Before next lecture</a:t>
+              <a:t>Common first mistake</a:t>
+            </a:r>
+          </a:p>
+        </p:txBody>
+      </p:sp>
+      <p:sp>
+        <p:nvSpPr>
+          <p:cNvPr id="3" name="Content Placeholder 2"/>
+          <p:cNvSpPr>
+            <a:spLocks noGrp="1"/>
+          </p:cNvSpPr>
+          <p:nvPr>
+            <p:ph idx="1"/>
+          </p:nvPr>
+        </p:nvSpPr>
+        <p:spPr/>
+        <p:txBody>
+          <a:bodyPr/>
+          <a:lstStyle/>
+          <a:p>
+            <a:pPr lvl="0" indent="0">
+              <a:buNone/>
+            </a:pPr>
+            <a:r>
+              <a:rPr b="1">
+                <a:solidFill>
+                  <a:srgbClr val="007020"/>
+                </a:solidFill>
+                <a:latin typeface="Courier"/>
+              </a:rPr>
+              <a:t>class</a:t>
+            </a:r>
+            <a:r>
+              <a:rPr>
+                <a:latin typeface="Courier"/>
+              </a:rPr>
+              <a:t> Point:</a:t>
+            </a:r>
+            <a:br/>
+            <a:r>
+              <a:rPr>
+                <a:latin typeface="Courier"/>
+              </a:rPr>
+              <a:t>    </a:t>
+            </a:r>
+            <a:r>
+              <a:rPr b="1">
+                <a:solidFill>
+                  <a:srgbClr val="007020"/>
+                </a:solidFill>
+                <a:latin typeface="Courier"/>
+              </a:rPr>
+              <a:t>def</a:t>
+            </a:r>
+            <a:r>
+              <a:rPr>
+                <a:latin typeface="Courier"/>
+              </a:rPr>
+              <a:t> </a:t>
+            </a:r>
+            <a:r>
+              <a:rPr>
+                <a:solidFill>
+                  <a:srgbClr val="06287E"/>
+                </a:solidFill>
+                <a:latin typeface="Courier"/>
+              </a:rPr>
+              <a:t>__init__</a:t>
+            </a:r>
+            <a:r>
+              <a:rPr>
+                <a:latin typeface="Courier"/>
+              </a:rPr>
+              <a:t>(</a:t>
+            </a:r>
+            <a:r>
+              <a:rPr>
+                <a:solidFill>
+                  <a:srgbClr val="19177C"/>
+                </a:solidFill>
+                <a:latin typeface="Courier"/>
+              </a:rPr>
+              <a:t>self</a:t>
+            </a:r>
+            <a:r>
+              <a:rPr>
+                <a:latin typeface="Courier"/>
+              </a:rPr>
+              <a:t>, x, y):</a:t>
+            </a:r>
+            <a:br/>
+            <a:r>
+              <a:rPr>
+                <a:latin typeface="Courier"/>
+              </a:rPr>
+              <a:t>        x </a:t>
+            </a:r>
+            <a:r>
+              <a:rPr>
+                <a:solidFill>
+                  <a:srgbClr val="666666"/>
+                </a:solidFill>
+                <a:latin typeface="Courier"/>
+              </a:rPr>
+              <a:t>=</a:t>
+            </a:r>
+            <a:r>
+              <a:rPr>
+                <a:latin typeface="Courier"/>
+              </a:rPr>
+              <a:t> x        </a:t>
+            </a:r>
+            <a:r>
+              <a:rPr i="1">
+                <a:solidFill>
+                  <a:srgbClr val="60A0B0"/>
+                </a:solidFill>
+                <a:latin typeface="Courier"/>
+              </a:rPr>
+              <a:t># </a:t>
+            </a:r>
+            <a:r>
+              <a:rPr b="1">
+                <a:solidFill>
+                  <a:srgbClr val="FF0000"/>
+                </a:solidFill>
+                <a:latin typeface="Courier"/>
+              </a:rPr>
+              <a:t>BUG</a:t>
+            </a:r>
+            <a:r>
+              <a:rPr i="1">
+                <a:solidFill>
+                  <a:srgbClr val="60A0B0"/>
+                </a:solidFill>
+                <a:latin typeface="Courier"/>
+              </a:rPr>
+              <a:t>: assigns to the local parameter, not self.x</a:t>
+            </a:r>
+            <a:br/>
+            <a:r>
+              <a:rPr>
+                <a:latin typeface="Courier"/>
+              </a:rPr>
+              <a:t>        y </a:t>
+            </a:r>
+            <a:r>
+              <a:rPr>
+                <a:solidFill>
+                  <a:srgbClr val="666666"/>
+                </a:solidFill>
+                <a:latin typeface="Courier"/>
+              </a:rPr>
+              <a:t>=</a:t>
+            </a:r>
+            <a:r>
+              <a:rPr>
+                <a:latin typeface="Courier"/>
+              </a:rPr>
+              <a:t> y</a:t>
+            </a:r>
+            <a:br/>
+            <a:br/>
+            <a:r>
+              <a:rPr>
+                <a:latin typeface="Courier"/>
+              </a:rPr>
+              <a:t>p </a:t>
+            </a:r>
+            <a:r>
+              <a:rPr>
+                <a:solidFill>
+                  <a:srgbClr val="666666"/>
+                </a:solidFill>
+                <a:latin typeface="Courier"/>
+              </a:rPr>
+              <a:t>=</a:t>
+            </a:r>
+            <a:r>
+              <a:rPr>
+                <a:latin typeface="Courier"/>
+              </a:rPr>
+              <a:t> Point(</a:t>
+            </a:r>
+            <a:r>
+              <a:rPr>
+                <a:solidFill>
+                  <a:srgbClr val="40A070"/>
+                </a:solidFill>
+                <a:latin typeface="Courier"/>
+              </a:rPr>
+              <a:t>3</a:t>
+            </a:r>
+            <a:r>
+              <a:rPr>
+                <a:latin typeface="Courier"/>
+              </a:rPr>
+              <a:t>, </a:t>
+            </a:r>
+            <a:r>
+              <a:rPr>
+                <a:solidFill>
+                  <a:srgbClr val="40A070"/>
+                </a:solidFill>
+                <a:latin typeface="Courier"/>
+              </a:rPr>
+              <a:t>4</a:t>
+            </a:r>
+            <a:r>
+              <a:rPr>
+                <a:latin typeface="Courier"/>
+              </a:rPr>
+              <a:t>)</a:t>
+            </a:r>
+            <a:br/>
+            <a:r>
+              <a:rPr>
+                <a:solidFill>
+                  <a:srgbClr val="008000"/>
+                </a:solidFill>
+                <a:latin typeface="Courier"/>
+              </a:rPr>
+              <a:t>print</a:t>
+            </a:r>
+            <a:r>
+              <a:rPr>
+                <a:latin typeface="Courier"/>
+              </a:rPr>
+              <a:t>(p.x)   </a:t>
+            </a:r>
+            <a:r>
+              <a:rPr i="1">
+                <a:solidFill>
+                  <a:srgbClr val="60A0B0"/>
+                </a:solidFill>
+                <a:latin typeface="Courier"/>
+              </a:rPr>
+              <a:t># AttributeError: 'Point' object has no attribute 'x'</a:t>
+            </a:r>
+          </a:p>
+        </p:txBody>
+      </p:sp>
+    </p:spTree>
+  </p:cSld>
+</p:sld>
+</file>
+
+<file path=ppt/slides/slide11.xml><?xml version="1.0" encoding="utf-8"?>
+<p:sld xmlns:a="http://schemas.openxmlformats.org/drawingml/2006/main" xmlns:r="http://schemas.openxmlformats.org/officeDocument/2006/relationships" xmlns:p="http://schemas.openxmlformats.org/presentationml/2006/main">
+  <p:cSld>
+    <p:spTree>
+      <p:nvGrpSpPr>
+        <p:cNvPr id="1" name=""/>
+        <p:cNvGrpSpPr/>
+        <p:nvPr/>
+      </p:nvGrpSpPr>
+      <p:grpSpPr>
+        <a:xfrm>
+          <a:off x="0" y="0"/>
+          <a:ext cx="0" cy="0"/>
+          <a:chOff x="0" y="0"/>
+          <a:chExt cx="0" cy="0"/>
+        </a:xfrm>
+      </p:grpSpPr>
+      <p:sp>
+        <p:nvSpPr>
+          <p:cNvPr id="2" name="Title 1"/>
+          <p:cNvSpPr>
+            <a:spLocks noGrp="1"/>
+          </p:cNvSpPr>
+          <p:nvPr>
+            <p:ph type="title"/>
+          </p:nvPr>
+        </p:nvSpPr>
+        <p:spPr/>
+        <p:txBody>
+          <a:bodyPr/>
+          <a:lstStyle/>
+          <a:p>
+            <a:pPr lvl="0" indent="0" marL="0">
+              <a:buNone/>
+            </a:pPr>
+            <a:r>
+              <a:rPr/>
+              <a:t>Live coding exercise (5 minutes)</a:t>
+            </a:r>
+          </a:p>
+        </p:txBody>
+      </p:sp>
+      <p:sp>
+        <p:nvSpPr>
+          <p:cNvPr id="3" name="Content Placeholder 2"/>
+          <p:cNvSpPr>
+            <a:spLocks noGrp="1"/>
+          </p:cNvSpPr>
+          <p:nvPr>
+            <p:ph idx="1"/>
+          </p:nvPr>
+        </p:nvSpPr>
+        <p:spPr/>
+        <p:txBody>
+          <a:bodyPr/>
+          <a:lstStyle/>
+          <a:p>
+            <a:pPr lvl="0" indent="0">
+              <a:buNone/>
+            </a:pPr>
+            <a:r>
+              <a:rPr b="1">
+                <a:solidFill>
+                  <a:srgbClr val="007020"/>
+                </a:solidFill>
+                <a:latin typeface="Courier"/>
+              </a:rPr>
+              <a:t>def</a:t>
+            </a:r>
+            <a:r>
+              <a:rPr>
+                <a:latin typeface="Courier"/>
+              </a:rPr>
+              <a:t> midpoint(</a:t>
+            </a:r>
+            <a:r>
+              <a:rPr>
+                <a:solidFill>
+                  <a:srgbClr val="19177C"/>
+                </a:solidFill>
+                <a:latin typeface="Courier"/>
+              </a:rPr>
+              <a:t>self</a:t>
+            </a:r>
+            <a:r>
+              <a:rPr>
+                <a:latin typeface="Courier"/>
+              </a:rPr>
+              <a:t>, other):</a:t>
+            </a:r>
+            <a:br/>
+            <a:r>
+              <a:rPr>
+                <a:latin typeface="Courier"/>
+              </a:rPr>
+              <a:t>    </a:t>
+            </a:r>
+            <a:r>
+              <a:rPr b="1">
+                <a:solidFill>
+                  <a:srgbClr val="007020"/>
+                </a:solidFill>
+                <a:latin typeface="Courier"/>
+              </a:rPr>
+              <a:t>return</a:t>
+            </a:r>
+            <a:r>
+              <a:rPr>
+                <a:latin typeface="Courier"/>
+              </a:rPr>
+              <a:t> Point((</a:t>
+            </a:r>
+            <a:r>
+              <a:rPr>
+                <a:solidFill>
+                  <a:srgbClr val="19177C"/>
+                </a:solidFill>
+                <a:latin typeface="Courier"/>
+              </a:rPr>
+              <a:t>self</a:t>
+            </a:r>
+            <a:r>
+              <a:rPr>
+                <a:latin typeface="Courier"/>
+              </a:rPr>
+              <a:t>.x </a:t>
+            </a:r>
+            <a:r>
+              <a:rPr>
+                <a:solidFill>
+                  <a:srgbClr val="666666"/>
+                </a:solidFill>
+                <a:latin typeface="Courier"/>
+              </a:rPr>
+              <a:t>+</a:t>
+            </a:r>
+            <a:r>
+              <a:rPr>
+                <a:latin typeface="Courier"/>
+              </a:rPr>
+              <a:t> other.x) </a:t>
+            </a:r>
+            <a:r>
+              <a:rPr>
+                <a:solidFill>
+                  <a:srgbClr val="666666"/>
+                </a:solidFill>
+                <a:latin typeface="Courier"/>
+              </a:rPr>
+              <a:t>/</a:t>
+            </a:r>
+            <a:r>
+              <a:rPr>
+                <a:latin typeface="Courier"/>
+              </a:rPr>
+              <a:t> </a:t>
+            </a:r>
+            <a:r>
+              <a:rPr>
+                <a:solidFill>
+                  <a:srgbClr val="40A070"/>
+                </a:solidFill>
+                <a:latin typeface="Courier"/>
+              </a:rPr>
+              <a:t>2</a:t>
+            </a:r>
+            <a:r>
+              <a:rPr>
+                <a:latin typeface="Courier"/>
+              </a:rPr>
+              <a:t>,</a:t>
+            </a:r>
+            <a:br/>
+            <a:r>
+              <a:rPr>
+                <a:latin typeface="Courier"/>
+              </a:rPr>
+              <a:t>                  (</a:t>
+            </a:r>
+            <a:r>
+              <a:rPr>
+                <a:solidFill>
+                  <a:srgbClr val="19177C"/>
+                </a:solidFill>
+                <a:latin typeface="Courier"/>
+              </a:rPr>
+              <a:t>self</a:t>
+            </a:r>
+            <a:r>
+              <a:rPr>
+                <a:latin typeface="Courier"/>
+              </a:rPr>
+              <a:t>.y </a:t>
+            </a:r>
+            <a:r>
+              <a:rPr>
+                <a:solidFill>
+                  <a:srgbClr val="666666"/>
+                </a:solidFill>
+                <a:latin typeface="Courier"/>
+              </a:rPr>
+              <a:t>+</a:t>
+            </a:r>
+            <a:r>
+              <a:rPr>
+                <a:latin typeface="Courier"/>
+              </a:rPr>
+              <a:t> other.y) </a:t>
+            </a:r>
+            <a:r>
+              <a:rPr>
+                <a:solidFill>
+                  <a:srgbClr val="666666"/>
+                </a:solidFill>
+                <a:latin typeface="Courier"/>
+              </a:rPr>
+              <a:t>/</a:t>
+            </a:r>
+            <a:r>
+              <a:rPr>
+                <a:latin typeface="Courier"/>
+              </a:rPr>
+              <a:t> </a:t>
+            </a:r>
+            <a:r>
+              <a:rPr>
+                <a:solidFill>
+                  <a:srgbClr val="40A070"/>
+                </a:solidFill>
+                <a:latin typeface="Courier"/>
+              </a:rPr>
+              <a:t>2</a:t>
+            </a:r>
+            <a:r>
+              <a:rPr>
+                <a:latin typeface="Courier"/>
+              </a:rPr>
+              <a:t>)</a:t>
+            </a:r>
+          </a:p>
+        </p:txBody>
+      </p:sp>
+    </p:spTree>
+  </p:cSld>
+</p:sld>
+</file>
+
+<file path=ppt/slides/slide12.xml><?xml version="1.0" encoding="utf-8"?>
+<p:sld xmlns:a="http://schemas.openxmlformats.org/drawingml/2006/main" xmlns:r="http://schemas.openxmlformats.org/officeDocument/2006/relationships" xmlns:p="http://schemas.openxmlformats.org/presentationml/2006/main">
+  <p:cSld>
+    <p:spTree>
+      <p:nvGrpSpPr>
+        <p:cNvPr id="1" name=""/>
+        <p:cNvGrpSpPr/>
+        <p:nvPr/>
+      </p:nvGrpSpPr>
+      <p:grpSpPr>
+        <a:xfrm>
+          <a:off x="0" y="0"/>
+          <a:ext cx="0" cy="0"/>
+          <a:chOff x="0" y="0"/>
+          <a:chExt cx="0" cy="0"/>
+        </a:xfrm>
+      </p:grpSpPr>
+      <p:sp>
+        <p:nvSpPr>
+          <p:cNvPr id="2" name="Title 1"/>
+          <p:cNvSpPr>
+            <a:spLocks noGrp="1"/>
+          </p:cNvSpPr>
+          <p:nvPr>
+            <p:ph type="title"/>
+          </p:nvPr>
+        </p:nvSpPr>
+        <p:spPr/>
+        <p:txBody>
+          <a:bodyPr/>
+          <a:lstStyle/>
+          <a:p>
+            <a:pPr lvl="0" indent="0" marL="0">
+              <a:buNone/>
+            </a:pPr>
+            <a:r>
+              <a:rPr/>
+              <a:t>Quiz — spot the bug</a:t>
+            </a:r>
+          </a:p>
+        </p:txBody>
+      </p:sp>
+      <p:sp>
+        <p:nvSpPr>
+          <p:cNvPr id="3" name="Content Placeholder 2"/>
+          <p:cNvSpPr>
+            <a:spLocks noGrp="1"/>
+          </p:cNvSpPr>
+          <p:nvPr>
+            <p:ph idx="1"/>
+          </p:nvPr>
+        </p:nvSpPr>
+        <p:spPr/>
+        <p:txBody>
+          <a:bodyPr/>
+          <a:lstStyle/>
+          <a:p>
+            <a:pPr lvl="0" indent="0">
+              <a:buNone/>
+            </a:pPr>
+            <a:r>
+              <a:rPr b="1">
+                <a:solidFill>
+                  <a:srgbClr val="007020"/>
+                </a:solidFill>
+                <a:latin typeface="Courier"/>
+              </a:rPr>
+              <a:t>class</a:t>
+            </a:r>
+            <a:r>
+              <a:rPr>
+                <a:latin typeface="Courier"/>
+              </a:rPr>
+              <a:t> Rectangle:</a:t>
+            </a:r>
+            <a:br/>
+            <a:r>
+              <a:rPr>
+                <a:latin typeface="Courier"/>
+              </a:rPr>
+              <a:t>    </a:t>
+            </a:r>
+            <a:r>
+              <a:rPr b="1">
+                <a:solidFill>
+                  <a:srgbClr val="007020"/>
+                </a:solidFill>
+                <a:latin typeface="Courier"/>
+              </a:rPr>
+              <a:t>def</a:t>
+            </a:r>
+            <a:r>
+              <a:rPr>
+                <a:latin typeface="Courier"/>
+              </a:rPr>
+              <a:t> </a:t>
+            </a:r>
+            <a:r>
+              <a:rPr>
+                <a:solidFill>
+                  <a:srgbClr val="06287E"/>
+                </a:solidFill>
+                <a:latin typeface="Courier"/>
+              </a:rPr>
+              <a:t>__init__</a:t>
+            </a:r>
+            <a:r>
+              <a:rPr>
+                <a:latin typeface="Courier"/>
+              </a:rPr>
+              <a:t>(</a:t>
+            </a:r>
+            <a:r>
+              <a:rPr>
+                <a:solidFill>
+                  <a:srgbClr val="19177C"/>
+                </a:solidFill>
+                <a:latin typeface="Courier"/>
+              </a:rPr>
+              <a:t>self</a:t>
+            </a:r>
+            <a:r>
+              <a:rPr>
+                <a:latin typeface="Courier"/>
+              </a:rPr>
+              <a:t>, w, h):</a:t>
+            </a:r>
+            <a:br/>
+            <a:r>
+              <a:rPr>
+                <a:latin typeface="Courier"/>
+              </a:rPr>
+              <a:t>        w </a:t>
+            </a:r>
+            <a:r>
+              <a:rPr>
+                <a:solidFill>
+                  <a:srgbClr val="666666"/>
+                </a:solidFill>
+                <a:latin typeface="Courier"/>
+              </a:rPr>
+              <a:t>=</a:t>
+            </a:r>
+            <a:r>
+              <a:rPr>
+                <a:latin typeface="Courier"/>
+              </a:rPr>
+              <a:t> w</a:t>
+            </a:r>
+            <a:br/>
+            <a:r>
+              <a:rPr>
+                <a:latin typeface="Courier"/>
+              </a:rPr>
+              <a:t>        h </a:t>
+            </a:r>
+            <a:r>
+              <a:rPr>
+                <a:solidFill>
+                  <a:srgbClr val="666666"/>
+                </a:solidFill>
+                <a:latin typeface="Courier"/>
+              </a:rPr>
+              <a:t>=</a:t>
+            </a:r>
+            <a:r>
+              <a:rPr>
+                <a:latin typeface="Courier"/>
+              </a:rPr>
+              <a:t> h</a:t>
+            </a:r>
+            <a:br/>
+            <a:r>
+              <a:rPr>
+                <a:latin typeface="Courier"/>
+              </a:rPr>
+              <a:t>    </a:t>
+            </a:r>
+            <a:r>
+              <a:rPr b="1">
+                <a:solidFill>
+                  <a:srgbClr val="007020"/>
+                </a:solidFill>
+                <a:latin typeface="Courier"/>
+              </a:rPr>
+              <a:t>def</a:t>
+            </a:r>
+            <a:r>
+              <a:rPr>
+                <a:latin typeface="Courier"/>
+              </a:rPr>
+              <a:t> area(</a:t>
+            </a:r>
+            <a:r>
+              <a:rPr>
+                <a:solidFill>
+                  <a:srgbClr val="19177C"/>
+                </a:solidFill>
+                <a:latin typeface="Courier"/>
+              </a:rPr>
+              <a:t>self</a:t>
+            </a:r>
+            <a:r>
+              <a:rPr>
+                <a:latin typeface="Courier"/>
+              </a:rPr>
+              <a:t>):</a:t>
+            </a:r>
+            <a:br/>
+            <a:r>
+              <a:rPr>
+                <a:latin typeface="Courier"/>
+              </a:rPr>
+              <a:t>        </a:t>
+            </a:r>
+            <a:r>
+              <a:rPr b="1">
+                <a:solidFill>
+                  <a:srgbClr val="007020"/>
+                </a:solidFill>
+                <a:latin typeface="Courier"/>
+              </a:rPr>
+              <a:t>return</a:t>
+            </a:r>
+            <a:r>
+              <a:rPr>
+                <a:latin typeface="Courier"/>
+              </a:rPr>
+              <a:t> </a:t>
+            </a:r>
+            <a:r>
+              <a:rPr>
+                <a:solidFill>
+                  <a:srgbClr val="19177C"/>
+                </a:solidFill>
+                <a:latin typeface="Courier"/>
+              </a:rPr>
+              <a:t>self</a:t>
+            </a:r>
+            <a:r>
+              <a:rPr>
+                <a:latin typeface="Courier"/>
+              </a:rPr>
+              <a:t>.w </a:t>
+            </a:r>
+            <a:r>
+              <a:rPr>
+                <a:solidFill>
+                  <a:srgbClr val="666666"/>
+                </a:solidFill>
+                <a:latin typeface="Courier"/>
+              </a:rPr>
+              <a:t>*</a:t>
+            </a:r>
+            <a:r>
+              <a:rPr>
+                <a:latin typeface="Courier"/>
+              </a:rPr>
+              <a:t> </a:t>
+            </a:r>
+            <a:r>
+              <a:rPr>
+                <a:solidFill>
+                  <a:srgbClr val="19177C"/>
+                </a:solidFill>
+                <a:latin typeface="Courier"/>
+              </a:rPr>
+              <a:t>self</a:t>
+            </a:r>
+            <a:r>
+              <a:rPr>
+                <a:latin typeface="Courier"/>
+              </a:rPr>
+              <a:t>.h</a:t>
+            </a:r>
+            <a:br/>
+            <a:br/>
+            <a:r>
+              <a:rPr>
+                <a:latin typeface="Courier"/>
+              </a:rPr>
+              <a:t>r </a:t>
+            </a:r>
+            <a:r>
+              <a:rPr>
+                <a:solidFill>
+                  <a:srgbClr val="666666"/>
+                </a:solidFill>
+                <a:latin typeface="Courier"/>
+              </a:rPr>
+              <a:t>=</a:t>
+            </a:r>
+            <a:r>
+              <a:rPr>
+                <a:latin typeface="Courier"/>
+              </a:rPr>
+              <a:t> Rectangle(</a:t>
+            </a:r>
+            <a:r>
+              <a:rPr>
+                <a:solidFill>
+                  <a:srgbClr val="40A070"/>
+                </a:solidFill>
+                <a:latin typeface="Courier"/>
+              </a:rPr>
+              <a:t>4</a:t>
+            </a:r>
+            <a:r>
+              <a:rPr>
+                <a:latin typeface="Courier"/>
+              </a:rPr>
+              <a:t>, </a:t>
+            </a:r>
+            <a:r>
+              <a:rPr>
+                <a:solidFill>
+                  <a:srgbClr val="40A070"/>
+                </a:solidFill>
+                <a:latin typeface="Courier"/>
+              </a:rPr>
+              <a:t>5</a:t>
+            </a:r>
+            <a:r>
+              <a:rPr>
+                <a:latin typeface="Courier"/>
+              </a:rPr>
+              <a:t>)</a:t>
+            </a:r>
+            <a:br/>
+            <a:r>
+              <a:rPr>
+                <a:solidFill>
+                  <a:srgbClr val="008000"/>
+                </a:solidFill>
+                <a:latin typeface="Courier"/>
+              </a:rPr>
+              <a:t>print</a:t>
+            </a:r>
+            <a:r>
+              <a:rPr>
+                <a:latin typeface="Courier"/>
+              </a:rPr>
+              <a:t>(r.area())</a:t>
+            </a:r>
+          </a:p>
+        </p:txBody>
+      </p:sp>
+    </p:spTree>
+  </p:cSld>
+</p:sld>
+</file>
+
+<file path=ppt/slides/slide13.xml><?xml version="1.0" encoding="utf-8"?>
+<p:sld xmlns:a="http://schemas.openxmlformats.org/drawingml/2006/main" xmlns:r="http://schemas.openxmlformats.org/officeDocument/2006/relationships" xmlns:p="http://schemas.openxmlformats.org/presentationml/2006/main">
+  <p:cSld>
+    <p:spTree>
+      <p:nvGrpSpPr>
+        <p:cNvPr id="1" name=""/>
+        <p:cNvGrpSpPr/>
+        <p:nvPr/>
+      </p:nvGrpSpPr>
+      <p:grpSpPr>
+        <a:xfrm>
+          <a:off x="0" y="0"/>
+          <a:ext cx="0" cy="0"/>
+          <a:chOff x="0" y="0"/>
+          <a:chExt cx="0" cy="0"/>
+        </a:xfrm>
+      </p:grpSpPr>
+      <p:sp>
+        <p:nvSpPr>
+          <p:cNvPr id="2" name="Title 1"/>
+          <p:cNvSpPr>
+            <a:spLocks noGrp="1"/>
+          </p:cNvSpPr>
+          <p:nvPr>
+            <p:ph type="title"/>
+          </p:nvPr>
+        </p:nvSpPr>
+        <p:spPr/>
+        <p:txBody>
+          <a:bodyPr/>
+          <a:lstStyle/>
+          <a:p>
+            <a:pPr lvl="0" indent="0" marL="0">
+              <a:buNone/>
+            </a:pPr>
+            <a:r>
+              <a:rPr/>
+              <a:t>Quiz — answer</a:t>
+            </a:r>
+          </a:p>
+        </p:txBody>
+      </p:sp>
+    </p:spTree>
+  </p:cSld>
+</p:sld>
+</file>
+
+<file path=ppt/slides/slide14.xml><?xml version="1.0" encoding="utf-8"?>
+<p:sld xmlns:a="http://schemas.openxmlformats.org/drawingml/2006/main" xmlns:r="http://schemas.openxmlformats.org/officeDocument/2006/relationships" xmlns:p="http://schemas.openxmlformats.org/presentationml/2006/main">
+  <p:cSld>
+    <p:spTree>
+      <p:nvGrpSpPr>
+        <p:cNvPr id="1" name=""/>
+        <p:cNvGrpSpPr/>
+        <p:nvPr/>
+      </p:nvGrpSpPr>
+      <p:grpSpPr>
+        <a:xfrm>
+          <a:off x="0" y="0"/>
+          <a:ext cx="0" cy="0"/>
+          <a:chOff x="0" y="0"/>
+          <a:chExt cx="0" cy="0"/>
+        </a:xfrm>
+      </p:grpSpPr>
+      <p:sp>
+        <p:nvSpPr>
+          <p:cNvPr id="2" name="Title 1"/>
+          <p:cNvSpPr>
+            <a:spLocks noGrp="1"/>
+          </p:cNvSpPr>
+          <p:nvPr>
+            <p:ph type="title"/>
+          </p:nvPr>
+        </p:nvSpPr>
+        <p:spPr/>
+        <p:txBody>
+          <a:bodyPr/>
+          <a:lstStyle/>
+          <a:p>
+            <a:pPr lvl="0" indent="0" marL="0">
+              <a:buNone/>
+            </a:pPr>
+            <a:r>
+              <a:rPr/>
+              <a:t>Summary</a:t>
             </a:r>
           </a:p>
         </p:txBody>
@@ -3780,7 +4714,7 @@
             </a:pPr>
             <a:r>
               <a:rPr/>
-              <a:t>Why we start here, not with data structures</a:t>
+              <a:t>Objectives</a:t>
             </a:r>
           </a:p>
         </p:txBody>
@@ -3827,342 +4761,7 @@
             </a:pPr>
             <a:r>
               <a:rPr/>
-              <a:t>The problem, before the solution</a:t>
-            </a:r>
-          </a:p>
-        </p:txBody>
-      </p:sp>
-      <p:sp>
-        <p:nvSpPr>
-          <p:cNvPr id="3" name="Content Placeholder 2"/>
-          <p:cNvSpPr>
-            <a:spLocks noGrp="1"/>
-          </p:cNvSpPr>
-          <p:nvPr>
-            <p:ph idx="1"/>
-          </p:nvPr>
-        </p:nvSpPr>
-        <p:spPr/>
-        <p:txBody>
-          <a:bodyPr/>
-          <a:lstStyle/>
-          <a:p>
-            <a:pPr lvl="0" indent="0">
-              <a:buNone/>
-            </a:pPr>
-            <a:r>
-              <a:rPr>
-                <a:latin typeface="Courier"/>
-              </a:rPr>
-              <a:t>p1 </a:t>
-            </a:r>
-            <a:r>
-              <a:rPr>
-                <a:solidFill>
-                  <a:srgbClr val="666666"/>
-                </a:solidFill>
-                <a:latin typeface="Courier"/>
-              </a:rPr>
-              <a:t>=</a:t>
-            </a:r>
-            <a:r>
-              <a:rPr>
-                <a:latin typeface="Courier"/>
-              </a:rPr>
-              <a:t> (</a:t>
-            </a:r>
-            <a:r>
-              <a:rPr>
-                <a:solidFill>
-                  <a:srgbClr val="40A070"/>
-                </a:solidFill>
-                <a:latin typeface="Courier"/>
-              </a:rPr>
-              <a:t>0</a:t>
-            </a:r>
-            <a:r>
-              <a:rPr>
-                <a:latin typeface="Courier"/>
-              </a:rPr>
-              <a:t>, </a:t>
-            </a:r>
-            <a:r>
-              <a:rPr>
-                <a:solidFill>
-                  <a:srgbClr val="40A070"/>
-                </a:solidFill>
-                <a:latin typeface="Courier"/>
-              </a:rPr>
-              <a:t>0</a:t>
-            </a:r>
-            <a:r>
-              <a:rPr>
-                <a:latin typeface="Courier"/>
-              </a:rPr>
-              <a:t>)</a:t>
-            </a:r>
-            <a:br/>
-            <a:r>
-              <a:rPr>
-                <a:latin typeface="Courier"/>
-              </a:rPr>
-              <a:t>p2 </a:t>
-            </a:r>
-            <a:r>
-              <a:rPr>
-                <a:solidFill>
-                  <a:srgbClr val="666666"/>
-                </a:solidFill>
-                <a:latin typeface="Courier"/>
-              </a:rPr>
-              <a:t>=</a:t>
-            </a:r>
-            <a:r>
-              <a:rPr>
-                <a:latin typeface="Courier"/>
-              </a:rPr>
-              <a:t> (</a:t>
-            </a:r>
-            <a:r>
-              <a:rPr>
-                <a:solidFill>
-                  <a:srgbClr val="40A070"/>
-                </a:solidFill>
-                <a:latin typeface="Courier"/>
-              </a:rPr>
-              <a:t>3</a:t>
-            </a:r>
-            <a:r>
-              <a:rPr>
-                <a:latin typeface="Courier"/>
-              </a:rPr>
-              <a:t>, </a:t>
-            </a:r>
-            <a:r>
-              <a:rPr>
-                <a:solidFill>
-                  <a:srgbClr val="40A070"/>
-                </a:solidFill>
-                <a:latin typeface="Courier"/>
-              </a:rPr>
-              <a:t>4</a:t>
-            </a:r>
-            <a:r>
-              <a:rPr>
-                <a:latin typeface="Courier"/>
-              </a:rPr>
-              <a:t>)</a:t>
-            </a:r>
-            <a:br/>
-            <a:r>
-              <a:rPr>
-                <a:latin typeface="Courier"/>
-              </a:rPr>
-              <a:t>distance </a:t>
-            </a:r>
-            <a:r>
-              <a:rPr>
-                <a:solidFill>
-                  <a:srgbClr val="666666"/>
-                </a:solidFill>
-                <a:latin typeface="Courier"/>
-              </a:rPr>
-              <a:t>=</a:t>
-            </a:r>
-            <a:r>
-              <a:rPr>
-                <a:latin typeface="Courier"/>
-              </a:rPr>
-              <a:t> ((p1[</a:t>
-            </a:r>
-            <a:r>
-              <a:rPr>
-                <a:solidFill>
-                  <a:srgbClr val="40A070"/>
-                </a:solidFill>
-                <a:latin typeface="Courier"/>
-              </a:rPr>
-              <a:t>0</a:t>
-            </a:r>
-            <a:r>
-              <a:rPr>
-                <a:latin typeface="Courier"/>
-              </a:rPr>
-              <a:t>] </a:t>
-            </a:r>
-            <a:r>
-              <a:rPr>
-                <a:solidFill>
-                  <a:srgbClr val="666666"/>
-                </a:solidFill>
-                <a:latin typeface="Courier"/>
-              </a:rPr>
-              <a:t>-</a:t>
-            </a:r>
-            <a:r>
-              <a:rPr>
-                <a:latin typeface="Courier"/>
-              </a:rPr>
-              <a:t> p2[</a:t>
-            </a:r>
-            <a:r>
-              <a:rPr>
-                <a:solidFill>
-                  <a:srgbClr val="40A070"/>
-                </a:solidFill>
-                <a:latin typeface="Courier"/>
-              </a:rPr>
-              <a:t>0</a:t>
-            </a:r>
-            <a:r>
-              <a:rPr>
-                <a:latin typeface="Courier"/>
-              </a:rPr>
-              <a:t>]) </a:t>
-            </a:r>
-            <a:r>
-              <a:rPr>
-                <a:solidFill>
-                  <a:srgbClr val="666666"/>
-                </a:solidFill>
-                <a:latin typeface="Courier"/>
-              </a:rPr>
-              <a:t>**</a:t>
-            </a:r>
-            <a:r>
-              <a:rPr>
-                <a:latin typeface="Courier"/>
-              </a:rPr>
-              <a:t> </a:t>
-            </a:r>
-            <a:r>
-              <a:rPr>
-                <a:solidFill>
-                  <a:srgbClr val="40A070"/>
-                </a:solidFill>
-                <a:latin typeface="Courier"/>
-              </a:rPr>
-              <a:t>2</a:t>
-            </a:r>
-            <a:r>
-              <a:rPr>
-                <a:latin typeface="Courier"/>
-              </a:rPr>
-              <a:t> </a:t>
-            </a:r>
-            <a:r>
-              <a:rPr>
-                <a:solidFill>
-                  <a:srgbClr val="666666"/>
-                </a:solidFill>
-                <a:latin typeface="Courier"/>
-              </a:rPr>
-              <a:t>+</a:t>
-            </a:r>
-            <a:r>
-              <a:rPr>
-                <a:latin typeface="Courier"/>
-              </a:rPr>
-              <a:t> (p1[</a:t>
-            </a:r>
-            <a:r>
-              <a:rPr>
-                <a:solidFill>
-                  <a:srgbClr val="40A070"/>
-                </a:solidFill>
-                <a:latin typeface="Courier"/>
-              </a:rPr>
-              <a:t>1</a:t>
-            </a:r>
-            <a:r>
-              <a:rPr>
-                <a:latin typeface="Courier"/>
-              </a:rPr>
-              <a:t>] </a:t>
-            </a:r>
-            <a:r>
-              <a:rPr>
-                <a:solidFill>
-                  <a:srgbClr val="666666"/>
-                </a:solidFill>
-                <a:latin typeface="Courier"/>
-              </a:rPr>
-              <a:t>-</a:t>
-            </a:r>
-            <a:r>
-              <a:rPr>
-                <a:latin typeface="Courier"/>
-              </a:rPr>
-              <a:t> p2[</a:t>
-            </a:r>
-            <a:r>
-              <a:rPr>
-                <a:solidFill>
-                  <a:srgbClr val="40A070"/>
-                </a:solidFill>
-                <a:latin typeface="Courier"/>
-              </a:rPr>
-              <a:t>1</a:t>
-            </a:r>
-            <a:r>
-              <a:rPr>
-                <a:latin typeface="Courier"/>
-              </a:rPr>
-              <a:t>]) </a:t>
-            </a:r>
-            <a:r>
-              <a:rPr>
-                <a:solidFill>
-                  <a:srgbClr val="666666"/>
-                </a:solidFill>
-                <a:latin typeface="Courier"/>
-              </a:rPr>
-              <a:t>**</a:t>
-            </a:r>
-            <a:r>
-              <a:rPr>
-                <a:latin typeface="Courier"/>
-              </a:rPr>
-              <a:t> </a:t>
-            </a:r>
-            <a:r>
-              <a:rPr>
-                <a:solidFill>
-                  <a:srgbClr val="40A070"/>
-                </a:solidFill>
-                <a:latin typeface="Courier"/>
-              </a:rPr>
-              <a:t>2</a:t>
-            </a:r>
-            <a:r>
-              <a:rPr>
-                <a:latin typeface="Courier"/>
-              </a:rPr>
-              <a:t>) </a:t>
-            </a:r>
-            <a:r>
-              <a:rPr>
-                <a:solidFill>
-                  <a:srgbClr val="666666"/>
-                </a:solidFill>
-                <a:latin typeface="Courier"/>
-              </a:rPr>
-              <a:t>**</a:t>
-            </a:r>
-            <a:r>
-              <a:rPr>
-                <a:latin typeface="Courier"/>
-              </a:rPr>
-              <a:t> </a:t>
-            </a:r>
-            <a:r>
-              <a:rPr>
-                <a:solidFill>
-                  <a:srgbClr val="40A070"/>
-                </a:solidFill>
-                <a:latin typeface="Courier"/>
-              </a:rPr>
-              <a:t>0.5</a:t>
+              <a:t>Outline</a:t>
             </a:r>
           </a:p>
         </p:txBody>
@@ -4209,476 +4808,7 @@
             </a:pPr>
             <a:r>
               <a:rPr/>
-              <a:t>A class is a blueprint</a:t>
-            </a:r>
-          </a:p>
-        </p:txBody>
-      </p:sp>
-      <p:sp>
-        <p:nvSpPr>
-          <p:cNvPr id="3" name="Content Placeholder 2"/>
-          <p:cNvSpPr>
-            <a:spLocks noGrp="1"/>
-          </p:cNvSpPr>
-          <p:nvPr>
-            <p:ph idx="1"/>
-          </p:nvPr>
-        </p:nvSpPr>
-        <p:spPr/>
-        <p:txBody>
-          <a:bodyPr/>
-          <a:lstStyle/>
-          <a:p>
-            <a:pPr lvl="0" indent="0">
-              <a:buNone/>
-            </a:pPr>
-            <a:r>
-              <a:rPr b="1">
-                <a:solidFill>
-                  <a:srgbClr val="007020"/>
-                </a:solidFill>
-                <a:latin typeface="Courier"/>
-              </a:rPr>
-              <a:t>class</a:t>
-            </a:r>
-            <a:r>
-              <a:rPr>
-                <a:latin typeface="Courier"/>
-              </a:rPr>
-              <a:t> Point:</a:t>
-            </a:r>
-            <a:br/>
-            <a:r>
-              <a:rPr>
-                <a:latin typeface="Courier"/>
-              </a:rPr>
-              <a:t>    </a:t>
-            </a:r>
-            <a:r>
-              <a:rPr i="1">
-                <a:solidFill>
-                  <a:srgbClr val="60A0B0"/>
-                </a:solidFill>
-                <a:latin typeface="Courier"/>
-              </a:rPr>
-              <a:t>"""A point in the 2D plane."""</a:t>
-            </a:r>
-            <a:br/>
-            <a:br/>
-            <a:r>
-              <a:rPr>
-                <a:latin typeface="Courier"/>
-              </a:rPr>
-              <a:t>    </a:t>
-            </a:r>
-            <a:r>
-              <a:rPr b="1">
-                <a:solidFill>
-                  <a:srgbClr val="007020"/>
-                </a:solidFill>
-                <a:latin typeface="Courier"/>
-              </a:rPr>
-              <a:t>def</a:t>
-            </a:r>
-            <a:r>
-              <a:rPr>
-                <a:latin typeface="Courier"/>
-              </a:rPr>
-              <a:t> </a:t>
-            </a:r>
-            <a:r>
-              <a:rPr>
-                <a:solidFill>
-                  <a:srgbClr val="06287E"/>
-                </a:solidFill>
-                <a:latin typeface="Courier"/>
-              </a:rPr>
-              <a:t>__init__</a:t>
-            </a:r>
-            <a:r>
-              <a:rPr>
-                <a:latin typeface="Courier"/>
-              </a:rPr>
-              <a:t>(</a:t>
-            </a:r>
-            <a:r>
-              <a:rPr>
-                <a:solidFill>
-                  <a:srgbClr val="19177C"/>
-                </a:solidFill>
-                <a:latin typeface="Courier"/>
-              </a:rPr>
-              <a:t>self</a:t>
-            </a:r>
-            <a:r>
-              <a:rPr>
-                <a:latin typeface="Courier"/>
-              </a:rPr>
-              <a:t>, x, y):      </a:t>
-            </a:r>
-            <a:r>
-              <a:rPr i="1">
-                <a:solidFill>
-                  <a:srgbClr val="60A0B0"/>
-                </a:solidFill>
-                <a:latin typeface="Courier"/>
-              </a:rPr>
-              <a:t># runs once, when a Point is created</a:t>
-            </a:r>
-            <a:br/>
-            <a:r>
-              <a:rPr>
-                <a:latin typeface="Courier"/>
-              </a:rPr>
-              <a:t>        </a:t>
-            </a:r>
-            <a:r>
-              <a:rPr>
-                <a:solidFill>
-                  <a:srgbClr val="19177C"/>
-                </a:solidFill>
-                <a:latin typeface="Courier"/>
-              </a:rPr>
-              <a:t>self</a:t>
-            </a:r>
-            <a:r>
-              <a:rPr>
-                <a:latin typeface="Courier"/>
-              </a:rPr>
-              <a:t>.x </a:t>
-            </a:r>
-            <a:r>
-              <a:rPr>
-                <a:solidFill>
-                  <a:srgbClr val="666666"/>
-                </a:solidFill>
-                <a:latin typeface="Courier"/>
-              </a:rPr>
-              <a:t>=</a:t>
-            </a:r>
-            <a:r>
-              <a:rPr>
-                <a:latin typeface="Courier"/>
-              </a:rPr>
-              <a:t> x                  </a:t>
-            </a:r>
-            <a:r>
-              <a:rPr i="1">
-                <a:solidFill>
-                  <a:srgbClr val="60A0B0"/>
-                </a:solidFill>
-                <a:latin typeface="Courier"/>
-              </a:rPr>
-              <a:t># self.x is THIS point's x, not some</a:t>
-            </a:r>
-            <a:br/>
-            <a:r>
-              <a:rPr>
-                <a:latin typeface="Courier"/>
-              </a:rPr>
-              <a:t>        </a:t>
-            </a:r>
-            <a:r>
-              <a:rPr>
-                <a:solidFill>
-                  <a:srgbClr val="19177C"/>
-                </a:solidFill>
-                <a:latin typeface="Courier"/>
-              </a:rPr>
-              <a:t>self</a:t>
-            </a:r>
-            <a:r>
-              <a:rPr>
-                <a:latin typeface="Courier"/>
-              </a:rPr>
-              <a:t>.y </a:t>
-            </a:r>
-            <a:r>
-              <a:rPr>
-                <a:solidFill>
-                  <a:srgbClr val="666666"/>
-                </a:solidFill>
-                <a:latin typeface="Courier"/>
-              </a:rPr>
-              <a:t>=</a:t>
-            </a:r>
-            <a:r>
-              <a:rPr>
-                <a:latin typeface="Courier"/>
-              </a:rPr>
-              <a:t> y                  </a:t>
-            </a:r>
-            <a:r>
-              <a:rPr i="1">
-                <a:solidFill>
-                  <a:srgbClr val="60A0B0"/>
-                </a:solidFill>
-                <a:latin typeface="Courier"/>
-              </a:rPr>
-              <a:t># global variable named x</a:t>
-            </a:r>
-            <a:br/>
-            <a:br/>
-            <a:r>
-              <a:rPr>
-                <a:latin typeface="Courier"/>
-              </a:rPr>
-              <a:t>    </a:t>
-            </a:r>
-            <a:r>
-              <a:rPr b="1">
-                <a:solidFill>
-                  <a:srgbClr val="007020"/>
-                </a:solidFill>
-                <a:latin typeface="Courier"/>
-              </a:rPr>
-              <a:t>def</a:t>
-            </a:r>
-            <a:r>
-              <a:rPr>
-                <a:latin typeface="Courier"/>
-              </a:rPr>
-              <a:t> distance_to(</a:t>
-            </a:r>
-            <a:r>
-              <a:rPr>
-                <a:solidFill>
-                  <a:srgbClr val="19177C"/>
-                </a:solidFill>
-                <a:latin typeface="Courier"/>
-              </a:rPr>
-              <a:t>self</a:t>
-            </a:r>
-            <a:r>
-              <a:rPr>
-                <a:latin typeface="Courier"/>
-              </a:rPr>
-              <a:t>, other):</a:t>
-            </a:r>
-            <a:br/>
-            <a:r>
-              <a:rPr>
-                <a:latin typeface="Courier"/>
-              </a:rPr>
-              <a:t>        dx </a:t>
-            </a:r>
-            <a:r>
-              <a:rPr>
-                <a:solidFill>
-                  <a:srgbClr val="666666"/>
-                </a:solidFill>
-                <a:latin typeface="Courier"/>
-              </a:rPr>
-              <a:t>=</a:t>
-            </a:r>
-            <a:r>
-              <a:rPr>
-                <a:latin typeface="Courier"/>
-              </a:rPr>
-              <a:t> </a:t>
-            </a:r>
-            <a:r>
-              <a:rPr>
-                <a:solidFill>
-                  <a:srgbClr val="19177C"/>
-                </a:solidFill>
-                <a:latin typeface="Courier"/>
-              </a:rPr>
-              <a:t>self</a:t>
-            </a:r>
-            <a:r>
-              <a:rPr>
-                <a:latin typeface="Courier"/>
-              </a:rPr>
-              <a:t>.x </a:t>
-            </a:r>
-            <a:r>
-              <a:rPr>
-                <a:solidFill>
-                  <a:srgbClr val="666666"/>
-                </a:solidFill>
-                <a:latin typeface="Courier"/>
-              </a:rPr>
-              <a:t>-</a:t>
-            </a:r>
-            <a:r>
-              <a:rPr>
-                <a:latin typeface="Courier"/>
-              </a:rPr>
-              <a:t> other.x</a:t>
-            </a:r>
-            <a:br/>
-            <a:r>
-              <a:rPr>
-                <a:latin typeface="Courier"/>
-              </a:rPr>
-              <a:t>        dy </a:t>
-            </a:r>
-            <a:r>
-              <a:rPr>
-                <a:solidFill>
-                  <a:srgbClr val="666666"/>
-                </a:solidFill>
-                <a:latin typeface="Courier"/>
-              </a:rPr>
-              <a:t>=</a:t>
-            </a:r>
-            <a:r>
-              <a:rPr>
-                <a:latin typeface="Courier"/>
-              </a:rPr>
-              <a:t> </a:t>
-            </a:r>
-            <a:r>
-              <a:rPr>
-                <a:solidFill>
-                  <a:srgbClr val="19177C"/>
-                </a:solidFill>
-                <a:latin typeface="Courier"/>
-              </a:rPr>
-              <a:t>self</a:t>
-            </a:r>
-            <a:r>
-              <a:rPr>
-                <a:latin typeface="Courier"/>
-              </a:rPr>
-              <a:t>.y </a:t>
-            </a:r>
-            <a:r>
-              <a:rPr>
-                <a:solidFill>
-                  <a:srgbClr val="666666"/>
-                </a:solidFill>
-                <a:latin typeface="Courier"/>
-              </a:rPr>
-              <a:t>-</a:t>
-            </a:r>
-            <a:r>
-              <a:rPr>
-                <a:latin typeface="Courier"/>
-              </a:rPr>
-              <a:t> other.y</a:t>
-            </a:r>
-            <a:br/>
-            <a:r>
-              <a:rPr>
-                <a:latin typeface="Courier"/>
-              </a:rPr>
-              <a:t>        </a:t>
-            </a:r>
-            <a:r>
-              <a:rPr b="1">
-                <a:solidFill>
-                  <a:srgbClr val="007020"/>
-                </a:solidFill>
-                <a:latin typeface="Courier"/>
-              </a:rPr>
-              <a:t>return</a:t>
-            </a:r>
-            <a:r>
-              <a:rPr>
-                <a:latin typeface="Courier"/>
-              </a:rPr>
-              <a:t> (dx </a:t>
-            </a:r>
-            <a:r>
-              <a:rPr>
-                <a:solidFill>
-                  <a:srgbClr val="666666"/>
-                </a:solidFill>
-                <a:latin typeface="Courier"/>
-              </a:rPr>
-              <a:t>**</a:t>
-            </a:r>
-            <a:r>
-              <a:rPr>
-                <a:latin typeface="Courier"/>
-              </a:rPr>
-              <a:t> </a:t>
-            </a:r>
-            <a:r>
-              <a:rPr>
-                <a:solidFill>
-                  <a:srgbClr val="40A070"/>
-                </a:solidFill>
-                <a:latin typeface="Courier"/>
-              </a:rPr>
-              <a:t>2</a:t>
-            </a:r>
-            <a:r>
-              <a:rPr>
-                <a:latin typeface="Courier"/>
-              </a:rPr>
-              <a:t> </a:t>
-            </a:r>
-            <a:r>
-              <a:rPr>
-                <a:solidFill>
-                  <a:srgbClr val="666666"/>
-                </a:solidFill>
-                <a:latin typeface="Courier"/>
-              </a:rPr>
-              <a:t>+</a:t>
-            </a:r>
-            <a:r>
-              <a:rPr>
-                <a:latin typeface="Courier"/>
-              </a:rPr>
-              <a:t> dy </a:t>
-            </a:r>
-            <a:r>
-              <a:rPr>
-                <a:solidFill>
-                  <a:srgbClr val="666666"/>
-                </a:solidFill>
-                <a:latin typeface="Courier"/>
-              </a:rPr>
-              <a:t>**</a:t>
-            </a:r>
-            <a:r>
-              <a:rPr>
-                <a:latin typeface="Courier"/>
-              </a:rPr>
-              <a:t> </a:t>
-            </a:r>
-            <a:r>
-              <a:rPr>
-                <a:solidFill>
-                  <a:srgbClr val="40A070"/>
-                </a:solidFill>
-                <a:latin typeface="Courier"/>
-              </a:rPr>
-              <a:t>2</a:t>
-            </a:r>
-            <a:r>
-              <a:rPr>
-                <a:latin typeface="Courier"/>
-              </a:rPr>
-              <a:t>) </a:t>
-            </a:r>
-            <a:r>
-              <a:rPr>
-                <a:solidFill>
-                  <a:srgbClr val="666666"/>
-                </a:solidFill>
-                <a:latin typeface="Courier"/>
-              </a:rPr>
-              <a:t>**</a:t>
-            </a:r>
-            <a:r>
-              <a:rPr>
-                <a:latin typeface="Courier"/>
-              </a:rPr>
-              <a:t> </a:t>
-            </a:r>
-            <a:r>
-              <a:rPr>
-                <a:solidFill>
-                  <a:srgbClr val="40A070"/>
-                </a:solidFill>
-                <a:latin typeface="Courier"/>
-              </a:rPr>
-              <a:t>0.5</a:t>
+              <a:t>Why we start here, not with data structures</a:t>
             </a:r>
           </a:p>
         </p:txBody>
@@ -4689,6 +4819,904 @@
 </file>
 
 <file path=ppt/slides/slide5.xml><?xml version="1.0" encoding="utf-8"?>
+<p:sld xmlns:a="http://schemas.openxmlformats.org/drawingml/2006/main" xmlns:r="http://schemas.openxmlformats.org/officeDocument/2006/relationships" xmlns:p="http://schemas.openxmlformats.org/presentationml/2006/main">
+  <p:cSld>
+    <p:spTree>
+      <p:nvGrpSpPr>
+        <p:cNvPr id="1" name=""/>
+        <p:cNvGrpSpPr/>
+        <p:nvPr/>
+      </p:nvGrpSpPr>
+      <p:grpSpPr>
+        <a:xfrm>
+          <a:off x="0" y="0"/>
+          <a:ext cx="0" cy="0"/>
+          <a:chOff x="0" y="0"/>
+          <a:chExt cx="0" cy="0"/>
+        </a:xfrm>
+      </p:grpSpPr>
+      <p:sp>
+        <p:nvSpPr>
+          <p:cNvPr id="2" name="Title 1"/>
+          <p:cNvSpPr>
+            <a:spLocks noGrp="1"/>
+          </p:cNvSpPr>
+          <p:nvPr>
+            <p:ph type="title"/>
+          </p:nvPr>
+        </p:nvSpPr>
+        <p:spPr/>
+        <p:txBody>
+          <a:bodyPr/>
+          <a:lstStyle/>
+          <a:p>
+            <a:pPr lvl="0" indent="0" marL="0">
+              <a:buNone/>
+            </a:pPr>
+            <a:r>
+              <a:rPr/>
+              <a:t>The problem, before the solution</a:t>
+            </a:r>
+          </a:p>
+        </p:txBody>
+      </p:sp>
+      <p:sp>
+        <p:nvSpPr>
+          <p:cNvPr id="3" name="Content Placeholder 2"/>
+          <p:cNvSpPr>
+            <a:spLocks noGrp="1"/>
+          </p:cNvSpPr>
+          <p:nvPr>
+            <p:ph idx="1"/>
+          </p:nvPr>
+        </p:nvSpPr>
+        <p:spPr/>
+        <p:txBody>
+          <a:bodyPr/>
+          <a:lstStyle/>
+          <a:p>
+            <a:pPr lvl="0" indent="0">
+              <a:buNone/>
+            </a:pPr>
+            <a:r>
+              <a:rPr>
+                <a:latin typeface="Courier"/>
+              </a:rPr>
+              <a:t>p1 </a:t>
+            </a:r>
+            <a:r>
+              <a:rPr>
+                <a:solidFill>
+                  <a:srgbClr val="666666"/>
+                </a:solidFill>
+                <a:latin typeface="Courier"/>
+              </a:rPr>
+              <a:t>=</a:t>
+            </a:r>
+            <a:r>
+              <a:rPr>
+                <a:latin typeface="Courier"/>
+              </a:rPr>
+              <a:t> (</a:t>
+            </a:r>
+            <a:r>
+              <a:rPr>
+                <a:solidFill>
+                  <a:srgbClr val="40A070"/>
+                </a:solidFill>
+                <a:latin typeface="Courier"/>
+              </a:rPr>
+              <a:t>0</a:t>
+            </a:r>
+            <a:r>
+              <a:rPr>
+                <a:latin typeface="Courier"/>
+              </a:rPr>
+              <a:t>, </a:t>
+            </a:r>
+            <a:r>
+              <a:rPr>
+                <a:solidFill>
+                  <a:srgbClr val="40A070"/>
+                </a:solidFill>
+                <a:latin typeface="Courier"/>
+              </a:rPr>
+              <a:t>0</a:t>
+            </a:r>
+            <a:r>
+              <a:rPr>
+                <a:latin typeface="Courier"/>
+              </a:rPr>
+              <a:t>)</a:t>
+            </a:r>
+            <a:br/>
+            <a:r>
+              <a:rPr>
+                <a:latin typeface="Courier"/>
+              </a:rPr>
+              <a:t>p2 </a:t>
+            </a:r>
+            <a:r>
+              <a:rPr>
+                <a:solidFill>
+                  <a:srgbClr val="666666"/>
+                </a:solidFill>
+                <a:latin typeface="Courier"/>
+              </a:rPr>
+              <a:t>=</a:t>
+            </a:r>
+            <a:r>
+              <a:rPr>
+                <a:latin typeface="Courier"/>
+              </a:rPr>
+              <a:t> (</a:t>
+            </a:r>
+            <a:r>
+              <a:rPr>
+                <a:solidFill>
+                  <a:srgbClr val="40A070"/>
+                </a:solidFill>
+                <a:latin typeface="Courier"/>
+              </a:rPr>
+              <a:t>3</a:t>
+            </a:r>
+            <a:r>
+              <a:rPr>
+                <a:latin typeface="Courier"/>
+              </a:rPr>
+              <a:t>, </a:t>
+            </a:r>
+            <a:r>
+              <a:rPr>
+                <a:solidFill>
+                  <a:srgbClr val="40A070"/>
+                </a:solidFill>
+                <a:latin typeface="Courier"/>
+              </a:rPr>
+              <a:t>4</a:t>
+            </a:r>
+            <a:r>
+              <a:rPr>
+                <a:latin typeface="Courier"/>
+              </a:rPr>
+              <a:t>)</a:t>
+            </a:r>
+            <a:br/>
+            <a:r>
+              <a:rPr>
+                <a:latin typeface="Courier"/>
+              </a:rPr>
+              <a:t>distance </a:t>
+            </a:r>
+            <a:r>
+              <a:rPr>
+                <a:solidFill>
+                  <a:srgbClr val="666666"/>
+                </a:solidFill>
+                <a:latin typeface="Courier"/>
+              </a:rPr>
+              <a:t>=</a:t>
+            </a:r>
+            <a:r>
+              <a:rPr>
+                <a:latin typeface="Courier"/>
+              </a:rPr>
+              <a:t> ((p1[</a:t>
+            </a:r>
+            <a:r>
+              <a:rPr>
+                <a:solidFill>
+                  <a:srgbClr val="40A070"/>
+                </a:solidFill>
+                <a:latin typeface="Courier"/>
+              </a:rPr>
+              <a:t>0</a:t>
+            </a:r>
+            <a:r>
+              <a:rPr>
+                <a:latin typeface="Courier"/>
+              </a:rPr>
+              <a:t>] </a:t>
+            </a:r>
+            <a:r>
+              <a:rPr>
+                <a:solidFill>
+                  <a:srgbClr val="666666"/>
+                </a:solidFill>
+                <a:latin typeface="Courier"/>
+              </a:rPr>
+              <a:t>-</a:t>
+            </a:r>
+            <a:r>
+              <a:rPr>
+                <a:latin typeface="Courier"/>
+              </a:rPr>
+              <a:t> p2[</a:t>
+            </a:r>
+            <a:r>
+              <a:rPr>
+                <a:solidFill>
+                  <a:srgbClr val="40A070"/>
+                </a:solidFill>
+                <a:latin typeface="Courier"/>
+              </a:rPr>
+              <a:t>0</a:t>
+            </a:r>
+            <a:r>
+              <a:rPr>
+                <a:latin typeface="Courier"/>
+              </a:rPr>
+              <a:t>]) </a:t>
+            </a:r>
+            <a:r>
+              <a:rPr>
+                <a:solidFill>
+                  <a:srgbClr val="666666"/>
+                </a:solidFill>
+                <a:latin typeface="Courier"/>
+              </a:rPr>
+              <a:t>**</a:t>
+            </a:r>
+            <a:r>
+              <a:rPr>
+                <a:latin typeface="Courier"/>
+              </a:rPr>
+              <a:t> </a:t>
+            </a:r>
+            <a:r>
+              <a:rPr>
+                <a:solidFill>
+                  <a:srgbClr val="40A070"/>
+                </a:solidFill>
+                <a:latin typeface="Courier"/>
+              </a:rPr>
+              <a:t>2</a:t>
+            </a:r>
+            <a:r>
+              <a:rPr>
+                <a:latin typeface="Courier"/>
+              </a:rPr>
+              <a:t> </a:t>
+            </a:r>
+            <a:r>
+              <a:rPr>
+                <a:solidFill>
+                  <a:srgbClr val="666666"/>
+                </a:solidFill>
+                <a:latin typeface="Courier"/>
+              </a:rPr>
+              <a:t>+</a:t>
+            </a:r>
+            <a:r>
+              <a:rPr>
+                <a:latin typeface="Courier"/>
+              </a:rPr>
+              <a:t> (p1[</a:t>
+            </a:r>
+            <a:r>
+              <a:rPr>
+                <a:solidFill>
+                  <a:srgbClr val="40A070"/>
+                </a:solidFill>
+                <a:latin typeface="Courier"/>
+              </a:rPr>
+              <a:t>1</a:t>
+            </a:r>
+            <a:r>
+              <a:rPr>
+                <a:latin typeface="Courier"/>
+              </a:rPr>
+              <a:t>] </a:t>
+            </a:r>
+            <a:r>
+              <a:rPr>
+                <a:solidFill>
+                  <a:srgbClr val="666666"/>
+                </a:solidFill>
+                <a:latin typeface="Courier"/>
+              </a:rPr>
+              <a:t>-</a:t>
+            </a:r>
+            <a:r>
+              <a:rPr>
+                <a:latin typeface="Courier"/>
+              </a:rPr>
+              <a:t> p2[</a:t>
+            </a:r>
+            <a:r>
+              <a:rPr>
+                <a:solidFill>
+                  <a:srgbClr val="40A070"/>
+                </a:solidFill>
+                <a:latin typeface="Courier"/>
+              </a:rPr>
+              <a:t>1</a:t>
+            </a:r>
+            <a:r>
+              <a:rPr>
+                <a:latin typeface="Courier"/>
+              </a:rPr>
+              <a:t>]) </a:t>
+            </a:r>
+            <a:r>
+              <a:rPr>
+                <a:solidFill>
+                  <a:srgbClr val="666666"/>
+                </a:solidFill>
+                <a:latin typeface="Courier"/>
+              </a:rPr>
+              <a:t>**</a:t>
+            </a:r>
+            <a:r>
+              <a:rPr>
+                <a:latin typeface="Courier"/>
+              </a:rPr>
+              <a:t> </a:t>
+            </a:r>
+            <a:r>
+              <a:rPr>
+                <a:solidFill>
+                  <a:srgbClr val="40A070"/>
+                </a:solidFill>
+                <a:latin typeface="Courier"/>
+              </a:rPr>
+              <a:t>2</a:t>
+            </a:r>
+            <a:r>
+              <a:rPr>
+                <a:latin typeface="Courier"/>
+              </a:rPr>
+              <a:t>) </a:t>
+            </a:r>
+            <a:r>
+              <a:rPr>
+                <a:solidFill>
+                  <a:srgbClr val="666666"/>
+                </a:solidFill>
+                <a:latin typeface="Courier"/>
+              </a:rPr>
+              <a:t>**</a:t>
+            </a:r>
+            <a:r>
+              <a:rPr>
+                <a:latin typeface="Courier"/>
+              </a:rPr>
+              <a:t> </a:t>
+            </a:r>
+            <a:r>
+              <a:rPr>
+                <a:solidFill>
+                  <a:srgbClr val="40A070"/>
+                </a:solidFill>
+                <a:latin typeface="Courier"/>
+              </a:rPr>
+              <a:t>0.5</a:t>
+            </a:r>
+          </a:p>
+        </p:txBody>
+      </p:sp>
+    </p:spTree>
+  </p:cSld>
+</p:sld>
+</file>
+
+<file path=ppt/slides/slide6.xml><?xml version="1.0" encoding="utf-8"?>
+<p:sld xmlns:a="http://schemas.openxmlformats.org/drawingml/2006/main" xmlns:r="http://schemas.openxmlformats.org/officeDocument/2006/relationships" xmlns:p="http://schemas.openxmlformats.org/presentationml/2006/main">
+  <p:cSld>
+    <p:spTree>
+      <p:nvGrpSpPr>
+        <p:cNvPr id="1" name=""/>
+        <p:cNvGrpSpPr/>
+        <p:nvPr/>
+      </p:nvGrpSpPr>
+      <p:grpSpPr>
+        <a:xfrm>
+          <a:off x="0" y="0"/>
+          <a:ext cx="0" cy="0"/>
+          <a:chOff x="0" y="0"/>
+          <a:chExt cx="0" cy="0"/>
+        </a:xfrm>
+      </p:grpSpPr>
+      <p:sp>
+        <p:nvSpPr>
+          <p:cNvPr id="2" name="Title 1"/>
+          <p:cNvSpPr>
+            <a:spLocks noGrp="1"/>
+          </p:cNvSpPr>
+          <p:nvPr>
+            <p:ph type="title"/>
+          </p:nvPr>
+        </p:nvSpPr>
+        <p:spPr/>
+        <p:txBody>
+          <a:bodyPr/>
+          <a:lstStyle/>
+          <a:p>
+            <a:pPr lvl="0" indent="0" marL="0">
+              <a:buNone/>
+            </a:pPr>
+            <a:r>
+              <a:rPr/>
+              <a:t>A class is a blueprint</a:t>
+            </a:r>
+          </a:p>
+        </p:txBody>
+      </p:sp>
+      <p:sp>
+        <p:nvSpPr>
+          <p:cNvPr id="3" name="Content Placeholder 2"/>
+          <p:cNvSpPr>
+            <a:spLocks noGrp="1"/>
+          </p:cNvSpPr>
+          <p:nvPr>
+            <p:ph idx="1"/>
+          </p:nvPr>
+        </p:nvSpPr>
+        <p:spPr/>
+        <p:txBody>
+          <a:bodyPr/>
+          <a:lstStyle/>
+          <a:p>
+            <a:pPr lvl="0" indent="0">
+              <a:buNone/>
+            </a:pPr>
+            <a:r>
+              <a:rPr b="1">
+                <a:solidFill>
+                  <a:srgbClr val="007020"/>
+                </a:solidFill>
+                <a:latin typeface="Courier"/>
+              </a:rPr>
+              <a:t>class</a:t>
+            </a:r>
+            <a:r>
+              <a:rPr>
+                <a:latin typeface="Courier"/>
+              </a:rPr>
+              <a:t> Point:</a:t>
+            </a:r>
+            <a:br/>
+            <a:r>
+              <a:rPr>
+                <a:latin typeface="Courier"/>
+              </a:rPr>
+              <a:t>    </a:t>
+            </a:r>
+            <a:r>
+              <a:rPr i="1">
+                <a:solidFill>
+                  <a:srgbClr val="60A0B0"/>
+                </a:solidFill>
+                <a:latin typeface="Courier"/>
+              </a:rPr>
+              <a:t>"""A point in the 2D plane."""</a:t>
+            </a:r>
+            <a:br/>
+            <a:br/>
+            <a:r>
+              <a:rPr>
+                <a:latin typeface="Courier"/>
+              </a:rPr>
+              <a:t>    </a:t>
+            </a:r>
+            <a:r>
+              <a:rPr b="1">
+                <a:solidFill>
+                  <a:srgbClr val="007020"/>
+                </a:solidFill>
+                <a:latin typeface="Courier"/>
+              </a:rPr>
+              <a:t>def</a:t>
+            </a:r>
+            <a:r>
+              <a:rPr>
+                <a:latin typeface="Courier"/>
+              </a:rPr>
+              <a:t> </a:t>
+            </a:r>
+            <a:r>
+              <a:rPr>
+                <a:solidFill>
+                  <a:srgbClr val="06287E"/>
+                </a:solidFill>
+                <a:latin typeface="Courier"/>
+              </a:rPr>
+              <a:t>__init__</a:t>
+            </a:r>
+            <a:r>
+              <a:rPr>
+                <a:latin typeface="Courier"/>
+              </a:rPr>
+              <a:t>(</a:t>
+            </a:r>
+            <a:r>
+              <a:rPr>
+                <a:solidFill>
+                  <a:srgbClr val="19177C"/>
+                </a:solidFill>
+                <a:latin typeface="Courier"/>
+              </a:rPr>
+              <a:t>self</a:t>
+            </a:r>
+            <a:r>
+              <a:rPr>
+                <a:latin typeface="Courier"/>
+              </a:rPr>
+              <a:t>, x, y):      </a:t>
+            </a:r>
+            <a:r>
+              <a:rPr i="1">
+                <a:solidFill>
+                  <a:srgbClr val="60A0B0"/>
+                </a:solidFill>
+                <a:latin typeface="Courier"/>
+              </a:rPr>
+              <a:t># runs once, when a Point is created</a:t>
+            </a:r>
+            <a:br/>
+            <a:r>
+              <a:rPr>
+                <a:latin typeface="Courier"/>
+              </a:rPr>
+              <a:t>        </a:t>
+            </a:r>
+            <a:r>
+              <a:rPr>
+                <a:solidFill>
+                  <a:srgbClr val="19177C"/>
+                </a:solidFill>
+                <a:latin typeface="Courier"/>
+              </a:rPr>
+              <a:t>self</a:t>
+            </a:r>
+            <a:r>
+              <a:rPr>
+                <a:latin typeface="Courier"/>
+              </a:rPr>
+              <a:t>.x </a:t>
+            </a:r>
+            <a:r>
+              <a:rPr>
+                <a:solidFill>
+                  <a:srgbClr val="666666"/>
+                </a:solidFill>
+                <a:latin typeface="Courier"/>
+              </a:rPr>
+              <a:t>=</a:t>
+            </a:r>
+            <a:r>
+              <a:rPr>
+                <a:latin typeface="Courier"/>
+              </a:rPr>
+              <a:t> x                  </a:t>
+            </a:r>
+            <a:r>
+              <a:rPr i="1">
+                <a:solidFill>
+                  <a:srgbClr val="60A0B0"/>
+                </a:solidFill>
+                <a:latin typeface="Courier"/>
+              </a:rPr>
+              <a:t># self.x is THIS point's x, not some</a:t>
+            </a:r>
+            <a:br/>
+            <a:r>
+              <a:rPr>
+                <a:latin typeface="Courier"/>
+              </a:rPr>
+              <a:t>        </a:t>
+            </a:r>
+            <a:r>
+              <a:rPr>
+                <a:solidFill>
+                  <a:srgbClr val="19177C"/>
+                </a:solidFill>
+                <a:latin typeface="Courier"/>
+              </a:rPr>
+              <a:t>self</a:t>
+            </a:r>
+            <a:r>
+              <a:rPr>
+                <a:latin typeface="Courier"/>
+              </a:rPr>
+              <a:t>.y </a:t>
+            </a:r>
+            <a:r>
+              <a:rPr>
+                <a:solidFill>
+                  <a:srgbClr val="666666"/>
+                </a:solidFill>
+                <a:latin typeface="Courier"/>
+              </a:rPr>
+              <a:t>=</a:t>
+            </a:r>
+            <a:r>
+              <a:rPr>
+                <a:latin typeface="Courier"/>
+              </a:rPr>
+              <a:t> y                  </a:t>
+            </a:r>
+            <a:r>
+              <a:rPr i="1">
+                <a:solidFill>
+                  <a:srgbClr val="60A0B0"/>
+                </a:solidFill>
+                <a:latin typeface="Courier"/>
+              </a:rPr>
+              <a:t># global variable named x</a:t>
+            </a:r>
+            <a:br/>
+            <a:br/>
+            <a:r>
+              <a:rPr>
+                <a:latin typeface="Courier"/>
+              </a:rPr>
+              <a:t>    </a:t>
+            </a:r>
+            <a:r>
+              <a:rPr b="1">
+                <a:solidFill>
+                  <a:srgbClr val="007020"/>
+                </a:solidFill>
+                <a:latin typeface="Courier"/>
+              </a:rPr>
+              <a:t>def</a:t>
+            </a:r>
+            <a:r>
+              <a:rPr>
+                <a:latin typeface="Courier"/>
+              </a:rPr>
+              <a:t> distance_to(</a:t>
+            </a:r>
+            <a:r>
+              <a:rPr>
+                <a:solidFill>
+                  <a:srgbClr val="19177C"/>
+                </a:solidFill>
+                <a:latin typeface="Courier"/>
+              </a:rPr>
+              <a:t>self</a:t>
+            </a:r>
+            <a:r>
+              <a:rPr>
+                <a:latin typeface="Courier"/>
+              </a:rPr>
+              <a:t>, other):</a:t>
+            </a:r>
+            <a:br/>
+            <a:r>
+              <a:rPr>
+                <a:latin typeface="Courier"/>
+              </a:rPr>
+              <a:t>        dx </a:t>
+            </a:r>
+            <a:r>
+              <a:rPr>
+                <a:solidFill>
+                  <a:srgbClr val="666666"/>
+                </a:solidFill>
+                <a:latin typeface="Courier"/>
+              </a:rPr>
+              <a:t>=</a:t>
+            </a:r>
+            <a:r>
+              <a:rPr>
+                <a:latin typeface="Courier"/>
+              </a:rPr>
+              <a:t> </a:t>
+            </a:r>
+            <a:r>
+              <a:rPr>
+                <a:solidFill>
+                  <a:srgbClr val="19177C"/>
+                </a:solidFill>
+                <a:latin typeface="Courier"/>
+              </a:rPr>
+              <a:t>self</a:t>
+            </a:r>
+            <a:r>
+              <a:rPr>
+                <a:latin typeface="Courier"/>
+              </a:rPr>
+              <a:t>.x </a:t>
+            </a:r>
+            <a:r>
+              <a:rPr>
+                <a:solidFill>
+                  <a:srgbClr val="666666"/>
+                </a:solidFill>
+                <a:latin typeface="Courier"/>
+              </a:rPr>
+              <a:t>-</a:t>
+            </a:r>
+            <a:r>
+              <a:rPr>
+                <a:latin typeface="Courier"/>
+              </a:rPr>
+              <a:t> other.x</a:t>
+            </a:r>
+            <a:br/>
+            <a:r>
+              <a:rPr>
+                <a:latin typeface="Courier"/>
+              </a:rPr>
+              <a:t>        dy </a:t>
+            </a:r>
+            <a:r>
+              <a:rPr>
+                <a:solidFill>
+                  <a:srgbClr val="666666"/>
+                </a:solidFill>
+                <a:latin typeface="Courier"/>
+              </a:rPr>
+              <a:t>=</a:t>
+            </a:r>
+            <a:r>
+              <a:rPr>
+                <a:latin typeface="Courier"/>
+              </a:rPr>
+              <a:t> </a:t>
+            </a:r>
+            <a:r>
+              <a:rPr>
+                <a:solidFill>
+                  <a:srgbClr val="19177C"/>
+                </a:solidFill>
+                <a:latin typeface="Courier"/>
+              </a:rPr>
+              <a:t>self</a:t>
+            </a:r>
+            <a:r>
+              <a:rPr>
+                <a:latin typeface="Courier"/>
+              </a:rPr>
+              <a:t>.y </a:t>
+            </a:r>
+            <a:r>
+              <a:rPr>
+                <a:solidFill>
+                  <a:srgbClr val="666666"/>
+                </a:solidFill>
+                <a:latin typeface="Courier"/>
+              </a:rPr>
+              <a:t>-</a:t>
+            </a:r>
+            <a:r>
+              <a:rPr>
+                <a:latin typeface="Courier"/>
+              </a:rPr>
+              <a:t> other.y</a:t>
+            </a:r>
+            <a:br/>
+            <a:r>
+              <a:rPr>
+                <a:latin typeface="Courier"/>
+              </a:rPr>
+              <a:t>        </a:t>
+            </a:r>
+            <a:r>
+              <a:rPr b="1">
+                <a:solidFill>
+                  <a:srgbClr val="007020"/>
+                </a:solidFill>
+                <a:latin typeface="Courier"/>
+              </a:rPr>
+              <a:t>return</a:t>
+            </a:r>
+            <a:r>
+              <a:rPr>
+                <a:latin typeface="Courier"/>
+              </a:rPr>
+              <a:t> (dx </a:t>
+            </a:r>
+            <a:r>
+              <a:rPr>
+                <a:solidFill>
+                  <a:srgbClr val="666666"/>
+                </a:solidFill>
+                <a:latin typeface="Courier"/>
+              </a:rPr>
+              <a:t>**</a:t>
+            </a:r>
+            <a:r>
+              <a:rPr>
+                <a:latin typeface="Courier"/>
+              </a:rPr>
+              <a:t> </a:t>
+            </a:r>
+            <a:r>
+              <a:rPr>
+                <a:solidFill>
+                  <a:srgbClr val="40A070"/>
+                </a:solidFill>
+                <a:latin typeface="Courier"/>
+              </a:rPr>
+              <a:t>2</a:t>
+            </a:r>
+            <a:r>
+              <a:rPr>
+                <a:latin typeface="Courier"/>
+              </a:rPr>
+              <a:t> </a:t>
+            </a:r>
+            <a:r>
+              <a:rPr>
+                <a:solidFill>
+                  <a:srgbClr val="666666"/>
+                </a:solidFill>
+                <a:latin typeface="Courier"/>
+              </a:rPr>
+              <a:t>+</a:t>
+            </a:r>
+            <a:r>
+              <a:rPr>
+                <a:latin typeface="Courier"/>
+              </a:rPr>
+              <a:t> dy </a:t>
+            </a:r>
+            <a:r>
+              <a:rPr>
+                <a:solidFill>
+                  <a:srgbClr val="666666"/>
+                </a:solidFill>
+                <a:latin typeface="Courier"/>
+              </a:rPr>
+              <a:t>**</a:t>
+            </a:r>
+            <a:r>
+              <a:rPr>
+                <a:latin typeface="Courier"/>
+              </a:rPr>
+              <a:t> </a:t>
+            </a:r>
+            <a:r>
+              <a:rPr>
+                <a:solidFill>
+                  <a:srgbClr val="40A070"/>
+                </a:solidFill>
+                <a:latin typeface="Courier"/>
+              </a:rPr>
+              <a:t>2</a:t>
+            </a:r>
+            <a:r>
+              <a:rPr>
+                <a:latin typeface="Courier"/>
+              </a:rPr>
+              <a:t>) </a:t>
+            </a:r>
+            <a:r>
+              <a:rPr>
+                <a:solidFill>
+                  <a:srgbClr val="666666"/>
+                </a:solidFill>
+                <a:latin typeface="Courier"/>
+              </a:rPr>
+              <a:t>**</a:t>
+            </a:r>
+            <a:r>
+              <a:rPr>
+                <a:latin typeface="Courier"/>
+              </a:rPr>
+              <a:t> </a:t>
+            </a:r>
+            <a:r>
+              <a:rPr>
+                <a:solidFill>
+                  <a:srgbClr val="40A070"/>
+                </a:solidFill>
+                <a:latin typeface="Courier"/>
+              </a:rPr>
+              <a:t>0.5</a:t>
+            </a:r>
+          </a:p>
+        </p:txBody>
+      </p:sp>
+    </p:spTree>
+  </p:cSld>
+</p:sld>
+</file>
+
+<file path=ppt/slides/slide7.xml><?xml version="1.0" encoding="utf-8"?>
 <p:sld xmlns:a="http://schemas.openxmlformats.org/drawingml/2006/main" xmlns:r="http://schemas.openxmlformats.org/officeDocument/2006/relationships" xmlns:p="http://schemas.openxmlformats.org/presentationml/2006/main">
   <p:cSld>
     <p:spTree>
@@ -4765,7 +5793,7 @@
 </p:sld>
 </file>
 
-<file path=ppt/slides/slide6.xml><?xml version="1.0" encoding="utf-8"?>
+<file path=ppt/slides/slide8.xml><?xml version="1.0" encoding="utf-8"?>
 <p:sld xmlns:a="http://schemas.openxmlformats.org/drawingml/2006/main" xmlns:r="http://schemas.openxmlformats.org/officeDocument/2006/relationships" xmlns:p="http://schemas.openxmlformats.org/presentationml/2006/main">
   <p:cSld>
     <p:spTree>
@@ -4963,7 +5991,7 @@
 </p:sld>
 </file>
 
-<file path=ppt/slides/slide7.xml><?xml version="1.0" encoding="utf-8"?>
+<file path=ppt/slides/slide9.xml><?xml version="1.0" encoding="utf-8"?>
 <p:sld xmlns:a="http://schemas.openxmlformats.org/drawingml/2006/main" xmlns:r="http://schemas.openxmlformats.org/officeDocument/2006/relationships" xmlns:p="http://schemas.openxmlformats.org/presentationml/2006/main">
   <p:cSld>
     <p:spTree>
@@ -5186,537 +6214,6 @@
           </a:graphicData>
         </a:graphic>
       </p:graphicFrame>
-    </p:spTree>
-  </p:cSld>
-</p:sld>
-</file>
-
-<file path=ppt/slides/slide8.xml><?xml version="1.0" encoding="utf-8"?>
-<p:sld xmlns:a="http://schemas.openxmlformats.org/drawingml/2006/main" xmlns:r="http://schemas.openxmlformats.org/officeDocument/2006/relationships" xmlns:p="http://schemas.openxmlformats.org/presentationml/2006/main">
-  <p:cSld>
-    <p:spTree>
-      <p:nvGrpSpPr>
-        <p:cNvPr id="1" name=""/>
-        <p:cNvGrpSpPr/>
-        <p:nvPr/>
-      </p:nvGrpSpPr>
-      <p:grpSpPr>
-        <a:xfrm>
-          <a:off x="0" y="0"/>
-          <a:ext cx="0" cy="0"/>
-          <a:chOff x="0" y="0"/>
-          <a:chExt cx="0" cy="0"/>
-        </a:xfrm>
-      </p:grpSpPr>
-      <p:sp>
-        <p:nvSpPr>
-          <p:cNvPr id="2" name="Title 1"/>
-          <p:cNvSpPr>
-            <a:spLocks noGrp="1"/>
-          </p:cNvSpPr>
-          <p:nvPr>
-            <p:ph type="title"/>
-          </p:nvPr>
-        </p:nvSpPr>
-        <p:spPr/>
-        <p:txBody>
-          <a:bodyPr/>
-          <a:lstStyle/>
-          <a:p>
-            <a:pPr lvl="0" indent="0" marL="0">
-              <a:buNone/>
-            </a:pPr>
-            <a:r>
-              <a:rPr/>
-              <a:t>Common first mistake</a:t>
-            </a:r>
-          </a:p>
-        </p:txBody>
-      </p:sp>
-      <p:sp>
-        <p:nvSpPr>
-          <p:cNvPr id="3" name="Content Placeholder 2"/>
-          <p:cNvSpPr>
-            <a:spLocks noGrp="1"/>
-          </p:cNvSpPr>
-          <p:nvPr>
-            <p:ph idx="1"/>
-          </p:nvPr>
-        </p:nvSpPr>
-        <p:spPr/>
-        <p:txBody>
-          <a:bodyPr/>
-          <a:lstStyle/>
-          <a:p>
-            <a:pPr lvl="0" indent="0">
-              <a:buNone/>
-            </a:pPr>
-            <a:r>
-              <a:rPr b="1">
-                <a:solidFill>
-                  <a:srgbClr val="007020"/>
-                </a:solidFill>
-                <a:latin typeface="Courier"/>
-              </a:rPr>
-              <a:t>class</a:t>
-            </a:r>
-            <a:r>
-              <a:rPr>
-                <a:latin typeface="Courier"/>
-              </a:rPr>
-              <a:t> Point:</a:t>
-            </a:r>
-            <a:br/>
-            <a:r>
-              <a:rPr>
-                <a:latin typeface="Courier"/>
-              </a:rPr>
-              <a:t>    </a:t>
-            </a:r>
-            <a:r>
-              <a:rPr b="1">
-                <a:solidFill>
-                  <a:srgbClr val="007020"/>
-                </a:solidFill>
-                <a:latin typeface="Courier"/>
-              </a:rPr>
-              <a:t>def</a:t>
-            </a:r>
-            <a:r>
-              <a:rPr>
-                <a:latin typeface="Courier"/>
-              </a:rPr>
-              <a:t> </a:t>
-            </a:r>
-            <a:r>
-              <a:rPr>
-                <a:solidFill>
-                  <a:srgbClr val="06287E"/>
-                </a:solidFill>
-                <a:latin typeface="Courier"/>
-              </a:rPr>
-              <a:t>__init__</a:t>
-            </a:r>
-            <a:r>
-              <a:rPr>
-                <a:latin typeface="Courier"/>
-              </a:rPr>
-              <a:t>(</a:t>
-            </a:r>
-            <a:r>
-              <a:rPr>
-                <a:solidFill>
-                  <a:srgbClr val="19177C"/>
-                </a:solidFill>
-                <a:latin typeface="Courier"/>
-              </a:rPr>
-              <a:t>self</a:t>
-            </a:r>
-            <a:r>
-              <a:rPr>
-                <a:latin typeface="Courier"/>
-              </a:rPr>
-              <a:t>, x, y):</a:t>
-            </a:r>
-            <a:br/>
-            <a:r>
-              <a:rPr>
-                <a:latin typeface="Courier"/>
-              </a:rPr>
-              <a:t>        x </a:t>
-            </a:r>
-            <a:r>
-              <a:rPr>
-                <a:solidFill>
-                  <a:srgbClr val="666666"/>
-                </a:solidFill>
-                <a:latin typeface="Courier"/>
-              </a:rPr>
-              <a:t>=</a:t>
-            </a:r>
-            <a:r>
-              <a:rPr>
-                <a:latin typeface="Courier"/>
-              </a:rPr>
-              <a:t> x        </a:t>
-            </a:r>
-            <a:r>
-              <a:rPr i="1">
-                <a:solidFill>
-                  <a:srgbClr val="60A0B0"/>
-                </a:solidFill>
-                <a:latin typeface="Courier"/>
-              </a:rPr>
-              <a:t># </a:t>
-            </a:r>
-            <a:r>
-              <a:rPr b="1">
-                <a:solidFill>
-                  <a:srgbClr val="FF0000"/>
-                </a:solidFill>
-                <a:latin typeface="Courier"/>
-              </a:rPr>
-              <a:t>BUG</a:t>
-            </a:r>
-            <a:r>
-              <a:rPr i="1">
-                <a:solidFill>
-                  <a:srgbClr val="60A0B0"/>
-                </a:solidFill>
-                <a:latin typeface="Courier"/>
-              </a:rPr>
-              <a:t>: assigns to the local parameter, not self.x</a:t>
-            </a:r>
-            <a:br/>
-            <a:r>
-              <a:rPr>
-                <a:latin typeface="Courier"/>
-              </a:rPr>
-              <a:t>        y </a:t>
-            </a:r>
-            <a:r>
-              <a:rPr>
-                <a:solidFill>
-                  <a:srgbClr val="666666"/>
-                </a:solidFill>
-                <a:latin typeface="Courier"/>
-              </a:rPr>
-              <a:t>=</a:t>
-            </a:r>
-            <a:r>
-              <a:rPr>
-                <a:latin typeface="Courier"/>
-              </a:rPr>
-              <a:t> y</a:t>
-            </a:r>
-            <a:br/>
-            <a:br/>
-            <a:r>
-              <a:rPr>
-                <a:latin typeface="Courier"/>
-              </a:rPr>
-              <a:t>p </a:t>
-            </a:r>
-            <a:r>
-              <a:rPr>
-                <a:solidFill>
-                  <a:srgbClr val="666666"/>
-                </a:solidFill>
-                <a:latin typeface="Courier"/>
-              </a:rPr>
-              <a:t>=</a:t>
-            </a:r>
-            <a:r>
-              <a:rPr>
-                <a:latin typeface="Courier"/>
-              </a:rPr>
-              <a:t> Point(</a:t>
-            </a:r>
-            <a:r>
-              <a:rPr>
-                <a:solidFill>
-                  <a:srgbClr val="40A070"/>
-                </a:solidFill>
-                <a:latin typeface="Courier"/>
-              </a:rPr>
-              <a:t>3</a:t>
-            </a:r>
-            <a:r>
-              <a:rPr>
-                <a:latin typeface="Courier"/>
-              </a:rPr>
-              <a:t>, </a:t>
-            </a:r>
-            <a:r>
-              <a:rPr>
-                <a:solidFill>
-                  <a:srgbClr val="40A070"/>
-                </a:solidFill>
-                <a:latin typeface="Courier"/>
-              </a:rPr>
-              <a:t>4</a:t>
-            </a:r>
-            <a:r>
-              <a:rPr>
-                <a:latin typeface="Courier"/>
-              </a:rPr>
-              <a:t>)</a:t>
-            </a:r>
-            <a:br/>
-            <a:r>
-              <a:rPr>
-                <a:solidFill>
-                  <a:srgbClr val="008000"/>
-                </a:solidFill>
-                <a:latin typeface="Courier"/>
-              </a:rPr>
-              <a:t>print</a:t>
-            </a:r>
-            <a:r>
-              <a:rPr>
-                <a:latin typeface="Courier"/>
-              </a:rPr>
-              <a:t>(p.x)   </a:t>
-            </a:r>
-            <a:r>
-              <a:rPr i="1">
-                <a:solidFill>
-                  <a:srgbClr val="60A0B0"/>
-                </a:solidFill>
-                <a:latin typeface="Courier"/>
-              </a:rPr>
-              <a:t># AttributeError: 'Point' object has no attribute 'x'</a:t>
-            </a:r>
-          </a:p>
-        </p:txBody>
-      </p:sp>
-    </p:spTree>
-  </p:cSld>
-</p:sld>
-</file>
-
-<file path=ppt/slides/slide9.xml><?xml version="1.0" encoding="utf-8"?>
-<p:sld xmlns:a="http://schemas.openxmlformats.org/drawingml/2006/main" xmlns:r="http://schemas.openxmlformats.org/officeDocument/2006/relationships" xmlns:p="http://schemas.openxmlformats.org/presentationml/2006/main">
-  <p:cSld>
-    <p:spTree>
-      <p:nvGrpSpPr>
-        <p:cNvPr id="1" name=""/>
-        <p:cNvGrpSpPr/>
-        <p:nvPr/>
-      </p:nvGrpSpPr>
-      <p:grpSpPr>
-        <a:xfrm>
-          <a:off x="0" y="0"/>
-          <a:ext cx="0" cy="0"/>
-          <a:chOff x="0" y="0"/>
-          <a:chExt cx="0" cy="0"/>
-        </a:xfrm>
-      </p:grpSpPr>
-      <p:sp>
-        <p:nvSpPr>
-          <p:cNvPr id="2" name="Title 1"/>
-          <p:cNvSpPr>
-            <a:spLocks noGrp="1"/>
-          </p:cNvSpPr>
-          <p:nvPr>
-            <p:ph type="title"/>
-          </p:nvPr>
-        </p:nvSpPr>
-        <p:spPr/>
-        <p:txBody>
-          <a:bodyPr/>
-          <a:lstStyle/>
-          <a:p>
-            <a:pPr lvl="0" indent="0" marL="0">
-              <a:buNone/>
-            </a:pPr>
-            <a:r>
-              <a:rPr/>
-              <a:t>Live coding exercise (5 minutes)</a:t>
-            </a:r>
-          </a:p>
-        </p:txBody>
-      </p:sp>
-      <p:sp>
-        <p:nvSpPr>
-          <p:cNvPr id="3" name="Content Placeholder 2"/>
-          <p:cNvSpPr>
-            <a:spLocks noGrp="1"/>
-          </p:cNvSpPr>
-          <p:nvPr>
-            <p:ph idx="1"/>
-          </p:nvPr>
-        </p:nvSpPr>
-        <p:spPr/>
-        <p:txBody>
-          <a:bodyPr/>
-          <a:lstStyle/>
-          <a:p>
-            <a:pPr lvl="0" indent="0">
-              <a:buNone/>
-            </a:pPr>
-            <a:r>
-              <a:rPr b="1">
-                <a:solidFill>
-                  <a:srgbClr val="007020"/>
-                </a:solidFill>
-                <a:latin typeface="Courier"/>
-              </a:rPr>
-              <a:t>def</a:t>
-            </a:r>
-            <a:r>
-              <a:rPr>
-                <a:latin typeface="Courier"/>
-              </a:rPr>
-              <a:t> midpoint(</a:t>
-            </a:r>
-            <a:r>
-              <a:rPr>
-                <a:solidFill>
-                  <a:srgbClr val="19177C"/>
-                </a:solidFill>
-                <a:latin typeface="Courier"/>
-              </a:rPr>
-              <a:t>self</a:t>
-            </a:r>
-            <a:r>
-              <a:rPr>
-                <a:latin typeface="Courier"/>
-              </a:rPr>
-              <a:t>, other):</a:t>
-            </a:r>
-            <a:br/>
-            <a:r>
-              <a:rPr>
-                <a:latin typeface="Courier"/>
-              </a:rPr>
-              <a:t>    </a:t>
-            </a:r>
-            <a:r>
-              <a:rPr b="1">
-                <a:solidFill>
-                  <a:srgbClr val="007020"/>
-                </a:solidFill>
-                <a:latin typeface="Courier"/>
-              </a:rPr>
-              <a:t>return</a:t>
-            </a:r>
-            <a:r>
-              <a:rPr>
-                <a:latin typeface="Courier"/>
-              </a:rPr>
-              <a:t> Point((</a:t>
-            </a:r>
-            <a:r>
-              <a:rPr>
-                <a:solidFill>
-                  <a:srgbClr val="19177C"/>
-                </a:solidFill>
-                <a:latin typeface="Courier"/>
-              </a:rPr>
-              <a:t>self</a:t>
-            </a:r>
-            <a:r>
-              <a:rPr>
-                <a:latin typeface="Courier"/>
-              </a:rPr>
-              <a:t>.x </a:t>
-            </a:r>
-            <a:r>
-              <a:rPr>
-                <a:solidFill>
-                  <a:srgbClr val="666666"/>
-                </a:solidFill>
-                <a:latin typeface="Courier"/>
-              </a:rPr>
-              <a:t>+</a:t>
-            </a:r>
-            <a:r>
-              <a:rPr>
-                <a:latin typeface="Courier"/>
-              </a:rPr>
-              <a:t> other.x) </a:t>
-            </a:r>
-            <a:r>
-              <a:rPr>
-                <a:solidFill>
-                  <a:srgbClr val="666666"/>
-                </a:solidFill>
-                <a:latin typeface="Courier"/>
-              </a:rPr>
-              <a:t>/</a:t>
-            </a:r>
-            <a:r>
-              <a:rPr>
-                <a:latin typeface="Courier"/>
-              </a:rPr>
-              <a:t> </a:t>
-            </a:r>
-            <a:r>
-              <a:rPr>
-                <a:solidFill>
-                  <a:srgbClr val="40A070"/>
-                </a:solidFill>
-                <a:latin typeface="Courier"/>
-              </a:rPr>
-              <a:t>2</a:t>
-            </a:r>
-            <a:r>
-              <a:rPr>
-                <a:latin typeface="Courier"/>
-              </a:rPr>
-              <a:t>,</a:t>
-            </a:r>
-            <a:br/>
-            <a:r>
-              <a:rPr>
-                <a:latin typeface="Courier"/>
-              </a:rPr>
-              <a:t>                  (</a:t>
-            </a:r>
-            <a:r>
-              <a:rPr>
-                <a:solidFill>
-                  <a:srgbClr val="19177C"/>
-                </a:solidFill>
-                <a:latin typeface="Courier"/>
-              </a:rPr>
-              <a:t>self</a:t>
-            </a:r>
-            <a:r>
-              <a:rPr>
-                <a:latin typeface="Courier"/>
-              </a:rPr>
-              <a:t>.y </a:t>
-            </a:r>
-            <a:r>
-              <a:rPr>
-                <a:solidFill>
-                  <a:srgbClr val="666666"/>
-                </a:solidFill>
-                <a:latin typeface="Courier"/>
-              </a:rPr>
-              <a:t>+</a:t>
-            </a:r>
-            <a:r>
-              <a:rPr>
-                <a:latin typeface="Courier"/>
-              </a:rPr>
-              <a:t> other.y) </a:t>
-            </a:r>
-            <a:r>
-              <a:rPr>
-                <a:solidFill>
-                  <a:srgbClr val="666666"/>
-                </a:solidFill>
-                <a:latin typeface="Courier"/>
-              </a:rPr>
-              <a:t>/</a:t>
-            </a:r>
-            <a:r>
-              <a:rPr>
-                <a:latin typeface="Courier"/>
-              </a:rPr>
-              <a:t> </a:t>
-            </a:r>
-            <a:r>
-              <a:rPr>
-                <a:solidFill>
-                  <a:srgbClr val="40A070"/>
-                </a:solidFill>
-                <a:latin typeface="Courier"/>
-              </a:rPr>
-              <a:t>2</a:t>
-            </a:r>
-            <a:r>
-              <a:rPr>
-                <a:latin typeface="Courier"/>
-              </a:rPr>
-              <a:t>)</a:t>
-            </a:r>
-          </a:p>
-        </p:txBody>
-      </p:sp>
     </p:spTree>
   </p:cSld>
 </p:sld>

</xml_diff>

<commit_message>
Week 1 Lecture 1: add full course orientation. Week 2: build Arrays and Dynamic Arrays (4 lectures, 20+ slides each)
</commit_message>
<xml_diff>
--- a/courses/z2005/00-oop-then-algorithms/lecture-1.pptx
+++ b/courses/z2005/00-oop-then-algorithms/lecture-1.pptx
@@ -5,7 +5,7 @@
     <p:sldMasterId id="2147483648" r:id="rId1"/>
   </p:sldMasterIdLst>
   <p:notesMasterIdLst>
-    <p:notesMasterId r:id="rId16"/>
+    <p:notesMasterId r:id="rId23"/>
   </p:notesMasterIdLst>
   <p:sldIdLst>
     <p:sldId id="256" r:id="rId2"/>
@@ -22,6 +22,13 @@
     <p:sldId id="267" r:id="rId13"/>
     <p:sldId id="268" r:id="rId14"/>
     <p:sldId id="269" r:id="rId15"/>
+    <p:sldId id="270" r:id="rId16"/>
+    <p:sldId id="271" r:id="rId17"/>
+    <p:sldId id="272" r:id="rId18"/>
+    <p:sldId id="273" r:id="rId19"/>
+    <p:sldId id="274" r:id="rId20"/>
+    <p:sldId id="275" r:id="rId21"/>
+    <p:sldId id="276" r:id="rId22"/>
   </p:sldIdLst>
   <p:sldSz cx="9144000" cy="5143500" type="screen16x9"/>
   <p:notesSz cx="6858000" cy="9144000"/>
@@ -559,7 +566,7 @@
           <a:p>
             <a:fld id="{18BDFEC3-8487-43E8-A154-7C12CBC1FFF2}" type="slidenum">
               <a:rPr lang="en-US"/>
-              <a:t>4</a:t>
+              <a:t>11</a:t>
             </a:fld>
             <a:endParaRPr lang="en-US"/>
           </a:p>
@@ -651,7 +658,7 @@
           <a:p>
             <a:fld id="{18BDFEC3-8487-43E8-A154-7C12CBC1FFF2}" type="slidenum">
               <a:rPr lang="en-US"/>
-              <a:t>11</a:t>
+              <a:t>18</a:t>
             </a:fld>
             <a:endParaRPr lang="en-US"/>
           </a:p>
@@ -3737,244 +3744,7 @@
             </a:pPr>
             <a:r>
               <a:rPr/>
-              <a:t>Common first mistake</a:t>
-            </a:r>
-          </a:p>
-        </p:txBody>
-      </p:sp>
-      <p:sp>
-        <p:nvSpPr>
-          <p:cNvPr id="3" name="Content Placeholder 2"/>
-          <p:cNvSpPr>
-            <a:spLocks noGrp="1"/>
-          </p:cNvSpPr>
-          <p:nvPr>
-            <p:ph idx="1"/>
-          </p:nvPr>
-        </p:nvSpPr>
-        <p:spPr/>
-        <p:txBody>
-          <a:bodyPr/>
-          <a:lstStyle/>
-          <a:p>
-            <a:pPr lvl="0" indent="0">
-              <a:buNone/>
-            </a:pPr>
-            <a:r>
-              <a:rPr b="1">
-                <a:solidFill>
-                  <a:srgbClr val="007020"/>
-                </a:solidFill>
-                <a:latin typeface="Courier"/>
-              </a:rPr>
-              <a:t>class</a:t>
-            </a:r>
-            <a:r>
-              <a:rPr>
-                <a:latin typeface="Courier"/>
-              </a:rPr>
-              <a:t> Point:</a:t>
-            </a:r>
-            <a:br/>
-            <a:r>
-              <a:rPr>
-                <a:latin typeface="Courier"/>
-              </a:rPr>
-              <a:t>    </a:t>
-            </a:r>
-            <a:r>
-              <a:rPr b="1">
-                <a:solidFill>
-                  <a:srgbClr val="007020"/>
-                </a:solidFill>
-                <a:latin typeface="Courier"/>
-              </a:rPr>
-              <a:t>def</a:t>
-            </a:r>
-            <a:r>
-              <a:rPr>
-                <a:latin typeface="Courier"/>
-              </a:rPr>
-              <a:t> </a:t>
-            </a:r>
-            <a:r>
-              <a:rPr>
-                <a:solidFill>
-                  <a:srgbClr val="06287E"/>
-                </a:solidFill>
-                <a:latin typeface="Courier"/>
-              </a:rPr>
-              <a:t>__init__</a:t>
-            </a:r>
-            <a:r>
-              <a:rPr>
-                <a:latin typeface="Courier"/>
-              </a:rPr>
-              <a:t>(</a:t>
-            </a:r>
-            <a:r>
-              <a:rPr>
-                <a:solidFill>
-                  <a:srgbClr val="19177C"/>
-                </a:solidFill>
-                <a:latin typeface="Courier"/>
-              </a:rPr>
-              <a:t>self</a:t>
-            </a:r>
-            <a:r>
-              <a:rPr>
-                <a:latin typeface="Courier"/>
-              </a:rPr>
-              <a:t>, x, y):</a:t>
-            </a:r>
-            <a:br/>
-            <a:r>
-              <a:rPr>
-                <a:latin typeface="Courier"/>
-              </a:rPr>
-              <a:t>        x </a:t>
-            </a:r>
-            <a:r>
-              <a:rPr>
-                <a:solidFill>
-                  <a:srgbClr val="666666"/>
-                </a:solidFill>
-                <a:latin typeface="Courier"/>
-              </a:rPr>
-              <a:t>=</a:t>
-            </a:r>
-            <a:r>
-              <a:rPr>
-                <a:latin typeface="Courier"/>
-              </a:rPr>
-              <a:t> x        </a:t>
-            </a:r>
-            <a:r>
-              <a:rPr i="1">
-                <a:solidFill>
-                  <a:srgbClr val="60A0B0"/>
-                </a:solidFill>
-                <a:latin typeface="Courier"/>
-              </a:rPr>
-              <a:t># </a:t>
-            </a:r>
-            <a:r>
-              <a:rPr b="1">
-                <a:solidFill>
-                  <a:srgbClr val="FF0000"/>
-                </a:solidFill>
-                <a:latin typeface="Courier"/>
-              </a:rPr>
-              <a:t>BUG</a:t>
-            </a:r>
-            <a:r>
-              <a:rPr i="1">
-                <a:solidFill>
-                  <a:srgbClr val="60A0B0"/>
-                </a:solidFill>
-                <a:latin typeface="Courier"/>
-              </a:rPr>
-              <a:t>: assigns to the local parameter, not self.x</a:t>
-            </a:r>
-            <a:br/>
-            <a:r>
-              <a:rPr>
-                <a:latin typeface="Courier"/>
-              </a:rPr>
-              <a:t>        y </a:t>
-            </a:r>
-            <a:r>
-              <a:rPr>
-                <a:solidFill>
-                  <a:srgbClr val="666666"/>
-                </a:solidFill>
-                <a:latin typeface="Courier"/>
-              </a:rPr>
-              <a:t>=</a:t>
-            </a:r>
-            <a:r>
-              <a:rPr>
-                <a:latin typeface="Courier"/>
-              </a:rPr>
-              <a:t> y</a:t>
-            </a:r>
-            <a:br/>
-            <a:br/>
-            <a:r>
-              <a:rPr>
-                <a:latin typeface="Courier"/>
-              </a:rPr>
-              <a:t>p </a:t>
-            </a:r>
-            <a:r>
-              <a:rPr>
-                <a:solidFill>
-                  <a:srgbClr val="666666"/>
-                </a:solidFill>
-                <a:latin typeface="Courier"/>
-              </a:rPr>
-              <a:t>=</a:t>
-            </a:r>
-            <a:r>
-              <a:rPr>
-                <a:latin typeface="Courier"/>
-              </a:rPr>
-              <a:t> Point(</a:t>
-            </a:r>
-            <a:r>
-              <a:rPr>
-                <a:solidFill>
-                  <a:srgbClr val="40A070"/>
-                </a:solidFill>
-                <a:latin typeface="Courier"/>
-              </a:rPr>
-              <a:t>3</a:t>
-            </a:r>
-            <a:r>
-              <a:rPr>
-                <a:latin typeface="Courier"/>
-              </a:rPr>
-              <a:t>, </a:t>
-            </a:r>
-            <a:r>
-              <a:rPr>
-                <a:solidFill>
-                  <a:srgbClr val="40A070"/>
-                </a:solidFill>
-                <a:latin typeface="Courier"/>
-              </a:rPr>
-              <a:t>4</a:t>
-            </a:r>
-            <a:r>
-              <a:rPr>
-                <a:latin typeface="Courier"/>
-              </a:rPr>
-              <a:t>)</a:t>
-            </a:r>
-            <a:br/>
-            <a:r>
-              <a:rPr>
-                <a:solidFill>
-                  <a:srgbClr val="008000"/>
-                </a:solidFill>
-                <a:latin typeface="Courier"/>
-              </a:rPr>
-              <a:t>print</a:t>
-            </a:r>
-            <a:r>
-              <a:rPr>
-                <a:latin typeface="Courier"/>
-              </a:rPr>
-              <a:t>(p.x)   </a:t>
-            </a:r>
-            <a:r>
-              <a:rPr i="1">
-                <a:solidFill>
-                  <a:srgbClr val="60A0B0"/>
-                </a:solidFill>
-                <a:latin typeface="Courier"/>
-              </a:rPr>
-              <a:t># AttributeError: 'Point' object has no attribute 'x'</a:t>
+              <a:t>Outline</a:t>
             </a:r>
           </a:p>
         </p:txBody>
@@ -4021,207 +3791,7 @@
             </a:pPr>
             <a:r>
               <a:rPr/>
-              <a:t>Live coding exercise (5 minutes)</a:t>
-            </a:r>
-          </a:p>
-        </p:txBody>
-      </p:sp>
-      <p:sp>
-        <p:nvSpPr>
-          <p:cNvPr id="3" name="Content Placeholder 2"/>
-          <p:cNvSpPr>
-            <a:spLocks noGrp="1"/>
-          </p:cNvSpPr>
-          <p:nvPr>
-            <p:ph idx="1"/>
-          </p:nvPr>
-        </p:nvSpPr>
-        <p:spPr/>
-        <p:txBody>
-          <a:bodyPr/>
-          <a:lstStyle/>
-          <a:p>
-            <a:pPr lvl="0" indent="0">
-              <a:buNone/>
-            </a:pPr>
-            <a:r>
-              <a:rPr b="1">
-                <a:solidFill>
-                  <a:srgbClr val="007020"/>
-                </a:solidFill>
-                <a:latin typeface="Courier"/>
-              </a:rPr>
-              <a:t>def</a:t>
-            </a:r>
-            <a:r>
-              <a:rPr>
-                <a:latin typeface="Courier"/>
-              </a:rPr>
-              <a:t> midpoint(</a:t>
-            </a:r>
-            <a:r>
-              <a:rPr>
-                <a:solidFill>
-                  <a:srgbClr val="19177C"/>
-                </a:solidFill>
-                <a:latin typeface="Courier"/>
-              </a:rPr>
-              <a:t>self</a:t>
-            </a:r>
-            <a:r>
-              <a:rPr>
-                <a:latin typeface="Courier"/>
-              </a:rPr>
-              <a:t>, other):</a:t>
-            </a:r>
-            <a:br/>
-            <a:r>
-              <a:rPr>
-                <a:latin typeface="Courier"/>
-              </a:rPr>
-              <a:t>    </a:t>
-            </a:r>
-            <a:r>
-              <a:rPr b="1">
-                <a:solidFill>
-                  <a:srgbClr val="007020"/>
-                </a:solidFill>
-                <a:latin typeface="Courier"/>
-              </a:rPr>
-              <a:t>return</a:t>
-            </a:r>
-            <a:r>
-              <a:rPr>
-                <a:latin typeface="Courier"/>
-              </a:rPr>
-              <a:t> Point((</a:t>
-            </a:r>
-            <a:r>
-              <a:rPr>
-                <a:solidFill>
-                  <a:srgbClr val="19177C"/>
-                </a:solidFill>
-                <a:latin typeface="Courier"/>
-              </a:rPr>
-              <a:t>self</a:t>
-            </a:r>
-            <a:r>
-              <a:rPr>
-                <a:latin typeface="Courier"/>
-              </a:rPr>
-              <a:t>.x </a:t>
-            </a:r>
-            <a:r>
-              <a:rPr>
-                <a:solidFill>
-                  <a:srgbClr val="666666"/>
-                </a:solidFill>
-                <a:latin typeface="Courier"/>
-              </a:rPr>
-              <a:t>+</a:t>
-            </a:r>
-            <a:r>
-              <a:rPr>
-                <a:latin typeface="Courier"/>
-              </a:rPr>
-              <a:t> other.x) </a:t>
-            </a:r>
-            <a:r>
-              <a:rPr>
-                <a:solidFill>
-                  <a:srgbClr val="666666"/>
-                </a:solidFill>
-                <a:latin typeface="Courier"/>
-              </a:rPr>
-              <a:t>/</a:t>
-            </a:r>
-            <a:r>
-              <a:rPr>
-                <a:latin typeface="Courier"/>
-              </a:rPr>
-              <a:t> </a:t>
-            </a:r>
-            <a:r>
-              <a:rPr>
-                <a:solidFill>
-                  <a:srgbClr val="40A070"/>
-                </a:solidFill>
-                <a:latin typeface="Courier"/>
-              </a:rPr>
-              <a:t>2</a:t>
-            </a:r>
-            <a:r>
-              <a:rPr>
-                <a:latin typeface="Courier"/>
-              </a:rPr>
-              <a:t>,</a:t>
-            </a:r>
-            <a:br/>
-            <a:r>
-              <a:rPr>
-                <a:latin typeface="Courier"/>
-              </a:rPr>
-              <a:t>                  (</a:t>
-            </a:r>
-            <a:r>
-              <a:rPr>
-                <a:solidFill>
-                  <a:srgbClr val="19177C"/>
-                </a:solidFill>
-                <a:latin typeface="Courier"/>
-              </a:rPr>
-              <a:t>self</a:t>
-            </a:r>
-            <a:r>
-              <a:rPr>
-                <a:latin typeface="Courier"/>
-              </a:rPr>
-              <a:t>.y </a:t>
-            </a:r>
-            <a:r>
-              <a:rPr>
-                <a:solidFill>
-                  <a:srgbClr val="666666"/>
-                </a:solidFill>
-                <a:latin typeface="Courier"/>
-              </a:rPr>
-              <a:t>+</a:t>
-            </a:r>
-            <a:r>
-              <a:rPr>
-                <a:latin typeface="Courier"/>
-              </a:rPr>
-              <a:t> other.y) </a:t>
-            </a:r>
-            <a:r>
-              <a:rPr>
-                <a:solidFill>
-                  <a:srgbClr val="666666"/>
-                </a:solidFill>
-                <a:latin typeface="Courier"/>
-              </a:rPr>
-              <a:t>/</a:t>
-            </a:r>
-            <a:r>
-              <a:rPr>
-                <a:latin typeface="Courier"/>
-              </a:rPr>
-              <a:t> </a:t>
-            </a:r>
-            <a:r>
-              <a:rPr>
-                <a:solidFill>
-                  <a:srgbClr val="40A070"/>
-                </a:solidFill>
-                <a:latin typeface="Courier"/>
-              </a:rPr>
-              <a:t>2</a:t>
-            </a:r>
-            <a:r>
-              <a:rPr>
-                <a:latin typeface="Courier"/>
-              </a:rPr>
-              <a:t>)</a:t>
+              <a:t>Why we start here, not with data structures</a:t>
             </a:r>
           </a:p>
         </p:txBody>
@@ -4268,7 +3838,7 @@
             </a:pPr>
             <a:r>
               <a:rPr/>
-              <a:t>Quiz — spot the bug</a:t>
+              <a:t>The problem, before the solution</a:t>
             </a:r>
           </a:p>
         </p:txBody>
@@ -4292,35 +3862,183 @@
               <a:buNone/>
             </a:pPr>
             <a:r>
-              <a:rPr b="1">
-                <a:solidFill>
-                  <a:srgbClr val="007020"/>
-                </a:solidFill>
-                <a:latin typeface="Courier"/>
-              </a:rPr>
-              <a:t>class</a:t>
-            </a:r>
-            <a:r>
-              <a:rPr>
-                <a:latin typeface="Courier"/>
-              </a:rPr>
-              <a:t> Rectangle:</a:t>
+              <a:rPr>
+                <a:latin typeface="Courier"/>
+              </a:rPr>
+              <a:t>p1 </a:t>
+            </a:r>
+            <a:r>
+              <a:rPr>
+                <a:solidFill>
+                  <a:srgbClr val="666666"/>
+                </a:solidFill>
+                <a:latin typeface="Courier"/>
+              </a:rPr>
+              <a:t>=</a:t>
+            </a:r>
+            <a:r>
+              <a:rPr>
+                <a:latin typeface="Courier"/>
+              </a:rPr>
+              <a:t> (</a:t>
+            </a:r>
+            <a:r>
+              <a:rPr>
+                <a:solidFill>
+                  <a:srgbClr val="40A070"/>
+                </a:solidFill>
+                <a:latin typeface="Courier"/>
+              </a:rPr>
+              <a:t>0</a:t>
+            </a:r>
+            <a:r>
+              <a:rPr>
+                <a:latin typeface="Courier"/>
+              </a:rPr>
+              <a:t>, </a:t>
+            </a:r>
+            <a:r>
+              <a:rPr>
+                <a:solidFill>
+                  <a:srgbClr val="40A070"/>
+                </a:solidFill>
+                <a:latin typeface="Courier"/>
+              </a:rPr>
+              <a:t>0</a:t>
+            </a:r>
+            <a:r>
+              <a:rPr>
+                <a:latin typeface="Courier"/>
+              </a:rPr>
+              <a:t>)</a:t>
             </a:r>
             <a:br/>
             <a:r>
               <a:rPr>
                 <a:latin typeface="Courier"/>
               </a:rPr>
-              <a:t>    </a:t>
-            </a:r>
-            <a:r>
-              <a:rPr b="1">
-                <a:solidFill>
-                  <a:srgbClr val="007020"/>
-                </a:solidFill>
-                <a:latin typeface="Courier"/>
-              </a:rPr>
-              <a:t>def</a:t>
+              <a:t>p2 </a:t>
+            </a:r>
+            <a:r>
+              <a:rPr>
+                <a:solidFill>
+                  <a:srgbClr val="666666"/>
+                </a:solidFill>
+                <a:latin typeface="Courier"/>
+              </a:rPr>
+              <a:t>=</a:t>
+            </a:r>
+            <a:r>
+              <a:rPr>
+                <a:latin typeface="Courier"/>
+              </a:rPr>
+              <a:t> (</a:t>
+            </a:r>
+            <a:r>
+              <a:rPr>
+                <a:solidFill>
+                  <a:srgbClr val="40A070"/>
+                </a:solidFill>
+                <a:latin typeface="Courier"/>
+              </a:rPr>
+              <a:t>3</a:t>
+            </a:r>
+            <a:r>
+              <a:rPr>
+                <a:latin typeface="Courier"/>
+              </a:rPr>
+              <a:t>, </a:t>
+            </a:r>
+            <a:r>
+              <a:rPr>
+                <a:solidFill>
+                  <a:srgbClr val="40A070"/>
+                </a:solidFill>
+                <a:latin typeface="Courier"/>
+              </a:rPr>
+              <a:t>4</a:t>
+            </a:r>
+            <a:r>
+              <a:rPr>
+                <a:latin typeface="Courier"/>
+              </a:rPr>
+              <a:t>)</a:t>
+            </a:r>
+            <a:br/>
+            <a:r>
+              <a:rPr>
+                <a:latin typeface="Courier"/>
+              </a:rPr>
+              <a:t>distance </a:t>
+            </a:r>
+            <a:r>
+              <a:rPr>
+                <a:solidFill>
+                  <a:srgbClr val="666666"/>
+                </a:solidFill>
+                <a:latin typeface="Courier"/>
+              </a:rPr>
+              <a:t>=</a:t>
+            </a:r>
+            <a:r>
+              <a:rPr>
+                <a:latin typeface="Courier"/>
+              </a:rPr>
+              <a:t> ((p1[</a:t>
+            </a:r>
+            <a:r>
+              <a:rPr>
+                <a:solidFill>
+                  <a:srgbClr val="40A070"/>
+                </a:solidFill>
+                <a:latin typeface="Courier"/>
+              </a:rPr>
+              <a:t>0</a:t>
+            </a:r>
+            <a:r>
+              <a:rPr>
+                <a:latin typeface="Courier"/>
+              </a:rPr>
+              <a:t>] </a:t>
+            </a:r>
+            <a:r>
+              <a:rPr>
+                <a:solidFill>
+                  <a:srgbClr val="666666"/>
+                </a:solidFill>
+                <a:latin typeface="Courier"/>
+              </a:rPr>
+              <a:t>-</a:t>
+            </a:r>
+            <a:r>
+              <a:rPr>
+                <a:latin typeface="Courier"/>
+              </a:rPr>
+              <a:t> p2[</a:t>
+            </a:r>
+            <a:r>
+              <a:rPr>
+                <a:solidFill>
+                  <a:srgbClr val="40A070"/>
+                </a:solidFill>
+                <a:latin typeface="Courier"/>
+              </a:rPr>
+              <a:t>0</a:t>
+            </a:r>
+            <a:r>
+              <a:rPr>
+                <a:latin typeface="Courier"/>
+              </a:rPr>
+              <a:t>]) </a:t>
+            </a:r>
+            <a:r>
+              <a:rPr>
+                <a:solidFill>
+                  <a:srgbClr val="666666"/>
+                </a:solidFill>
+                <a:latin typeface="Courier"/>
+              </a:rPr>
+              <a:t>**</a:t>
             </a:r>
             <a:r>
               <a:rPr>
@@ -4331,39 +4049,17 @@
             <a:r>
               <a:rPr>
                 <a:solidFill>
-                  <a:srgbClr val="06287E"/>
-                </a:solidFill>
-                <a:latin typeface="Courier"/>
-              </a:rPr>
-              <a:t>__init__</a:t>
-            </a:r>
-            <a:r>
-              <a:rPr>
-                <a:latin typeface="Courier"/>
-              </a:rPr>
-              <a:t>(</a:t>
-            </a:r>
-            <a:r>
-              <a:rPr>
-                <a:solidFill>
-                  <a:srgbClr val="19177C"/>
-                </a:solidFill>
-                <a:latin typeface="Courier"/>
-              </a:rPr>
-              <a:t>self</a:t>
-            </a:r>
-            <a:r>
-              <a:rPr>
-                <a:latin typeface="Courier"/>
-              </a:rPr>
-              <a:t>, w, h):</a:t>
-            </a:r>
-            <a:br/>
-            <a:r>
-              <a:rPr>
-                <a:latin typeface="Courier"/>
-              </a:rPr>
-              <a:t>        w </a:t>
+                  <a:srgbClr val="40A070"/>
+                </a:solidFill>
+                <a:latin typeface="Courier"/>
+              </a:rPr>
+              <a:t>2</a:t>
+            </a:r>
+            <a:r>
+              <a:rPr>
+                <a:latin typeface="Courier"/>
+              </a:rPr>
+              <a:t> </a:t>
             </a:r>
             <a:r>
               <a:rPr>
@@ -4372,20 +4068,28 @@
                 </a:solidFill>
                 <a:latin typeface="Courier"/>
               </a:rPr>
-              <a:t>=</a:t>
-            </a:r>
-            <a:r>
-              <a:rPr>
-                <a:latin typeface="Courier"/>
-              </a:rPr>
-              <a:t> w</a:t>
-            </a:r>
-            <a:br/>
-            <a:r>
-              <a:rPr>
-                <a:latin typeface="Courier"/>
-              </a:rPr>
-              <a:t>        h </a:t>
+              <a:t>+</a:t>
+            </a:r>
+            <a:r>
+              <a:rPr>
+                <a:latin typeface="Courier"/>
+              </a:rPr>
+              <a:t> (p1[</a:t>
+            </a:r>
+            <a:r>
+              <a:rPr>
+                <a:solidFill>
+                  <a:srgbClr val="40A070"/>
+                </a:solidFill>
+                <a:latin typeface="Courier"/>
+              </a:rPr>
+              <a:t>1</a:t>
+            </a:r>
+            <a:r>
+              <a:rPr>
+                <a:latin typeface="Courier"/>
+              </a:rPr>
+              <a:t>] </a:t>
             </a:r>
             <a:r>
               <a:rPr>
@@ -4394,66 +4098,37 @@
                 </a:solidFill>
                 <a:latin typeface="Courier"/>
               </a:rPr>
-              <a:t>=</a:t>
-            </a:r>
-            <a:r>
-              <a:rPr>
-                <a:latin typeface="Courier"/>
-              </a:rPr>
-              <a:t> h</a:t>
-            </a:r>
-            <a:br/>
-            <a:r>
-              <a:rPr>
-                <a:latin typeface="Courier"/>
-              </a:rPr>
-              <a:t>    </a:t>
-            </a:r>
-            <a:r>
-              <a:rPr b="1">
-                <a:solidFill>
-                  <a:srgbClr val="007020"/>
-                </a:solidFill>
-                <a:latin typeface="Courier"/>
-              </a:rPr>
-              <a:t>def</a:t>
-            </a:r>
-            <a:r>
-              <a:rPr>
-                <a:latin typeface="Courier"/>
-              </a:rPr>
-              <a:t> area(</a:t>
-            </a:r>
-            <a:r>
-              <a:rPr>
-                <a:solidFill>
-                  <a:srgbClr val="19177C"/>
-                </a:solidFill>
-                <a:latin typeface="Courier"/>
-              </a:rPr>
-              <a:t>self</a:t>
-            </a:r>
-            <a:r>
-              <a:rPr>
-                <a:latin typeface="Courier"/>
-              </a:rPr>
-              <a:t>):</a:t>
-            </a:r>
-            <a:br/>
-            <a:r>
-              <a:rPr>
-                <a:latin typeface="Courier"/>
-              </a:rPr>
-              <a:t>        </a:t>
-            </a:r>
-            <a:r>
-              <a:rPr b="1">
-                <a:solidFill>
-                  <a:srgbClr val="007020"/>
-                </a:solidFill>
-                <a:latin typeface="Courier"/>
-              </a:rPr>
-              <a:t>return</a:t>
+              <a:t>-</a:t>
+            </a:r>
+            <a:r>
+              <a:rPr>
+                <a:latin typeface="Courier"/>
+              </a:rPr>
+              <a:t> p2[</a:t>
+            </a:r>
+            <a:r>
+              <a:rPr>
+                <a:solidFill>
+                  <a:srgbClr val="40A070"/>
+                </a:solidFill>
+                <a:latin typeface="Courier"/>
+              </a:rPr>
+              <a:t>1</a:t>
+            </a:r>
+            <a:r>
+              <a:rPr>
+                <a:latin typeface="Courier"/>
+              </a:rPr>
+              <a:t>]) </a:t>
+            </a:r>
+            <a:r>
+              <a:rPr>
+                <a:solidFill>
+                  <a:srgbClr val="666666"/>
+                </a:solidFill>
+                <a:latin typeface="Courier"/>
+              </a:rPr>
+              <a:t>**</a:t>
             </a:r>
             <a:r>
               <a:rPr>
@@ -4464,17 +4139,17 @@
             <a:r>
               <a:rPr>
                 <a:solidFill>
-                  <a:srgbClr val="19177C"/>
-                </a:solidFill>
-                <a:latin typeface="Courier"/>
-              </a:rPr>
-              <a:t>self</a:t>
-            </a:r>
-            <a:r>
-              <a:rPr>
-                <a:latin typeface="Courier"/>
-              </a:rPr>
-              <a:t>.w </a:t>
+                  <a:srgbClr val="40A070"/>
+                </a:solidFill>
+                <a:latin typeface="Courier"/>
+              </a:rPr>
+              <a:t>2</a:t>
+            </a:r>
+            <a:r>
+              <a:rPr>
+                <a:latin typeface="Courier"/>
+              </a:rPr>
+              <a:t>) </a:t>
             </a:r>
             <a:r>
               <a:rPr>
@@ -4483,7 +4158,7 @@
                 </a:solidFill>
                 <a:latin typeface="Courier"/>
               </a:rPr>
-              <a:t>*</a:t>
+              <a:t>**</a:t>
             </a:r>
             <a:r>
               <a:rPr>
@@ -4494,86 +4169,11 @@
             <a:r>
               <a:rPr>
                 <a:solidFill>
-                  <a:srgbClr val="19177C"/>
-                </a:solidFill>
-                <a:latin typeface="Courier"/>
-              </a:rPr>
-              <a:t>self</a:t>
-            </a:r>
-            <a:r>
-              <a:rPr>
-                <a:latin typeface="Courier"/>
-              </a:rPr>
-              <a:t>.h</a:t>
-            </a:r>
-            <a:br/>
-            <a:br/>
-            <a:r>
-              <a:rPr>
-                <a:latin typeface="Courier"/>
-              </a:rPr>
-              <a:t>r </a:t>
-            </a:r>
-            <a:r>
-              <a:rPr>
-                <a:solidFill>
-                  <a:srgbClr val="666666"/>
-                </a:solidFill>
-                <a:latin typeface="Courier"/>
-              </a:rPr>
-              <a:t>=</a:t>
-            </a:r>
-            <a:r>
-              <a:rPr>
-                <a:latin typeface="Courier"/>
-              </a:rPr>
-              <a:t> Rectangle(</a:t>
-            </a:r>
-            <a:r>
-              <a:rPr>
-                <a:solidFill>
                   <a:srgbClr val="40A070"/>
                 </a:solidFill>
                 <a:latin typeface="Courier"/>
               </a:rPr>
-              <a:t>4</a:t>
-            </a:r>
-            <a:r>
-              <a:rPr>
-                <a:latin typeface="Courier"/>
-              </a:rPr>
-              <a:t>, </a:t>
-            </a:r>
-            <a:r>
-              <a:rPr>
-                <a:solidFill>
-                  <a:srgbClr val="40A070"/>
-                </a:solidFill>
-                <a:latin typeface="Courier"/>
-              </a:rPr>
-              <a:t>5</a:t>
-            </a:r>
-            <a:r>
-              <a:rPr>
-                <a:latin typeface="Courier"/>
-              </a:rPr>
-              <a:t>)</a:t>
-            </a:r>
-            <a:br/>
-            <a:r>
-              <a:rPr>
-                <a:solidFill>
-                  <a:srgbClr val="008000"/>
-                </a:solidFill>
-                <a:latin typeface="Courier"/>
-              </a:rPr>
-              <a:t>print</a:t>
-            </a:r>
-            <a:r>
-              <a:rPr>
-                <a:latin typeface="Courier"/>
-              </a:rPr>
-              <a:t>(r.area())</a:t>
+              <a:t>0.5</a:t>
             </a:r>
           </a:p>
         </p:txBody>
@@ -4620,7 +4220,476 @@
             </a:pPr>
             <a:r>
               <a:rPr/>
-              <a:t>Quiz — answer</a:t>
+              <a:t>A class is a blueprint</a:t>
+            </a:r>
+          </a:p>
+        </p:txBody>
+      </p:sp>
+      <p:sp>
+        <p:nvSpPr>
+          <p:cNvPr id="3" name="Content Placeholder 2"/>
+          <p:cNvSpPr>
+            <a:spLocks noGrp="1"/>
+          </p:cNvSpPr>
+          <p:nvPr>
+            <p:ph idx="1"/>
+          </p:nvPr>
+        </p:nvSpPr>
+        <p:spPr/>
+        <p:txBody>
+          <a:bodyPr/>
+          <a:lstStyle/>
+          <a:p>
+            <a:pPr lvl="0" indent="0">
+              <a:buNone/>
+            </a:pPr>
+            <a:r>
+              <a:rPr b="1">
+                <a:solidFill>
+                  <a:srgbClr val="007020"/>
+                </a:solidFill>
+                <a:latin typeface="Courier"/>
+              </a:rPr>
+              <a:t>class</a:t>
+            </a:r>
+            <a:r>
+              <a:rPr>
+                <a:latin typeface="Courier"/>
+              </a:rPr>
+              <a:t> Point:</a:t>
+            </a:r>
+            <a:br/>
+            <a:r>
+              <a:rPr>
+                <a:latin typeface="Courier"/>
+              </a:rPr>
+              <a:t>    </a:t>
+            </a:r>
+            <a:r>
+              <a:rPr i="1">
+                <a:solidFill>
+                  <a:srgbClr val="60A0B0"/>
+                </a:solidFill>
+                <a:latin typeface="Courier"/>
+              </a:rPr>
+              <a:t>"""A point in the 2D plane."""</a:t>
+            </a:r>
+            <a:br/>
+            <a:br/>
+            <a:r>
+              <a:rPr>
+                <a:latin typeface="Courier"/>
+              </a:rPr>
+              <a:t>    </a:t>
+            </a:r>
+            <a:r>
+              <a:rPr b="1">
+                <a:solidFill>
+                  <a:srgbClr val="007020"/>
+                </a:solidFill>
+                <a:latin typeface="Courier"/>
+              </a:rPr>
+              <a:t>def</a:t>
+            </a:r>
+            <a:r>
+              <a:rPr>
+                <a:latin typeface="Courier"/>
+              </a:rPr>
+              <a:t> </a:t>
+            </a:r>
+            <a:r>
+              <a:rPr>
+                <a:solidFill>
+                  <a:srgbClr val="06287E"/>
+                </a:solidFill>
+                <a:latin typeface="Courier"/>
+              </a:rPr>
+              <a:t>__init__</a:t>
+            </a:r>
+            <a:r>
+              <a:rPr>
+                <a:latin typeface="Courier"/>
+              </a:rPr>
+              <a:t>(</a:t>
+            </a:r>
+            <a:r>
+              <a:rPr>
+                <a:solidFill>
+                  <a:srgbClr val="19177C"/>
+                </a:solidFill>
+                <a:latin typeface="Courier"/>
+              </a:rPr>
+              <a:t>self</a:t>
+            </a:r>
+            <a:r>
+              <a:rPr>
+                <a:latin typeface="Courier"/>
+              </a:rPr>
+              <a:t>, x, y):      </a:t>
+            </a:r>
+            <a:r>
+              <a:rPr i="1">
+                <a:solidFill>
+                  <a:srgbClr val="60A0B0"/>
+                </a:solidFill>
+                <a:latin typeface="Courier"/>
+              </a:rPr>
+              <a:t># runs once, when a Point is created</a:t>
+            </a:r>
+            <a:br/>
+            <a:r>
+              <a:rPr>
+                <a:latin typeface="Courier"/>
+              </a:rPr>
+              <a:t>        </a:t>
+            </a:r>
+            <a:r>
+              <a:rPr>
+                <a:solidFill>
+                  <a:srgbClr val="19177C"/>
+                </a:solidFill>
+                <a:latin typeface="Courier"/>
+              </a:rPr>
+              <a:t>self</a:t>
+            </a:r>
+            <a:r>
+              <a:rPr>
+                <a:latin typeface="Courier"/>
+              </a:rPr>
+              <a:t>.x </a:t>
+            </a:r>
+            <a:r>
+              <a:rPr>
+                <a:solidFill>
+                  <a:srgbClr val="666666"/>
+                </a:solidFill>
+                <a:latin typeface="Courier"/>
+              </a:rPr>
+              <a:t>=</a:t>
+            </a:r>
+            <a:r>
+              <a:rPr>
+                <a:latin typeface="Courier"/>
+              </a:rPr>
+              <a:t> x                  </a:t>
+            </a:r>
+            <a:r>
+              <a:rPr i="1">
+                <a:solidFill>
+                  <a:srgbClr val="60A0B0"/>
+                </a:solidFill>
+                <a:latin typeface="Courier"/>
+              </a:rPr>
+              <a:t># self.x is THIS point's x, not some</a:t>
+            </a:r>
+            <a:br/>
+            <a:r>
+              <a:rPr>
+                <a:latin typeface="Courier"/>
+              </a:rPr>
+              <a:t>        </a:t>
+            </a:r>
+            <a:r>
+              <a:rPr>
+                <a:solidFill>
+                  <a:srgbClr val="19177C"/>
+                </a:solidFill>
+                <a:latin typeface="Courier"/>
+              </a:rPr>
+              <a:t>self</a:t>
+            </a:r>
+            <a:r>
+              <a:rPr>
+                <a:latin typeface="Courier"/>
+              </a:rPr>
+              <a:t>.y </a:t>
+            </a:r>
+            <a:r>
+              <a:rPr>
+                <a:solidFill>
+                  <a:srgbClr val="666666"/>
+                </a:solidFill>
+                <a:latin typeface="Courier"/>
+              </a:rPr>
+              <a:t>=</a:t>
+            </a:r>
+            <a:r>
+              <a:rPr>
+                <a:latin typeface="Courier"/>
+              </a:rPr>
+              <a:t> y                  </a:t>
+            </a:r>
+            <a:r>
+              <a:rPr i="1">
+                <a:solidFill>
+                  <a:srgbClr val="60A0B0"/>
+                </a:solidFill>
+                <a:latin typeface="Courier"/>
+              </a:rPr>
+              <a:t># global variable named x</a:t>
+            </a:r>
+            <a:br/>
+            <a:br/>
+            <a:r>
+              <a:rPr>
+                <a:latin typeface="Courier"/>
+              </a:rPr>
+              <a:t>    </a:t>
+            </a:r>
+            <a:r>
+              <a:rPr b="1">
+                <a:solidFill>
+                  <a:srgbClr val="007020"/>
+                </a:solidFill>
+                <a:latin typeface="Courier"/>
+              </a:rPr>
+              <a:t>def</a:t>
+            </a:r>
+            <a:r>
+              <a:rPr>
+                <a:latin typeface="Courier"/>
+              </a:rPr>
+              <a:t> distance_to(</a:t>
+            </a:r>
+            <a:r>
+              <a:rPr>
+                <a:solidFill>
+                  <a:srgbClr val="19177C"/>
+                </a:solidFill>
+                <a:latin typeface="Courier"/>
+              </a:rPr>
+              <a:t>self</a:t>
+            </a:r>
+            <a:r>
+              <a:rPr>
+                <a:latin typeface="Courier"/>
+              </a:rPr>
+              <a:t>, other):</a:t>
+            </a:r>
+            <a:br/>
+            <a:r>
+              <a:rPr>
+                <a:latin typeface="Courier"/>
+              </a:rPr>
+              <a:t>        dx </a:t>
+            </a:r>
+            <a:r>
+              <a:rPr>
+                <a:solidFill>
+                  <a:srgbClr val="666666"/>
+                </a:solidFill>
+                <a:latin typeface="Courier"/>
+              </a:rPr>
+              <a:t>=</a:t>
+            </a:r>
+            <a:r>
+              <a:rPr>
+                <a:latin typeface="Courier"/>
+              </a:rPr>
+              <a:t> </a:t>
+            </a:r>
+            <a:r>
+              <a:rPr>
+                <a:solidFill>
+                  <a:srgbClr val="19177C"/>
+                </a:solidFill>
+                <a:latin typeface="Courier"/>
+              </a:rPr>
+              <a:t>self</a:t>
+            </a:r>
+            <a:r>
+              <a:rPr>
+                <a:latin typeface="Courier"/>
+              </a:rPr>
+              <a:t>.x </a:t>
+            </a:r>
+            <a:r>
+              <a:rPr>
+                <a:solidFill>
+                  <a:srgbClr val="666666"/>
+                </a:solidFill>
+                <a:latin typeface="Courier"/>
+              </a:rPr>
+              <a:t>-</a:t>
+            </a:r>
+            <a:r>
+              <a:rPr>
+                <a:latin typeface="Courier"/>
+              </a:rPr>
+              <a:t> other.x</a:t>
+            </a:r>
+            <a:br/>
+            <a:r>
+              <a:rPr>
+                <a:latin typeface="Courier"/>
+              </a:rPr>
+              <a:t>        dy </a:t>
+            </a:r>
+            <a:r>
+              <a:rPr>
+                <a:solidFill>
+                  <a:srgbClr val="666666"/>
+                </a:solidFill>
+                <a:latin typeface="Courier"/>
+              </a:rPr>
+              <a:t>=</a:t>
+            </a:r>
+            <a:r>
+              <a:rPr>
+                <a:latin typeface="Courier"/>
+              </a:rPr>
+              <a:t> </a:t>
+            </a:r>
+            <a:r>
+              <a:rPr>
+                <a:solidFill>
+                  <a:srgbClr val="19177C"/>
+                </a:solidFill>
+                <a:latin typeface="Courier"/>
+              </a:rPr>
+              <a:t>self</a:t>
+            </a:r>
+            <a:r>
+              <a:rPr>
+                <a:latin typeface="Courier"/>
+              </a:rPr>
+              <a:t>.y </a:t>
+            </a:r>
+            <a:r>
+              <a:rPr>
+                <a:solidFill>
+                  <a:srgbClr val="666666"/>
+                </a:solidFill>
+                <a:latin typeface="Courier"/>
+              </a:rPr>
+              <a:t>-</a:t>
+            </a:r>
+            <a:r>
+              <a:rPr>
+                <a:latin typeface="Courier"/>
+              </a:rPr>
+              <a:t> other.y</a:t>
+            </a:r>
+            <a:br/>
+            <a:r>
+              <a:rPr>
+                <a:latin typeface="Courier"/>
+              </a:rPr>
+              <a:t>        </a:t>
+            </a:r>
+            <a:r>
+              <a:rPr b="1">
+                <a:solidFill>
+                  <a:srgbClr val="007020"/>
+                </a:solidFill>
+                <a:latin typeface="Courier"/>
+              </a:rPr>
+              <a:t>return</a:t>
+            </a:r>
+            <a:r>
+              <a:rPr>
+                <a:latin typeface="Courier"/>
+              </a:rPr>
+              <a:t> (dx </a:t>
+            </a:r>
+            <a:r>
+              <a:rPr>
+                <a:solidFill>
+                  <a:srgbClr val="666666"/>
+                </a:solidFill>
+                <a:latin typeface="Courier"/>
+              </a:rPr>
+              <a:t>**</a:t>
+            </a:r>
+            <a:r>
+              <a:rPr>
+                <a:latin typeface="Courier"/>
+              </a:rPr>
+              <a:t> </a:t>
+            </a:r>
+            <a:r>
+              <a:rPr>
+                <a:solidFill>
+                  <a:srgbClr val="40A070"/>
+                </a:solidFill>
+                <a:latin typeface="Courier"/>
+              </a:rPr>
+              <a:t>2</a:t>
+            </a:r>
+            <a:r>
+              <a:rPr>
+                <a:latin typeface="Courier"/>
+              </a:rPr>
+              <a:t> </a:t>
+            </a:r>
+            <a:r>
+              <a:rPr>
+                <a:solidFill>
+                  <a:srgbClr val="666666"/>
+                </a:solidFill>
+                <a:latin typeface="Courier"/>
+              </a:rPr>
+              <a:t>+</a:t>
+            </a:r>
+            <a:r>
+              <a:rPr>
+                <a:latin typeface="Courier"/>
+              </a:rPr>
+              <a:t> dy </a:t>
+            </a:r>
+            <a:r>
+              <a:rPr>
+                <a:solidFill>
+                  <a:srgbClr val="666666"/>
+                </a:solidFill>
+                <a:latin typeface="Courier"/>
+              </a:rPr>
+              <a:t>**</a:t>
+            </a:r>
+            <a:r>
+              <a:rPr>
+                <a:latin typeface="Courier"/>
+              </a:rPr>
+              <a:t> </a:t>
+            </a:r>
+            <a:r>
+              <a:rPr>
+                <a:solidFill>
+                  <a:srgbClr val="40A070"/>
+                </a:solidFill>
+                <a:latin typeface="Courier"/>
+              </a:rPr>
+              <a:t>2</a:t>
+            </a:r>
+            <a:r>
+              <a:rPr>
+                <a:latin typeface="Courier"/>
+              </a:rPr>
+              <a:t>) </a:t>
+            </a:r>
+            <a:r>
+              <a:rPr>
+                <a:solidFill>
+                  <a:srgbClr val="666666"/>
+                </a:solidFill>
+                <a:latin typeface="Courier"/>
+              </a:rPr>
+              <a:t>**</a:t>
+            </a:r>
+            <a:r>
+              <a:rPr>
+                <a:latin typeface="Courier"/>
+              </a:rPr>
+              <a:t> </a:t>
+            </a:r>
+            <a:r>
+              <a:rPr>
+                <a:solidFill>
+                  <a:srgbClr val="40A070"/>
+                </a:solidFill>
+                <a:latin typeface="Courier"/>
+              </a:rPr>
+              <a:t>0.5</a:t>
             </a:r>
           </a:p>
         </p:txBody>
@@ -4631,1092 +4700,6 @@
 </file>
 
 <file path=ppt/slides/slide14.xml><?xml version="1.0" encoding="utf-8"?>
-<p:sld xmlns:a="http://schemas.openxmlformats.org/drawingml/2006/main" xmlns:r="http://schemas.openxmlformats.org/officeDocument/2006/relationships" xmlns:p="http://schemas.openxmlformats.org/presentationml/2006/main">
-  <p:cSld>
-    <p:spTree>
-      <p:nvGrpSpPr>
-        <p:cNvPr id="1" name=""/>
-        <p:cNvGrpSpPr/>
-        <p:nvPr/>
-      </p:nvGrpSpPr>
-      <p:grpSpPr>
-        <a:xfrm>
-          <a:off x="0" y="0"/>
-          <a:ext cx="0" cy="0"/>
-          <a:chOff x="0" y="0"/>
-          <a:chExt cx="0" cy="0"/>
-        </a:xfrm>
-      </p:grpSpPr>
-      <p:sp>
-        <p:nvSpPr>
-          <p:cNvPr id="2" name="Title 1"/>
-          <p:cNvSpPr>
-            <a:spLocks noGrp="1"/>
-          </p:cNvSpPr>
-          <p:nvPr>
-            <p:ph type="title"/>
-          </p:nvPr>
-        </p:nvSpPr>
-        <p:spPr/>
-        <p:txBody>
-          <a:bodyPr/>
-          <a:lstStyle/>
-          <a:p>
-            <a:pPr lvl="0" indent="0" marL="0">
-              <a:buNone/>
-            </a:pPr>
-            <a:r>
-              <a:rPr/>
-              <a:t>Summary</a:t>
-            </a:r>
-          </a:p>
-        </p:txBody>
-      </p:sp>
-    </p:spTree>
-  </p:cSld>
-</p:sld>
-</file>
-
-<file path=ppt/slides/slide2.xml><?xml version="1.0" encoding="utf-8"?>
-<p:sld xmlns:a="http://schemas.openxmlformats.org/drawingml/2006/main" xmlns:r="http://schemas.openxmlformats.org/officeDocument/2006/relationships" xmlns:p="http://schemas.openxmlformats.org/presentationml/2006/main">
-  <p:cSld>
-    <p:spTree>
-      <p:nvGrpSpPr>
-        <p:cNvPr id="1" name=""/>
-        <p:cNvGrpSpPr/>
-        <p:nvPr/>
-      </p:nvGrpSpPr>
-      <p:grpSpPr>
-        <a:xfrm>
-          <a:off x="0" y="0"/>
-          <a:ext cx="0" cy="0"/>
-          <a:chOff x="0" y="0"/>
-          <a:chExt cx="0" cy="0"/>
-        </a:xfrm>
-      </p:grpSpPr>
-      <p:sp>
-        <p:nvSpPr>
-          <p:cNvPr id="2" name="Title 1"/>
-          <p:cNvSpPr>
-            <a:spLocks noGrp="1"/>
-          </p:cNvSpPr>
-          <p:nvPr>
-            <p:ph type="title"/>
-          </p:nvPr>
-        </p:nvSpPr>
-        <p:spPr/>
-        <p:txBody>
-          <a:bodyPr/>
-          <a:lstStyle/>
-          <a:p>
-            <a:pPr lvl="0" indent="0" marL="0">
-              <a:buNone/>
-            </a:pPr>
-            <a:r>
-              <a:rPr/>
-              <a:t>Objectives</a:t>
-            </a:r>
-          </a:p>
-        </p:txBody>
-      </p:sp>
-    </p:spTree>
-  </p:cSld>
-</p:sld>
-</file>
-
-<file path=ppt/slides/slide3.xml><?xml version="1.0" encoding="utf-8"?>
-<p:sld xmlns:a="http://schemas.openxmlformats.org/drawingml/2006/main" xmlns:r="http://schemas.openxmlformats.org/officeDocument/2006/relationships" xmlns:p="http://schemas.openxmlformats.org/presentationml/2006/main">
-  <p:cSld>
-    <p:spTree>
-      <p:nvGrpSpPr>
-        <p:cNvPr id="1" name=""/>
-        <p:cNvGrpSpPr/>
-        <p:nvPr/>
-      </p:nvGrpSpPr>
-      <p:grpSpPr>
-        <a:xfrm>
-          <a:off x="0" y="0"/>
-          <a:ext cx="0" cy="0"/>
-          <a:chOff x="0" y="0"/>
-          <a:chExt cx="0" cy="0"/>
-        </a:xfrm>
-      </p:grpSpPr>
-      <p:sp>
-        <p:nvSpPr>
-          <p:cNvPr id="2" name="Title 1"/>
-          <p:cNvSpPr>
-            <a:spLocks noGrp="1"/>
-          </p:cNvSpPr>
-          <p:nvPr>
-            <p:ph type="title"/>
-          </p:nvPr>
-        </p:nvSpPr>
-        <p:spPr/>
-        <p:txBody>
-          <a:bodyPr/>
-          <a:lstStyle/>
-          <a:p>
-            <a:pPr lvl="0" indent="0" marL="0">
-              <a:buNone/>
-            </a:pPr>
-            <a:r>
-              <a:rPr/>
-              <a:t>Outline</a:t>
-            </a:r>
-          </a:p>
-        </p:txBody>
-      </p:sp>
-    </p:spTree>
-  </p:cSld>
-</p:sld>
-</file>
-
-<file path=ppt/slides/slide4.xml><?xml version="1.0" encoding="utf-8"?>
-<p:sld xmlns:a="http://schemas.openxmlformats.org/drawingml/2006/main" xmlns:r="http://schemas.openxmlformats.org/officeDocument/2006/relationships" xmlns:p="http://schemas.openxmlformats.org/presentationml/2006/main">
-  <p:cSld>
-    <p:spTree>
-      <p:nvGrpSpPr>
-        <p:cNvPr id="1" name=""/>
-        <p:cNvGrpSpPr/>
-        <p:nvPr/>
-      </p:nvGrpSpPr>
-      <p:grpSpPr>
-        <a:xfrm>
-          <a:off x="0" y="0"/>
-          <a:ext cx="0" cy="0"/>
-          <a:chOff x="0" y="0"/>
-          <a:chExt cx="0" cy="0"/>
-        </a:xfrm>
-      </p:grpSpPr>
-      <p:sp>
-        <p:nvSpPr>
-          <p:cNvPr id="2" name="Title 1"/>
-          <p:cNvSpPr>
-            <a:spLocks noGrp="1"/>
-          </p:cNvSpPr>
-          <p:nvPr>
-            <p:ph type="title"/>
-          </p:nvPr>
-        </p:nvSpPr>
-        <p:spPr/>
-        <p:txBody>
-          <a:bodyPr/>
-          <a:lstStyle/>
-          <a:p>
-            <a:pPr lvl="0" indent="0" marL="0">
-              <a:buNone/>
-            </a:pPr>
-            <a:r>
-              <a:rPr/>
-              <a:t>Why we start here, not with data structures</a:t>
-            </a:r>
-          </a:p>
-        </p:txBody>
-      </p:sp>
-    </p:spTree>
-  </p:cSld>
-</p:sld>
-</file>
-
-<file path=ppt/slides/slide5.xml><?xml version="1.0" encoding="utf-8"?>
-<p:sld xmlns:a="http://schemas.openxmlformats.org/drawingml/2006/main" xmlns:r="http://schemas.openxmlformats.org/officeDocument/2006/relationships" xmlns:p="http://schemas.openxmlformats.org/presentationml/2006/main">
-  <p:cSld>
-    <p:spTree>
-      <p:nvGrpSpPr>
-        <p:cNvPr id="1" name=""/>
-        <p:cNvGrpSpPr/>
-        <p:nvPr/>
-      </p:nvGrpSpPr>
-      <p:grpSpPr>
-        <a:xfrm>
-          <a:off x="0" y="0"/>
-          <a:ext cx="0" cy="0"/>
-          <a:chOff x="0" y="0"/>
-          <a:chExt cx="0" cy="0"/>
-        </a:xfrm>
-      </p:grpSpPr>
-      <p:sp>
-        <p:nvSpPr>
-          <p:cNvPr id="2" name="Title 1"/>
-          <p:cNvSpPr>
-            <a:spLocks noGrp="1"/>
-          </p:cNvSpPr>
-          <p:nvPr>
-            <p:ph type="title"/>
-          </p:nvPr>
-        </p:nvSpPr>
-        <p:spPr/>
-        <p:txBody>
-          <a:bodyPr/>
-          <a:lstStyle/>
-          <a:p>
-            <a:pPr lvl="0" indent="0" marL="0">
-              <a:buNone/>
-            </a:pPr>
-            <a:r>
-              <a:rPr/>
-              <a:t>The problem, before the solution</a:t>
-            </a:r>
-          </a:p>
-        </p:txBody>
-      </p:sp>
-      <p:sp>
-        <p:nvSpPr>
-          <p:cNvPr id="3" name="Content Placeholder 2"/>
-          <p:cNvSpPr>
-            <a:spLocks noGrp="1"/>
-          </p:cNvSpPr>
-          <p:nvPr>
-            <p:ph idx="1"/>
-          </p:nvPr>
-        </p:nvSpPr>
-        <p:spPr/>
-        <p:txBody>
-          <a:bodyPr/>
-          <a:lstStyle/>
-          <a:p>
-            <a:pPr lvl="0" indent="0">
-              <a:buNone/>
-            </a:pPr>
-            <a:r>
-              <a:rPr>
-                <a:latin typeface="Courier"/>
-              </a:rPr>
-              <a:t>p1 </a:t>
-            </a:r>
-            <a:r>
-              <a:rPr>
-                <a:solidFill>
-                  <a:srgbClr val="666666"/>
-                </a:solidFill>
-                <a:latin typeface="Courier"/>
-              </a:rPr>
-              <a:t>=</a:t>
-            </a:r>
-            <a:r>
-              <a:rPr>
-                <a:latin typeface="Courier"/>
-              </a:rPr>
-              <a:t> (</a:t>
-            </a:r>
-            <a:r>
-              <a:rPr>
-                <a:solidFill>
-                  <a:srgbClr val="40A070"/>
-                </a:solidFill>
-                <a:latin typeface="Courier"/>
-              </a:rPr>
-              <a:t>0</a:t>
-            </a:r>
-            <a:r>
-              <a:rPr>
-                <a:latin typeface="Courier"/>
-              </a:rPr>
-              <a:t>, </a:t>
-            </a:r>
-            <a:r>
-              <a:rPr>
-                <a:solidFill>
-                  <a:srgbClr val="40A070"/>
-                </a:solidFill>
-                <a:latin typeface="Courier"/>
-              </a:rPr>
-              <a:t>0</a:t>
-            </a:r>
-            <a:r>
-              <a:rPr>
-                <a:latin typeface="Courier"/>
-              </a:rPr>
-              <a:t>)</a:t>
-            </a:r>
-            <a:br/>
-            <a:r>
-              <a:rPr>
-                <a:latin typeface="Courier"/>
-              </a:rPr>
-              <a:t>p2 </a:t>
-            </a:r>
-            <a:r>
-              <a:rPr>
-                <a:solidFill>
-                  <a:srgbClr val="666666"/>
-                </a:solidFill>
-                <a:latin typeface="Courier"/>
-              </a:rPr>
-              <a:t>=</a:t>
-            </a:r>
-            <a:r>
-              <a:rPr>
-                <a:latin typeface="Courier"/>
-              </a:rPr>
-              <a:t> (</a:t>
-            </a:r>
-            <a:r>
-              <a:rPr>
-                <a:solidFill>
-                  <a:srgbClr val="40A070"/>
-                </a:solidFill>
-                <a:latin typeface="Courier"/>
-              </a:rPr>
-              <a:t>3</a:t>
-            </a:r>
-            <a:r>
-              <a:rPr>
-                <a:latin typeface="Courier"/>
-              </a:rPr>
-              <a:t>, </a:t>
-            </a:r>
-            <a:r>
-              <a:rPr>
-                <a:solidFill>
-                  <a:srgbClr val="40A070"/>
-                </a:solidFill>
-                <a:latin typeface="Courier"/>
-              </a:rPr>
-              <a:t>4</a:t>
-            </a:r>
-            <a:r>
-              <a:rPr>
-                <a:latin typeface="Courier"/>
-              </a:rPr>
-              <a:t>)</a:t>
-            </a:r>
-            <a:br/>
-            <a:r>
-              <a:rPr>
-                <a:latin typeface="Courier"/>
-              </a:rPr>
-              <a:t>distance </a:t>
-            </a:r>
-            <a:r>
-              <a:rPr>
-                <a:solidFill>
-                  <a:srgbClr val="666666"/>
-                </a:solidFill>
-                <a:latin typeface="Courier"/>
-              </a:rPr>
-              <a:t>=</a:t>
-            </a:r>
-            <a:r>
-              <a:rPr>
-                <a:latin typeface="Courier"/>
-              </a:rPr>
-              <a:t> ((p1[</a:t>
-            </a:r>
-            <a:r>
-              <a:rPr>
-                <a:solidFill>
-                  <a:srgbClr val="40A070"/>
-                </a:solidFill>
-                <a:latin typeface="Courier"/>
-              </a:rPr>
-              <a:t>0</a:t>
-            </a:r>
-            <a:r>
-              <a:rPr>
-                <a:latin typeface="Courier"/>
-              </a:rPr>
-              <a:t>] </a:t>
-            </a:r>
-            <a:r>
-              <a:rPr>
-                <a:solidFill>
-                  <a:srgbClr val="666666"/>
-                </a:solidFill>
-                <a:latin typeface="Courier"/>
-              </a:rPr>
-              <a:t>-</a:t>
-            </a:r>
-            <a:r>
-              <a:rPr>
-                <a:latin typeface="Courier"/>
-              </a:rPr>
-              <a:t> p2[</a:t>
-            </a:r>
-            <a:r>
-              <a:rPr>
-                <a:solidFill>
-                  <a:srgbClr val="40A070"/>
-                </a:solidFill>
-                <a:latin typeface="Courier"/>
-              </a:rPr>
-              <a:t>0</a:t>
-            </a:r>
-            <a:r>
-              <a:rPr>
-                <a:latin typeface="Courier"/>
-              </a:rPr>
-              <a:t>]) </a:t>
-            </a:r>
-            <a:r>
-              <a:rPr>
-                <a:solidFill>
-                  <a:srgbClr val="666666"/>
-                </a:solidFill>
-                <a:latin typeface="Courier"/>
-              </a:rPr>
-              <a:t>**</a:t>
-            </a:r>
-            <a:r>
-              <a:rPr>
-                <a:latin typeface="Courier"/>
-              </a:rPr>
-              <a:t> </a:t>
-            </a:r>
-            <a:r>
-              <a:rPr>
-                <a:solidFill>
-                  <a:srgbClr val="40A070"/>
-                </a:solidFill>
-                <a:latin typeface="Courier"/>
-              </a:rPr>
-              <a:t>2</a:t>
-            </a:r>
-            <a:r>
-              <a:rPr>
-                <a:latin typeface="Courier"/>
-              </a:rPr>
-              <a:t> </a:t>
-            </a:r>
-            <a:r>
-              <a:rPr>
-                <a:solidFill>
-                  <a:srgbClr val="666666"/>
-                </a:solidFill>
-                <a:latin typeface="Courier"/>
-              </a:rPr>
-              <a:t>+</a:t>
-            </a:r>
-            <a:r>
-              <a:rPr>
-                <a:latin typeface="Courier"/>
-              </a:rPr>
-              <a:t> (p1[</a:t>
-            </a:r>
-            <a:r>
-              <a:rPr>
-                <a:solidFill>
-                  <a:srgbClr val="40A070"/>
-                </a:solidFill>
-                <a:latin typeface="Courier"/>
-              </a:rPr>
-              <a:t>1</a:t>
-            </a:r>
-            <a:r>
-              <a:rPr>
-                <a:latin typeface="Courier"/>
-              </a:rPr>
-              <a:t>] </a:t>
-            </a:r>
-            <a:r>
-              <a:rPr>
-                <a:solidFill>
-                  <a:srgbClr val="666666"/>
-                </a:solidFill>
-                <a:latin typeface="Courier"/>
-              </a:rPr>
-              <a:t>-</a:t>
-            </a:r>
-            <a:r>
-              <a:rPr>
-                <a:latin typeface="Courier"/>
-              </a:rPr>
-              <a:t> p2[</a:t>
-            </a:r>
-            <a:r>
-              <a:rPr>
-                <a:solidFill>
-                  <a:srgbClr val="40A070"/>
-                </a:solidFill>
-                <a:latin typeface="Courier"/>
-              </a:rPr>
-              <a:t>1</a:t>
-            </a:r>
-            <a:r>
-              <a:rPr>
-                <a:latin typeface="Courier"/>
-              </a:rPr>
-              <a:t>]) </a:t>
-            </a:r>
-            <a:r>
-              <a:rPr>
-                <a:solidFill>
-                  <a:srgbClr val="666666"/>
-                </a:solidFill>
-                <a:latin typeface="Courier"/>
-              </a:rPr>
-              <a:t>**</a:t>
-            </a:r>
-            <a:r>
-              <a:rPr>
-                <a:latin typeface="Courier"/>
-              </a:rPr>
-              <a:t> </a:t>
-            </a:r>
-            <a:r>
-              <a:rPr>
-                <a:solidFill>
-                  <a:srgbClr val="40A070"/>
-                </a:solidFill>
-                <a:latin typeface="Courier"/>
-              </a:rPr>
-              <a:t>2</a:t>
-            </a:r>
-            <a:r>
-              <a:rPr>
-                <a:latin typeface="Courier"/>
-              </a:rPr>
-              <a:t>) </a:t>
-            </a:r>
-            <a:r>
-              <a:rPr>
-                <a:solidFill>
-                  <a:srgbClr val="666666"/>
-                </a:solidFill>
-                <a:latin typeface="Courier"/>
-              </a:rPr>
-              <a:t>**</a:t>
-            </a:r>
-            <a:r>
-              <a:rPr>
-                <a:latin typeface="Courier"/>
-              </a:rPr>
-              <a:t> </a:t>
-            </a:r>
-            <a:r>
-              <a:rPr>
-                <a:solidFill>
-                  <a:srgbClr val="40A070"/>
-                </a:solidFill>
-                <a:latin typeface="Courier"/>
-              </a:rPr>
-              <a:t>0.5</a:t>
-            </a:r>
-          </a:p>
-        </p:txBody>
-      </p:sp>
-    </p:spTree>
-  </p:cSld>
-</p:sld>
-</file>
-
-<file path=ppt/slides/slide6.xml><?xml version="1.0" encoding="utf-8"?>
-<p:sld xmlns:a="http://schemas.openxmlformats.org/drawingml/2006/main" xmlns:r="http://schemas.openxmlformats.org/officeDocument/2006/relationships" xmlns:p="http://schemas.openxmlformats.org/presentationml/2006/main">
-  <p:cSld>
-    <p:spTree>
-      <p:nvGrpSpPr>
-        <p:cNvPr id="1" name=""/>
-        <p:cNvGrpSpPr/>
-        <p:nvPr/>
-      </p:nvGrpSpPr>
-      <p:grpSpPr>
-        <a:xfrm>
-          <a:off x="0" y="0"/>
-          <a:ext cx="0" cy="0"/>
-          <a:chOff x="0" y="0"/>
-          <a:chExt cx="0" cy="0"/>
-        </a:xfrm>
-      </p:grpSpPr>
-      <p:sp>
-        <p:nvSpPr>
-          <p:cNvPr id="2" name="Title 1"/>
-          <p:cNvSpPr>
-            <a:spLocks noGrp="1"/>
-          </p:cNvSpPr>
-          <p:nvPr>
-            <p:ph type="title"/>
-          </p:nvPr>
-        </p:nvSpPr>
-        <p:spPr/>
-        <p:txBody>
-          <a:bodyPr/>
-          <a:lstStyle/>
-          <a:p>
-            <a:pPr lvl="0" indent="0" marL="0">
-              <a:buNone/>
-            </a:pPr>
-            <a:r>
-              <a:rPr/>
-              <a:t>A class is a blueprint</a:t>
-            </a:r>
-          </a:p>
-        </p:txBody>
-      </p:sp>
-      <p:sp>
-        <p:nvSpPr>
-          <p:cNvPr id="3" name="Content Placeholder 2"/>
-          <p:cNvSpPr>
-            <a:spLocks noGrp="1"/>
-          </p:cNvSpPr>
-          <p:nvPr>
-            <p:ph idx="1"/>
-          </p:nvPr>
-        </p:nvSpPr>
-        <p:spPr/>
-        <p:txBody>
-          <a:bodyPr/>
-          <a:lstStyle/>
-          <a:p>
-            <a:pPr lvl="0" indent="0">
-              <a:buNone/>
-            </a:pPr>
-            <a:r>
-              <a:rPr b="1">
-                <a:solidFill>
-                  <a:srgbClr val="007020"/>
-                </a:solidFill>
-                <a:latin typeface="Courier"/>
-              </a:rPr>
-              <a:t>class</a:t>
-            </a:r>
-            <a:r>
-              <a:rPr>
-                <a:latin typeface="Courier"/>
-              </a:rPr>
-              <a:t> Point:</a:t>
-            </a:r>
-            <a:br/>
-            <a:r>
-              <a:rPr>
-                <a:latin typeface="Courier"/>
-              </a:rPr>
-              <a:t>    </a:t>
-            </a:r>
-            <a:r>
-              <a:rPr i="1">
-                <a:solidFill>
-                  <a:srgbClr val="60A0B0"/>
-                </a:solidFill>
-                <a:latin typeface="Courier"/>
-              </a:rPr>
-              <a:t>"""A point in the 2D plane."""</a:t>
-            </a:r>
-            <a:br/>
-            <a:br/>
-            <a:r>
-              <a:rPr>
-                <a:latin typeface="Courier"/>
-              </a:rPr>
-              <a:t>    </a:t>
-            </a:r>
-            <a:r>
-              <a:rPr b="1">
-                <a:solidFill>
-                  <a:srgbClr val="007020"/>
-                </a:solidFill>
-                <a:latin typeface="Courier"/>
-              </a:rPr>
-              <a:t>def</a:t>
-            </a:r>
-            <a:r>
-              <a:rPr>
-                <a:latin typeface="Courier"/>
-              </a:rPr>
-              <a:t> </a:t>
-            </a:r>
-            <a:r>
-              <a:rPr>
-                <a:solidFill>
-                  <a:srgbClr val="06287E"/>
-                </a:solidFill>
-                <a:latin typeface="Courier"/>
-              </a:rPr>
-              <a:t>__init__</a:t>
-            </a:r>
-            <a:r>
-              <a:rPr>
-                <a:latin typeface="Courier"/>
-              </a:rPr>
-              <a:t>(</a:t>
-            </a:r>
-            <a:r>
-              <a:rPr>
-                <a:solidFill>
-                  <a:srgbClr val="19177C"/>
-                </a:solidFill>
-                <a:latin typeface="Courier"/>
-              </a:rPr>
-              <a:t>self</a:t>
-            </a:r>
-            <a:r>
-              <a:rPr>
-                <a:latin typeface="Courier"/>
-              </a:rPr>
-              <a:t>, x, y):      </a:t>
-            </a:r>
-            <a:r>
-              <a:rPr i="1">
-                <a:solidFill>
-                  <a:srgbClr val="60A0B0"/>
-                </a:solidFill>
-                <a:latin typeface="Courier"/>
-              </a:rPr>
-              <a:t># runs once, when a Point is created</a:t>
-            </a:r>
-            <a:br/>
-            <a:r>
-              <a:rPr>
-                <a:latin typeface="Courier"/>
-              </a:rPr>
-              <a:t>        </a:t>
-            </a:r>
-            <a:r>
-              <a:rPr>
-                <a:solidFill>
-                  <a:srgbClr val="19177C"/>
-                </a:solidFill>
-                <a:latin typeface="Courier"/>
-              </a:rPr>
-              <a:t>self</a:t>
-            </a:r>
-            <a:r>
-              <a:rPr>
-                <a:latin typeface="Courier"/>
-              </a:rPr>
-              <a:t>.x </a:t>
-            </a:r>
-            <a:r>
-              <a:rPr>
-                <a:solidFill>
-                  <a:srgbClr val="666666"/>
-                </a:solidFill>
-                <a:latin typeface="Courier"/>
-              </a:rPr>
-              <a:t>=</a:t>
-            </a:r>
-            <a:r>
-              <a:rPr>
-                <a:latin typeface="Courier"/>
-              </a:rPr>
-              <a:t> x                  </a:t>
-            </a:r>
-            <a:r>
-              <a:rPr i="1">
-                <a:solidFill>
-                  <a:srgbClr val="60A0B0"/>
-                </a:solidFill>
-                <a:latin typeface="Courier"/>
-              </a:rPr>
-              <a:t># self.x is THIS point's x, not some</a:t>
-            </a:r>
-            <a:br/>
-            <a:r>
-              <a:rPr>
-                <a:latin typeface="Courier"/>
-              </a:rPr>
-              <a:t>        </a:t>
-            </a:r>
-            <a:r>
-              <a:rPr>
-                <a:solidFill>
-                  <a:srgbClr val="19177C"/>
-                </a:solidFill>
-                <a:latin typeface="Courier"/>
-              </a:rPr>
-              <a:t>self</a:t>
-            </a:r>
-            <a:r>
-              <a:rPr>
-                <a:latin typeface="Courier"/>
-              </a:rPr>
-              <a:t>.y </a:t>
-            </a:r>
-            <a:r>
-              <a:rPr>
-                <a:solidFill>
-                  <a:srgbClr val="666666"/>
-                </a:solidFill>
-                <a:latin typeface="Courier"/>
-              </a:rPr>
-              <a:t>=</a:t>
-            </a:r>
-            <a:r>
-              <a:rPr>
-                <a:latin typeface="Courier"/>
-              </a:rPr>
-              <a:t> y                  </a:t>
-            </a:r>
-            <a:r>
-              <a:rPr i="1">
-                <a:solidFill>
-                  <a:srgbClr val="60A0B0"/>
-                </a:solidFill>
-                <a:latin typeface="Courier"/>
-              </a:rPr>
-              <a:t># global variable named x</a:t>
-            </a:r>
-            <a:br/>
-            <a:br/>
-            <a:r>
-              <a:rPr>
-                <a:latin typeface="Courier"/>
-              </a:rPr>
-              <a:t>    </a:t>
-            </a:r>
-            <a:r>
-              <a:rPr b="1">
-                <a:solidFill>
-                  <a:srgbClr val="007020"/>
-                </a:solidFill>
-                <a:latin typeface="Courier"/>
-              </a:rPr>
-              <a:t>def</a:t>
-            </a:r>
-            <a:r>
-              <a:rPr>
-                <a:latin typeface="Courier"/>
-              </a:rPr>
-              <a:t> distance_to(</a:t>
-            </a:r>
-            <a:r>
-              <a:rPr>
-                <a:solidFill>
-                  <a:srgbClr val="19177C"/>
-                </a:solidFill>
-                <a:latin typeface="Courier"/>
-              </a:rPr>
-              <a:t>self</a:t>
-            </a:r>
-            <a:r>
-              <a:rPr>
-                <a:latin typeface="Courier"/>
-              </a:rPr>
-              <a:t>, other):</a:t>
-            </a:r>
-            <a:br/>
-            <a:r>
-              <a:rPr>
-                <a:latin typeface="Courier"/>
-              </a:rPr>
-              <a:t>        dx </a:t>
-            </a:r>
-            <a:r>
-              <a:rPr>
-                <a:solidFill>
-                  <a:srgbClr val="666666"/>
-                </a:solidFill>
-                <a:latin typeface="Courier"/>
-              </a:rPr>
-              <a:t>=</a:t>
-            </a:r>
-            <a:r>
-              <a:rPr>
-                <a:latin typeface="Courier"/>
-              </a:rPr>
-              <a:t> </a:t>
-            </a:r>
-            <a:r>
-              <a:rPr>
-                <a:solidFill>
-                  <a:srgbClr val="19177C"/>
-                </a:solidFill>
-                <a:latin typeface="Courier"/>
-              </a:rPr>
-              <a:t>self</a:t>
-            </a:r>
-            <a:r>
-              <a:rPr>
-                <a:latin typeface="Courier"/>
-              </a:rPr>
-              <a:t>.x </a:t>
-            </a:r>
-            <a:r>
-              <a:rPr>
-                <a:solidFill>
-                  <a:srgbClr val="666666"/>
-                </a:solidFill>
-                <a:latin typeface="Courier"/>
-              </a:rPr>
-              <a:t>-</a:t>
-            </a:r>
-            <a:r>
-              <a:rPr>
-                <a:latin typeface="Courier"/>
-              </a:rPr>
-              <a:t> other.x</a:t>
-            </a:r>
-            <a:br/>
-            <a:r>
-              <a:rPr>
-                <a:latin typeface="Courier"/>
-              </a:rPr>
-              <a:t>        dy </a:t>
-            </a:r>
-            <a:r>
-              <a:rPr>
-                <a:solidFill>
-                  <a:srgbClr val="666666"/>
-                </a:solidFill>
-                <a:latin typeface="Courier"/>
-              </a:rPr>
-              <a:t>=</a:t>
-            </a:r>
-            <a:r>
-              <a:rPr>
-                <a:latin typeface="Courier"/>
-              </a:rPr>
-              <a:t> </a:t>
-            </a:r>
-            <a:r>
-              <a:rPr>
-                <a:solidFill>
-                  <a:srgbClr val="19177C"/>
-                </a:solidFill>
-                <a:latin typeface="Courier"/>
-              </a:rPr>
-              <a:t>self</a:t>
-            </a:r>
-            <a:r>
-              <a:rPr>
-                <a:latin typeface="Courier"/>
-              </a:rPr>
-              <a:t>.y </a:t>
-            </a:r>
-            <a:r>
-              <a:rPr>
-                <a:solidFill>
-                  <a:srgbClr val="666666"/>
-                </a:solidFill>
-                <a:latin typeface="Courier"/>
-              </a:rPr>
-              <a:t>-</a:t>
-            </a:r>
-            <a:r>
-              <a:rPr>
-                <a:latin typeface="Courier"/>
-              </a:rPr>
-              <a:t> other.y</a:t>
-            </a:r>
-            <a:br/>
-            <a:r>
-              <a:rPr>
-                <a:latin typeface="Courier"/>
-              </a:rPr>
-              <a:t>        </a:t>
-            </a:r>
-            <a:r>
-              <a:rPr b="1">
-                <a:solidFill>
-                  <a:srgbClr val="007020"/>
-                </a:solidFill>
-                <a:latin typeface="Courier"/>
-              </a:rPr>
-              <a:t>return</a:t>
-            </a:r>
-            <a:r>
-              <a:rPr>
-                <a:latin typeface="Courier"/>
-              </a:rPr>
-              <a:t> (dx </a:t>
-            </a:r>
-            <a:r>
-              <a:rPr>
-                <a:solidFill>
-                  <a:srgbClr val="666666"/>
-                </a:solidFill>
-                <a:latin typeface="Courier"/>
-              </a:rPr>
-              <a:t>**</a:t>
-            </a:r>
-            <a:r>
-              <a:rPr>
-                <a:latin typeface="Courier"/>
-              </a:rPr>
-              <a:t> </a:t>
-            </a:r>
-            <a:r>
-              <a:rPr>
-                <a:solidFill>
-                  <a:srgbClr val="40A070"/>
-                </a:solidFill>
-                <a:latin typeface="Courier"/>
-              </a:rPr>
-              <a:t>2</a:t>
-            </a:r>
-            <a:r>
-              <a:rPr>
-                <a:latin typeface="Courier"/>
-              </a:rPr>
-              <a:t> </a:t>
-            </a:r>
-            <a:r>
-              <a:rPr>
-                <a:solidFill>
-                  <a:srgbClr val="666666"/>
-                </a:solidFill>
-                <a:latin typeface="Courier"/>
-              </a:rPr>
-              <a:t>+</a:t>
-            </a:r>
-            <a:r>
-              <a:rPr>
-                <a:latin typeface="Courier"/>
-              </a:rPr>
-              <a:t> dy </a:t>
-            </a:r>
-            <a:r>
-              <a:rPr>
-                <a:solidFill>
-                  <a:srgbClr val="666666"/>
-                </a:solidFill>
-                <a:latin typeface="Courier"/>
-              </a:rPr>
-              <a:t>**</a:t>
-            </a:r>
-            <a:r>
-              <a:rPr>
-                <a:latin typeface="Courier"/>
-              </a:rPr>
-              <a:t> </a:t>
-            </a:r>
-            <a:r>
-              <a:rPr>
-                <a:solidFill>
-                  <a:srgbClr val="40A070"/>
-                </a:solidFill>
-                <a:latin typeface="Courier"/>
-              </a:rPr>
-              <a:t>2</a:t>
-            </a:r>
-            <a:r>
-              <a:rPr>
-                <a:latin typeface="Courier"/>
-              </a:rPr>
-              <a:t>) </a:t>
-            </a:r>
-            <a:r>
-              <a:rPr>
-                <a:solidFill>
-                  <a:srgbClr val="666666"/>
-                </a:solidFill>
-                <a:latin typeface="Courier"/>
-              </a:rPr>
-              <a:t>**</a:t>
-            </a:r>
-            <a:r>
-              <a:rPr>
-                <a:latin typeface="Courier"/>
-              </a:rPr>
-              <a:t> </a:t>
-            </a:r>
-            <a:r>
-              <a:rPr>
-                <a:solidFill>
-                  <a:srgbClr val="40A070"/>
-                </a:solidFill>
-                <a:latin typeface="Courier"/>
-              </a:rPr>
-              <a:t>0.5</a:t>
-            </a:r>
-          </a:p>
-        </p:txBody>
-      </p:sp>
-    </p:spTree>
-  </p:cSld>
-</p:sld>
-</file>
-
-<file path=ppt/slides/slide7.xml><?xml version="1.0" encoding="utf-8"?>
 <p:sld xmlns:a="http://schemas.openxmlformats.org/drawingml/2006/main" xmlns:r="http://schemas.openxmlformats.org/officeDocument/2006/relationships" xmlns:p="http://schemas.openxmlformats.org/presentationml/2006/main">
   <p:cSld>
     <p:spTree>
@@ -5793,7 +4776,7 @@
 </p:sld>
 </file>
 
-<file path=ppt/slides/slide8.xml><?xml version="1.0" encoding="utf-8"?>
+<file path=ppt/slides/slide15.xml><?xml version="1.0" encoding="utf-8"?>
 <p:sld xmlns:a="http://schemas.openxmlformats.org/drawingml/2006/main" xmlns:r="http://schemas.openxmlformats.org/officeDocument/2006/relationships" xmlns:p="http://schemas.openxmlformats.org/presentationml/2006/main">
   <p:cSld>
     <p:spTree>
@@ -5991,7 +4974,7 @@
 </p:sld>
 </file>
 
-<file path=ppt/slides/slide9.xml><?xml version="1.0" encoding="utf-8"?>
+<file path=ppt/slides/slide16.xml><?xml version="1.0" encoding="utf-8"?>
 <p:sld xmlns:a="http://schemas.openxmlformats.org/drawingml/2006/main" xmlns:r="http://schemas.openxmlformats.org/officeDocument/2006/relationships" xmlns:p="http://schemas.openxmlformats.org/presentationml/2006/main">
   <p:cSld>
     <p:spTree>
@@ -6214,6 +5197,1359 @@
           </a:graphicData>
         </a:graphic>
       </p:graphicFrame>
+    </p:spTree>
+  </p:cSld>
+</p:sld>
+</file>
+
+<file path=ppt/slides/slide17.xml><?xml version="1.0" encoding="utf-8"?>
+<p:sld xmlns:a="http://schemas.openxmlformats.org/drawingml/2006/main" xmlns:r="http://schemas.openxmlformats.org/officeDocument/2006/relationships" xmlns:p="http://schemas.openxmlformats.org/presentationml/2006/main">
+  <p:cSld>
+    <p:spTree>
+      <p:nvGrpSpPr>
+        <p:cNvPr id="1" name=""/>
+        <p:cNvGrpSpPr/>
+        <p:nvPr/>
+      </p:nvGrpSpPr>
+      <p:grpSpPr>
+        <a:xfrm>
+          <a:off x="0" y="0"/>
+          <a:ext cx="0" cy="0"/>
+          <a:chOff x="0" y="0"/>
+          <a:chExt cx="0" cy="0"/>
+        </a:xfrm>
+      </p:grpSpPr>
+      <p:sp>
+        <p:nvSpPr>
+          <p:cNvPr id="2" name="Title 1"/>
+          <p:cNvSpPr>
+            <a:spLocks noGrp="1"/>
+          </p:cNvSpPr>
+          <p:nvPr>
+            <p:ph type="title"/>
+          </p:nvPr>
+        </p:nvSpPr>
+        <p:spPr/>
+        <p:txBody>
+          <a:bodyPr/>
+          <a:lstStyle/>
+          <a:p>
+            <a:pPr lvl="0" indent="0" marL="0">
+              <a:buNone/>
+            </a:pPr>
+            <a:r>
+              <a:rPr/>
+              <a:t>Common first mistake</a:t>
+            </a:r>
+          </a:p>
+        </p:txBody>
+      </p:sp>
+      <p:sp>
+        <p:nvSpPr>
+          <p:cNvPr id="3" name="Content Placeholder 2"/>
+          <p:cNvSpPr>
+            <a:spLocks noGrp="1"/>
+          </p:cNvSpPr>
+          <p:nvPr>
+            <p:ph idx="1"/>
+          </p:nvPr>
+        </p:nvSpPr>
+        <p:spPr/>
+        <p:txBody>
+          <a:bodyPr/>
+          <a:lstStyle/>
+          <a:p>
+            <a:pPr lvl="0" indent="0">
+              <a:buNone/>
+            </a:pPr>
+            <a:r>
+              <a:rPr b="1">
+                <a:solidFill>
+                  <a:srgbClr val="007020"/>
+                </a:solidFill>
+                <a:latin typeface="Courier"/>
+              </a:rPr>
+              <a:t>class</a:t>
+            </a:r>
+            <a:r>
+              <a:rPr>
+                <a:latin typeface="Courier"/>
+              </a:rPr>
+              <a:t> Point:</a:t>
+            </a:r>
+            <a:br/>
+            <a:r>
+              <a:rPr>
+                <a:latin typeface="Courier"/>
+              </a:rPr>
+              <a:t>    </a:t>
+            </a:r>
+            <a:r>
+              <a:rPr b="1">
+                <a:solidFill>
+                  <a:srgbClr val="007020"/>
+                </a:solidFill>
+                <a:latin typeface="Courier"/>
+              </a:rPr>
+              <a:t>def</a:t>
+            </a:r>
+            <a:r>
+              <a:rPr>
+                <a:latin typeface="Courier"/>
+              </a:rPr>
+              <a:t> </a:t>
+            </a:r>
+            <a:r>
+              <a:rPr>
+                <a:solidFill>
+                  <a:srgbClr val="06287E"/>
+                </a:solidFill>
+                <a:latin typeface="Courier"/>
+              </a:rPr>
+              <a:t>__init__</a:t>
+            </a:r>
+            <a:r>
+              <a:rPr>
+                <a:latin typeface="Courier"/>
+              </a:rPr>
+              <a:t>(</a:t>
+            </a:r>
+            <a:r>
+              <a:rPr>
+                <a:solidFill>
+                  <a:srgbClr val="19177C"/>
+                </a:solidFill>
+                <a:latin typeface="Courier"/>
+              </a:rPr>
+              <a:t>self</a:t>
+            </a:r>
+            <a:r>
+              <a:rPr>
+                <a:latin typeface="Courier"/>
+              </a:rPr>
+              <a:t>, x, y):</a:t>
+            </a:r>
+            <a:br/>
+            <a:r>
+              <a:rPr>
+                <a:latin typeface="Courier"/>
+              </a:rPr>
+              <a:t>        x </a:t>
+            </a:r>
+            <a:r>
+              <a:rPr>
+                <a:solidFill>
+                  <a:srgbClr val="666666"/>
+                </a:solidFill>
+                <a:latin typeface="Courier"/>
+              </a:rPr>
+              <a:t>=</a:t>
+            </a:r>
+            <a:r>
+              <a:rPr>
+                <a:latin typeface="Courier"/>
+              </a:rPr>
+              <a:t> x        </a:t>
+            </a:r>
+            <a:r>
+              <a:rPr i="1">
+                <a:solidFill>
+                  <a:srgbClr val="60A0B0"/>
+                </a:solidFill>
+                <a:latin typeface="Courier"/>
+              </a:rPr>
+              <a:t># </a:t>
+            </a:r>
+            <a:r>
+              <a:rPr b="1">
+                <a:solidFill>
+                  <a:srgbClr val="FF0000"/>
+                </a:solidFill>
+                <a:latin typeface="Courier"/>
+              </a:rPr>
+              <a:t>BUG</a:t>
+            </a:r>
+            <a:r>
+              <a:rPr i="1">
+                <a:solidFill>
+                  <a:srgbClr val="60A0B0"/>
+                </a:solidFill>
+                <a:latin typeface="Courier"/>
+              </a:rPr>
+              <a:t>: assigns to the local parameter, not self.x</a:t>
+            </a:r>
+            <a:br/>
+            <a:r>
+              <a:rPr>
+                <a:latin typeface="Courier"/>
+              </a:rPr>
+              <a:t>        y </a:t>
+            </a:r>
+            <a:r>
+              <a:rPr>
+                <a:solidFill>
+                  <a:srgbClr val="666666"/>
+                </a:solidFill>
+                <a:latin typeface="Courier"/>
+              </a:rPr>
+              <a:t>=</a:t>
+            </a:r>
+            <a:r>
+              <a:rPr>
+                <a:latin typeface="Courier"/>
+              </a:rPr>
+              <a:t> y</a:t>
+            </a:r>
+            <a:br/>
+            <a:br/>
+            <a:r>
+              <a:rPr>
+                <a:latin typeface="Courier"/>
+              </a:rPr>
+              <a:t>p </a:t>
+            </a:r>
+            <a:r>
+              <a:rPr>
+                <a:solidFill>
+                  <a:srgbClr val="666666"/>
+                </a:solidFill>
+                <a:latin typeface="Courier"/>
+              </a:rPr>
+              <a:t>=</a:t>
+            </a:r>
+            <a:r>
+              <a:rPr>
+                <a:latin typeface="Courier"/>
+              </a:rPr>
+              <a:t> Point(</a:t>
+            </a:r>
+            <a:r>
+              <a:rPr>
+                <a:solidFill>
+                  <a:srgbClr val="40A070"/>
+                </a:solidFill>
+                <a:latin typeface="Courier"/>
+              </a:rPr>
+              <a:t>3</a:t>
+            </a:r>
+            <a:r>
+              <a:rPr>
+                <a:latin typeface="Courier"/>
+              </a:rPr>
+              <a:t>, </a:t>
+            </a:r>
+            <a:r>
+              <a:rPr>
+                <a:solidFill>
+                  <a:srgbClr val="40A070"/>
+                </a:solidFill>
+                <a:latin typeface="Courier"/>
+              </a:rPr>
+              <a:t>4</a:t>
+            </a:r>
+            <a:r>
+              <a:rPr>
+                <a:latin typeface="Courier"/>
+              </a:rPr>
+              <a:t>)</a:t>
+            </a:r>
+            <a:br/>
+            <a:r>
+              <a:rPr>
+                <a:solidFill>
+                  <a:srgbClr val="008000"/>
+                </a:solidFill>
+                <a:latin typeface="Courier"/>
+              </a:rPr>
+              <a:t>print</a:t>
+            </a:r>
+            <a:r>
+              <a:rPr>
+                <a:latin typeface="Courier"/>
+              </a:rPr>
+              <a:t>(p.x)   </a:t>
+            </a:r>
+            <a:r>
+              <a:rPr i="1">
+                <a:solidFill>
+                  <a:srgbClr val="60A0B0"/>
+                </a:solidFill>
+                <a:latin typeface="Courier"/>
+              </a:rPr>
+              <a:t># AttributeError: 'Point' object has no attribute 'x'</a:t>
+            </a:r>
+          </a:p>
+        </p:txBody>
+      </p:sp>
+    </p:spTree>
+  </p:cSld>
+</p:sld>
+</file>
+
+<file path=ppt/slides/slide18.xml><?xml version="1.0" encoding="utf-8"?>
+<p:sld xmlns:a="http://schemas.openxmlformats.org/drawingml/2006/main" xmlns:r="http://schemas.openxmlformats.org/officeDocument/2006/relationships" xmlns:p="http://schemas.openxmlformats.org/presentationml/2006/main">
+  <p:cSld>
+    <p:spTree>
+      <p:nvGrpSpPr>
+        <p:cNvPr id="1" name=""/>
+        <p:cNvGrpSpPr/>
+        <p:nvPr/>
+      </p:nvGrpSpPr>
+      <p:grpSpPr>
+        <a:xfrm>
+          <a:off x="0" y="0"/>
+          <a:ext cx="0" cy="0"/>
+          <a:chOff x="0" y="0"/>
+          <a:chExt cx="0" cy="0"/>
+        </a:xfrm>
+      </p:grpSpPr>
+      <p:sp>
+        <p:nvSpPr>
+          <p:cNvPr id="2" name="Title 1"/>
+          <p:cNvSpPr>
+            <a:spLocks noGrp="1"/>
+          </p:cNvSpPr>
+          <p:nvPr>
+            <p:ph type="title"/>
+          </p:nvPr>
+        </p:nvSpPr>
+        <p:spPr/>
+        <p:txBody>
+          <a:bodyPr/>
+          <a:lstStyle/>
+          <a:p>
+            <a:pPr lvl="0" indent="0" marL="0">
+              <a:buNone/>
+            </a:pPr>
+            <a:r>
+              <a:rPr/>
+              <a:t>Live coding exercise (5 minutes)</a:t>
+            </a:r>
+          </a:p>
+        </p:txBody>
+      </p:sp>
+      <p:sp>
+        <p:nvSpPr>
+          <p:cNvPr id="3" name="Content Placeholder 2"/>
+          <p:cNvSpPr>
+            <a:spLocks noGrp="1"/>
+          </p:cNvSpPr>
+          <p:nvPr>
+            <p:ph idx="1"/>
+          </p:nvPr>
+        </p:nvSpPr>
+        <p:spPr/>
+        <p:txBody>
+          <a:bodyPr/>
+          <a:lstStyle/>
+          <a:p>
+            <a:pPr lvl="0" indent="0">
+              <a:buNone/>
+            </a:pPr>
+            <a:r>
+              <a:rPr b="1">
+                <a:solidFill>
+                  <a:srgbClr val="007020"/>
+                </a:solidFill>
+                <a:latin typeface="Courier"/>
+              </a:rPr>
+              <a:t>def</a:t>
+            </a:r>
+            <a:r>
+              <a:rPr>
+                <a:latin typeface="Courier"/>
+              </a:rPr>
+              <a:t> midpoint(</a:t>
+            </a:r>
+            <a:r>
+              <a:rPr>
+                <a:solidFill>
+                  <a:srgbClr val="19177C"/>
+                </a:solidFill>
+                <a:latin typeface="Courier"/>
+              </a:rPr>
+              <a:t>self</a:t>
+            </a:r>
+            <a:r>
+              <a:rPr>
+                <a:latin typeface="Courier"/>
+              </a:rPr>
+              <a:t>, other):</a:t>
+            </a:r>
+            <a:br/>
+            <a:r>
+              <a:rPr>
+                <a:latin typeface="Courier"/>
+              </a:rPr>
+              <a:t>    </a:t>
+            </a:r>
+            <a:r>
+              <a:rPr b="1">
+                <a:solidFill>
+                  <a:srgbClr val="007020"/>
+                </a:solidFill>
+                <a:latin typeface="Courier"/>
+              </a:rPr>
+              <a:t>return</a:t>
+            </a:r>
+            <a:r>
+              <a:rPr>
+                <a:latin typeface="Courier"/>
+              </a:rPr>
+              <a:t> Point((</a:t>
+            </a:r>
+            <a:r>
+              <a:rPr>
+                <a:solidFill>
+                  <a:srgbClr val="19177C"/>
+                </a:solidFill>
+                <a:latin typeface="Courier"/>
+              </a:rPr>
+              <a:t>self</a:t>
+            </a:r>
+            <a:r>
+              <a:rPr>
+                <a:latin typeface="Courier"/>
+              </a:rPr>
+              <a:t>.x </a:t>
+            </a:r>
+            <a:r>
+              <a:rPr>
+                <a:solidFill>
+                  <a:srgbClr val="666666"/>
+                </a:solidFill>
+                <a:latin typeface="Courier"/>
+              </a:rPr>
+              <a:t>+</a:t>
+            </a:r>
+            <a:r>
+              <a:rPr>
+                <a:latin typeface="Courier"/>
+              </a:rPr>
+              <a:t> other.x) </a:t>
+            </a:r>
+            <a:r>
+              <a:rPr>
+                <a:solidFill>
+                  <a:srgbClr val="666666"/>
+                </a:solidFill>
+                <a:latin typeface="Courier"/>
+              </a:rPr>
+              <a:t>/</a:t>
+            </a:r>
+            <a:r>
+              <a:rPr>
+                <a:latin typeface="Courier"/>
+              </a:rPr>
+              <a:t> </a:t>
+            </a:r>
+            <a:r>
+              <a:rPr>
+                <a:solidFill>
+                  <a:srgbClr val="40A070"/>
+                </a:solidFill>
+                <a:latin typeface="Courier"/>
+              </a:rPr>
+              <a:t>2</a:t>
+            </a:r>
+            <a:r>
+              <a:rPr>
+                <a:latin typeface="Courier"/>
+              </a:rPr>
+              <a:t>,</a:t>
+            </a:r>
+            <a:br/>
+            <a:r>
+              <a:rPr>
+                <a:latin typeface="Courier"/>
+              </a:rPr>
+              <a:t>                  (</a:t>
+            </a:r>
+            <a:r>
+              <a:rPr>
+                <a:solidFill>
+                  <a:srgbClr val="19177C"/>
+                </a:solidFill>
+                <a:latin typeface="Courier"/>
+              </a:rPr>
+              <a:t>self</a:t>
+            </a:r>
+            <a:r>
+              <a:rPr>
+                <a:latin typeface="Courier"/>
+              </a:rPr>
+              <a:t>.y </a:t>
+            </a:r>
+            <a:r>
+              <a:rPr>
+                <a:solidFill>
+                  <a:srgbClr val="666666"/>
+                </a:solidFill>
+                <a:latin typeface="Courier"/>
+              </a:rPr>
+              <a:t>+</a:t>
+            </a:r>
+            <a:r>
+              <a:rPr>
+                <a:latin typeface="Courier"/>
+              </a:rPr>
+              <a:t> other.y) </a:t>
+            </a:r>
+            <a:r>
+              <a:rPr>
+                <a:solidFill>
+                  <a:srgbClr val="666666"/>
+                </a:solidFill>
+                <a:latin typeface="Courier"/>
+              </a:rPr>
+              <a:t>/</a:t>
+            </a:r>
+            <a:r>
+              <a:rPr>
+                <a:latin typeface="Courier"/>
+              </a:rPr>
+              <a:t> </a:t>
+            </a:r>
+            <a:r>
+              <a:rPr>
+                <a:solidFill>
+                  <a:srgbClr val="40A070"/>
+                </a:solidFill>
+                <a:latin typeface="Courier"/>
+              </a:rPr>
+              <a:t>2</a:t>
+            </a:r>
+            <a:r>
+              <a:rPr>
+                <a:latin typeface="Courier"/>
+              </a:rPr>
+              <a:t>)</a:t>
+            </a:r>
+          </a:p>
+        </p:txBody>
+      </p:sp>
+    </p:spTree>
+  </p:cSld>
+</p:sld>
+</file>
+
+<file path=ppt/slides/slide19.xml><?xml version="1.0" encoding="utf-8"?>
+<p:sld xmlns:a="http://schemas.openxmlformats.org/drawingml/2006/main" xmlns:r="http://schemas.openxmlformats.org/officeDocument/2006/relationships" xmlns:p="http://schemas.openxmlformats.org/presentationml/2006/main">
+  <p:cSld>
+    <p:spTree>
+      <p:nvGrpSpPr>
+        <p:cNvPr id="1" name=""/>
+        <p:cNvGrpSpPr/>
+        <p:nvPr/>
+      </p:nvGrpSpPr>
+      <p:grpSpPr>
+        <a:xfrm>
+          <a:off x="0" y="0"/>
+          <a:ext cx="0" cy="0"/>
+          <a:chOff x="0" y="0"/>
+          <a:chExt cx="0" cy="0"/>
+        </a:xfrm>
+      </p:grpSpPr>
+      <p:sp>
+        <p:nvSpPr>
+          <p:cNvPr id="2" name="Title 1"/>
+          <p:cNvSpPr>
+            <a:spLocks noGrp="1"/>
+          </p:cNvSpPr>
+          <p:nvPr>
+            <p:ph type="title"/>
+          </p:nvPr>
+        </p:nvSpPr>
+        <p:spPr/>
+        <p:txBody>
+          <a:bodyPr/>
+          <a:lstStyle/>
+          <a:p>
+            <a:pPr lvl="0" indent="0" marL="0">
+              <a:buNone/>
+            </a:pPr>
+            <a:r>
+              <a:rPr/>
+              <a:t>Quiz — spot the bug</a:t>
+            </a:r>
+          </a:p>
+        </p:txBody>
+      </p:sp>
+      <p:sp>
+        <p:nvSpPr>
+          <p:cNvPr id="3" name="Content Placeholder 2"/>
+          <p:cNvSpPr>
+            <a:spLocks noGrp="1"/>
+          </p:cNvSpPr>
+          <p:nvPr>
+            <p:ph idx="1"/>
+          </p:nvPr>
+        </p:nvSpPr>
+        <p:spPr/>
+        <p:txBody>
+          <a:bodyPr/>
+          <a:lstStyle/>
+          <a:p>
+            <a:pPr lvl="0" indent="0">
+              <a:buNone/>
+            </a:pPr>
+            <a:r>
+              <a:rPr b="1">
+                <a:solidFill>
+                  <a:srgbClr val="007020"/>
+                </a:solidFill>
+                <a:latin typeface="Courier"/>
+              </a:rPr>
+              <a:t>class</a:t>
+            </a:r>
+            <a:r>
+              <a:rPr>
+                <a:latin typeface="Courier"/>
+              </a:rPr>
+              <a:t> Rectangle:</a:t>
+            </a:r>
+            <a:br/>
+            <a:r>
+              <a:rPr>
+                <a:latin typeface="Courier"/>
+              </a:rPr>
+              <a:t>    </a:t>
+            </a:r>
+            <a:r>
+              <a:rPr b="1">
+                <a:solidFill>
+                  <a:srgbClr val="007020"/>
+                </a:solidFill>
+                <a:latin typeface="Courier"/>
+              </a:rPr>
+              <a:t>def</a:t>
+            </a:r>
+            <a:r>
+              <a:rPr>
+                <a:latin typeface="Courier"/>
+              </a:rPr>
+              <a:t> </a:t>
+            </a:r>
+            <a:r>
+              <a:rPr>
+                <a:solidFill>
+                  <a:srgbClr val="06287E"/>
+                </a:solidFill>
+                <a:latin typeface="Courier"/>
+              </a:rPr>
+              <a:t>__init__</a:t>
+            </a:r>
+            <a:r>
+              <a:rPr>
+                <a:latin typeface="Courier"/>
+              </a:rPr>
+              <a:t>(</a:t>
+            </a:r>
+            <a:r>
+              <a:rPr>
+                <a:solidFill>
+                  <a:srgbClr val="19177C"/>
+                </a:solidFill>
+                <a:latin typeface="Courier"/>
+              </a:rPr>
+              <a:t>self</a:t>
+            </a:r>
+            <a:r>
+              <a:rPr>
+                <a:latin typeface="Courier"/>
+              </a:rPr>
+              <a:t>, w, h):</a:t>
+            </a:r>
+            <a:br/>
+            <a:r>
+              <a:rPr>
+                <a:latin typeface="Courier"/>
+              </a:rPr>
+              <a:t>        w </a:t>
+            </a:r>
+            <a:r>
+              <a:rPr>
+                <a:solidFill>
+                  <a:srgbClr val="666666"/>
+                </a:solidFill>
+                <a:latin typeface="Courier"/>
+              </a:rPr>
+              <a:t>=</a:t>
+            </a:r>
+            <a:r>
+              <a:rPr>
+                <a:latin typeface="Courier"/>
+              </a:rPr>
+              <a:t> w</a:t>
+            </a:r>
+            <a:br/>
+            <a:r>
+              <a:rPr>
+                <a:latin typeface="Courier"/>
+              </a:rPr>
+              <a:t>        h </a:t>
+            </a:r>
+            <a:r>
+              <a:rPr>
+                <a:solidFill>
+                  <a:srgbClr val="666666"/>
+                </a:solidFill>
+                <a:latin typeface="Courier"/>
+              </a:rPr>
+              <a:t>=</a:t>
+            </a:r>
+            <a:r>
+              <a:rPr>
+                <a:latin typeface="Courier"/>
+              </a:rPr>
+              <a:t> h</a:t>
+            </a:r>
+            <a:br/>
+            <a:r>
+              <a:rPr>
+                <a:latin typeface="Courier"/>
+              </a:rPr>
+              <a:t>    </a:t>
+            </a:r>
+            <a:r>
+              <a:rPr b="1">
+                <a:solidFill>
+                  <a:srgbClr val="007020"/>
+                </a:solidFill>
+                <a:latin typeface="Courier"/>
+              </a:rPr>
+              <a:t>def</a:t>
+            </a:r>
+            <a:r>
+              <a:rPr>
+                <a:latin typeface="Courier"/>
+              </a:rPr>
+              <a:t> area(</a:t>
+            </a:r>
+            <a:r>
+              <a:rPr>
+                <a:solidFill>
+                  <a:srgbClr val="19177C"/>
+                </a:solidFill>
+                <a:latin typeface="Courier"/>
+              </a:rPr>
+              <a:t>self</a:t>
+            </a:r>
+            <a:r>
+              <a:rPr>
+                <a:latin typeface="Courier"/>
+              </a:rPr>
+              <a:t>):</a:t>
+            </a:r>
+            <a:br/>
+            <a:r>
+              <a:rPr>
+                <a:latin typeface="Courier"/>
+              </a:rPr>
+              <a:t>        </a:t>
+            </a:r>
+            <a:r>
+              <a:rPr b="1">
+                <a:solidFill>
+                  <a:srgbClr val="007020"/>
+                </a:solidFill>
+                <a:latin typeface="Courier"/>
+              </a:rPr>
+              <a:t>return</a:t>
+            </a:r>
+            <a:r>
+              <a:rPr>
+                <a:latin typeface="Courier"/>
+              </a:rPr>
+              <a:t> </a:t>
+            </a:r>
+            <a:r>
+              <a:rPr>
+                <a:solidFill>
+                  <a:srgbClr val="19177C"/>
+                </a:solidFill>
+                <a:latin typeface="Courier"/>
+              </a:rPr>
+              <a:t>self</a:t>
+            </a:r>
+            <a:r>
+              <a:rPr>
+                <a:latin typeface="Courier"/>
+              </a:rPr>
+              <a:t>.w </a:t>
+            </a:r>
+            <a:r>
+              <a:rPr>
+                <a:solidFill>
+                  <a:srgbClr val="666666"/>
+                </a:solidFill>
+                <a:latin typeface="Courier"/>
+              </a:rPr>
+              <a:t>*</a:t>
+            </a:r>
+            <a:r>
+              <a:rPr>
+                <a:latin typeface="Courier"/>
+              </a:rPr>
+              <a:t> </a:t>
+            </a:r>
+            <a:r>
+              <a:rPr>
+                <a:solidFill>
+                  <a:srgbClr val="19177C"/>
+                </a:solidFill>
+                <a:latin typeface="Courier"/>
+              </a:rPr>
+              <a:t>self</a:t>
+            </a:r>
+            <a:r>
+              <a:rPr>
+                <a:latin typeface="Courier"/>
+              </a:rPr>
+              <a:t>.h</a:t>
+            </a:r>
+            <a:br/>
+            <a:br/>
+            <a:r>
+              <a:rPr>
+                <a:latin typeface="Courier"/>
+              </a:rPr>
+              <a:t>r </a:t>
+            </a:r>
+            <a:r>
+              <a:rPr>
+                <a:solidFill>
+                  <a:srgbClr val="666666"/>
+                </a:solidFill>
+                <a:latin typeface="Courier"/>
+              </a:rPr>
+              <a:t>=</a:t>
+            </a:r>
+            <a:r>
+              <a:rPr>
+                <a:latin typeface="Courier"/>
+              </a:rPr>
+              <a:t> Rectangle(</a:t>
+            </a:r>
+            <a:r>
+              <a:rPr>
+                <a:solidFill>
+                  <a:srgbClr val="40A070"/>
+                </a:solidFill>
+                <a:latin typeface="Courier"/>
+              </a:rPr>
+              <a:t>4</a:t>
+            </a:r>
+            <a:r>
+              <a:rPr>
+                <a:latin typeface="Courier"/>
+              </a:rPr>
+              <a:t>, </a:t>
+            </a:r>
+            <a:r>
+              <a:rPr>
+                <a:solidFill>
+                  <a:srgbClr val="40A070"/>
+                </a:solidFill>
+                <a:latin typeface="Courier"/>
+              </a:rPr>
+              <a:t>5</a:t>
+            </a:r>
+            <a:r>
+              <a:rPr>
+                <a:latin typeface="Courier"/>
+              </a:rPr>
+              <a:t>)</a:t>
+            </a:r>
+            <a:br/>
+            <a:r>
+              <a:rPr>
+                <a:solidFill>
+                  <a:srgbClr val="008000"/>
+                </a:solidFill>
+                <a:latin typeface="Courier"/>
+              </a:rPr>
+              <a:t>print</a:t>
+            </a:r>
+            <a:r>
+              <a:rPr>
+                <a:latin typeface="Courier"/>
+              </a:rPr>
+              <a:t>(r.area())</a:t>
+            </a:r>
+          </a:p>
+        </p:txBody>
+      </p:sp>
+    </p:spTree>
+  </p:cSld>
+</p:sld>
+</file>
+
+<file path=ppt/slides/slide2.xml><?xml version="1.0" encoding="utf-8"?>
+<p:sld xmlns:a="http://schemas.openxmlformats.org/drawingml/2006/main" xmlns:r="http://schemas.openxmlformats.org/officeDocument/2006/relationships" xmlns:p="http://schemas.openxmlformats.org/presentationml/2006/main">
+  <p:cSld>
+    <p:spTree>
+      <p:nvGrpSpPr>
+        <p:cNvPr id="1" name=""/>
+        <p:cNvGrpSpPr/>
+        <p:nvPr/>
+      </p:nvGrpSpPr>
+      <p:grpSpPr>
+        <a:xfrm>
+          <a:off x="0" y="0"/>
+          <a:ext cx="0" cy="0"/>
+          <a:chOff x="0" y="0"/>
+          <a:chExt cx="0" cy="0"/>
+        </a:xfrm>
+      </p:grpSpPr>
+      <p:sp>
+        <p:nvSpPr>
+          <p:cNvPr id="2" name="Title 1"/>
+          <p:cNvSpPr>
+            <a:spLocks noGrp="1"/>
+          </p:cNvSpPr>
+          <p:nvPr>
+            <p:ph type="title"/>
+          </p:nvPr>
+        </p:nvSpPr>
+        <p:spPr/>
+        <p:txBody>
+          <a:bodyPr/>
+          <a:lstStyle/>
+          <a:p>
+            <a:pPr lvl="0" indent="0" marL="0">
+              <a:buNone/>
+            </a:pPr>
+            <a:r>
+              <a:rPr/>
+              <a:t>Welcome to Programming and Data Structures</a:t>
+            </a:r>
+          </a:p>
+        </p:txBody>
+      </p:sp>
+    </p:spTree>
+  </p:cSld>
+</p:sld>
+</file>
+
+<file path=ppt/slides/slide20.xml><?xml version="1.0" encoding="utf-8"?>
+<p:sld xmlns:a="http://schemas.openxmlformats.org/drawingml/2006/main" xmlns:r="http://schemas.openxmlformats.org/officeDocument/2006/relationships" xmlns:p="http://schemas.openxmlformats.org/presentationml/2006/main">
+  <p:cSld>
+    <p:spTree>
+      <p:nvGrpSpPr>
+        <p:cNvPr id="1" name=""/>
+        <p:cNvGrpSpPr/>
+        <p:nvPr/>
+      </p:nvGrpSpPr>
+      <p:grpSpPr>
+        <a:xfrm>
+          <a:off x="0" y="0"/>
+          <a:ext cx="0" cy="0"/>
+          <a:chOff x="0" y="0"/>
+          <a:chExt cx="0" cy="0"/>
+        </a:xfrm>
+      </p:grpSpPr>
+      <p:sp>
+        <p:nvSpPr>
+          <p:cNvPr id="2" name="Title 1"/>
+          <p:cNvSpPr>
+            <a:spLocks noGrp="1"/>
+          </p:cNvSpPr>
+          <p:nvPr>
+            <p:ph type="title"/>
+          </p:nvPr>
+        </p:nvSpPr>
+        <p:spPr/>
+        <p:txBody>
+          <a:bodyPr/>
+          <a:lstStyle/>
+          <a:p>
+            <a:pPr lvl="0" indent="0" marL="0">
+              <a:buNone/>
+            </a:pPr>
+            <a:r>
+              <a:rPr/>
+              <a:t>Quiz — answer</a:t>
+            </a:r>
+          </a:p>
+        </p:txBody>
+      </p:sp>
+    </p:spTree>
+  </p:cSld>
+</p:sld>
+</file>
+
+<file path=ppt/slides/slide21.xml><?xml version="1.0" encoding="utf-8"?>
+<p:sld xmlns:a="http://schemas.openxmlformats.org/drawingml/2006/main" xmlns:r="http://schemas.openxmlformats.org/officeDocument/2006/relationships" xmlns:p="http://schemas.openxmlformats.org/presentationml/2006/main">
+  <p:cSld>
+    <p:spTree>
+      <p:nvGrpSpPr>
+        <p:cNvPr id="1" name=""/>
+        <p:cNvGrpSpPr/>
+        <p:nvPr/>
+      </p:nvGrpSpPr>
+      <p:grpSpPr>
+        <a:xfrm>
+          <a:off x="0" y="0"/>
+          <a:ext cx="0" cy="0"/>
+          <a:chOff x="0" y="0"/>
+          <a:chExt cx="0" cy="0"/>
+        </a:xfrm>
+      </p:grpSpPr>
+      <p:sp>
+        <p:nvSpPr>
+          <p:cNvPr id="2" name="Title 1"/>
+          <p:cNvSpPr>
+            <a:spLocks noGrp="1"/>
+          </p:cNvSpPr>
+          <p:nvPr>
+            <p:ph type="title"/>
+          </p:nvPr>
+        </p:nvSpPr>
+        <p:spPr/>
+        <p:txBody>
+          <a:bodyPr/>
+          <a:lstStyle/>
+          <a:p>
+            <a:pPr lvl="0" indent="0" marL="0">
+              <a:buNone/>
+            </a:pPr>
+            <a:r>
+              <a:rPr/>
+              <a:t>Summary</a:t>
+            </a:r>
+          </a:p>
+        </p:txBody>
+      </p:sp>
+    </p:spTree>
+  </p:cSld>
+</p:sld>
+</file>
+
+<file path=ppt/slides/slide3.xml><?xml version="1.0" encoding="utf-8"?>
+<p:sld xmlns:a="http://schemas.openxmlformats.org/drawingml/2006/main" xmlns:r="http://schemas.openxmlformats.org/officeDocument/2006/relationships" xmlns:p="http://schemas.openxmlformats.org/presentationml/2006/main">
+  <p:cSld>
+    <p:spTree>
+      <p:nvGrpSpPr>
+        <p:cNvPr id="1" name=""/>
+        <p:cNvGrpSpPr/>
+        <p:nvPr/>
+      </p:nvGrpSpPr>
+      <p:grpSpPr>
+        <a:xfrm>
+          <a:off x="0" y="0"/>
+          <a:ext cx="0" cy="0"/>
+          <a:chOff x="0" y="0"/>
+          <a:chExt cx="0" cy="0"/>
+        </a:xfrm>
+      </p:grpSpPr>
+      <p:sp>
+        <p:nvSpPr>
+          <p:cNvPr id="2" name="Title 1"/>
+          <p:cNvSpPr>
+            <a:spLocks noGrp="1"/>
+          </p:cNvSpPr>
+          <p:nvPr>
+            <p:ph type="title"/>
+          </p:nvPr>
+        </p:nvSpPr>
+        <p:spPr/>
+        <p:txBody>
+          <a:bodyPr/>
+          <a:lstStyle/>
+          <a:p>
+            <a:pPr lvl="0" indent="0" marL="0">
+              <a:buNone/>
+            </a:pPr>
+            <a:r>
+              <a:rPr/>
+              <a:t>What you will be able to do by January</a:t>
+            </a:r>
+          </a:p>
+        </p:txBody>
+      </p:sp>
+    </p:spTree>
+  </p:cSld>
+</p:sld>
+</file>
+
+<file path=ppt/slides/slide4.xml><?xml version="1.0" encoding="utf-8"?>
+<p:sld xmlns:a="http://schemas.openxmlformats.org/drawingml/2006/main" xmlns:r="http://schemas.openxmlformats.org/officeDocument/2006/relationships" xmlns:p="http://schemas.openxmlformats.org/presentationml/2006/main">
+  <p:cSld>
+    <p:spTree>
+      <p:nvGrpSpPr>
+        <p:cNvPr id="1" name=""/>
+        <p:cNvGrpSpPr/>
+        <p:nvPr/>
+      </p:nvGrpSpPr>
+      <p:grpSpPr>
+        <a:xfrm>
+          <a:off x="0" y="0"/>
+          <a:ext cx="0" cy="0"/>
+          <a:chOff x="0" y="0"/>
+          <a:chExt cx="0" cy="0"/>
+        </a:xfrm>
+      </p:grpSpPr>
+      <p:sp>
+        <p:nvSpPr>
+          <p:cNvPr id="2" name="Title 1"/>
+          <p:cNvSpPr>
+            <a:spLocks noGrp="1"/>
+          </p:cNvSpPr>
+          <p:nvPr>
+            <p:ph type="title"/>
+          </p:nvPr>
+        </p:nvSpPr>
+        <p:spPr/>
+        <p:txBody>
+          <a:bodyPr/>
+          <a:lstStyle/>
+          <a:p>
+            <a:pPr lvl="0" indent="0" marL="0">
+              <a:buNone/>
+            </a:pPr>
+            <a:r>
+              <a:rPr/>
+              <a:t>The 15-week roadmap</a:t>
+            </a:r>
+          </a:p>
+        </p:txBody>
+      </p:sp>
+    </p:spTree>
+  </p:cSld>
+</p:sld>
+</file>
+
+<file path=ppt/slides/slide5.xml><?xml version="1.0" encoding="utf-8"?>
+<p:sld xmlns:a="http://schemas.openxmlformats.org/drawingml/2006/main" xmlns:r="http://schemas.openxmlformats.org/officeDocument/2006/relationships" xmlns:p="http://schemas.openxmlformats.org/presentationml/2006/main">
+  <p:cSld>
+    <p:spTree>
+      <p:nvGrpSpPr>
+        <p:cNvPr id="1" name=""/>
+        <p:cNvGrpSpPr/>
+        <p:nvPr/>
+      </p:nvGrpSpPr>
+      <p:grpSpPr>
+        <a:xfrm>
+          <a:off x="0" y="0"/>
+          <a:ext cx="0" cy="0"/>
+          <a:chOff x="0" y="0"/>
+          <a:chExt cx="0" cy="0"/>
+        </a:xfrm>
+      </p:grpSpPr>
+      <p:sp>
+        <p:nvSpPr>
+          <p:cNvPr id="2" name="Title 1"/>
+          <p:cNvSpPr>
+            <a:spLocks noGrp="1"/>
+          </p:cNvSpPr>
+          <p:nvPr>
+            <p:ph type="title"/>
+          </p:nvPr>
+        </p:nvSpPr>
+        <p:spPr/>
+        <p:txBody>
+          <a:bodyPr/>
+          <a:lstStyle/>
+          <a:p>
+            <a:pPr lvl="0" indent="0" marL="0">
+              <a:buNone/>
+            </a:pPr>
+            <a:r>
+              <a:rPr/>
+              <a:t>The 15-week roadmap, continued</a:t>
+            </a:r>
+          </a:p>
+        </p:txBody>
+      </p:sp>
+    </p:spTree>
+  </p:cSld>
+</p:sld>
+</file>
+
+<file path=ppt/slides/slide6.xml><?xml version="1.0" encoding="utf-8"?>
+<p:sld xmlns:a="http://schemas.openxmlformats.org/drawingml/2006/main" xmlns:r="http://schemas.openxmlformats.org/officeDocument/2006/relationships" xmlns:p="http://schemas.openxmlformats.org/presentationml/2006/main">
+  <p:cSld>
+    <p:spTree>
+      <p:nvGrpSpPr>
+        <p:cNvPr id="1" name=""/>
+        <p:cNvGrpSpPr/>
+        <p:nvPr/>
+      </p:nvGrpSpPr>
+      <p:grpSpPr>
+        <a:xfrm>
+          <a:off x="0" y="0"/>
+          <a:ext cx="0" cy="0"/>
+          <a:chOff x="0" y="0"/>
+          <a:chExt cx="0" cy="0"/>
+        </a:xfrm>
+      </p:grpSpPr>
+      <p:sp>
+        <p:nvSpPr>
+          <p:cNvPr id="2" name="Title 1"/>
+          <p:cNvSpPr>
+            <a:spLocks noGrp="1"/>
+          </p:cNvSpPr>
+          <p:nvPr>
+            <p:ph type="title"/>
+          </p:nvPr>
+        </p:nvSpPr>
+        <p:spPr/>
+        <p:txBody>
+          <a:bodyPr/>
+          <a:lstStyle/>
+          <a:p>
+            <a:pPr lvl="0" indent="0" marL="0">
+              <a:buNone/>
+            </a:pPr>
+            <a:r>
+              <a:rPr/>
+              <a:t>How your grade is composed</a:t>
+            </a:r>
+          </a:p>
+        </p:txBody>
+      </p:sp>
+    </p:spTree>
+  </p:cSld>
+</p:sld>
+</file>
+
+<file path=ppt/slides/slide7.xml><?xml version="1.0" encoding="utf-8"?>
+<p:sld xmlns:a="http://schemas.openxmlformats.org/drawingml/2006/main" xmlns:r="http://schemas.openxmlformats.org/officeDocument/2006/relationships" xmlns:p="http://schemas.openxmlformats.org/presentationml/2006/main">
+  <p:cSld>
+    <p:spTree>
+      <p:nvGrpSpPr>
+        <p:cNvPr id="1" name=""/>
+        <p:cNvGrpSpPr/>
+        <p:nvPr/>
+      </p:nvGrpSpPr>
+      <p:grpSpPr>
+        <a:xfrm>
+          <a:off x="0" y="0"/>
+          <a:ext cx="0" cy="0"/>
+          <a:chOff x="0" y="0"/>
+          <a:chExt cx="0" cy="0"/>
+        </a:xfrm>
+      </p:grpSpPr>
+      <p:sp>
+        <p:nvSpPr>
+          <p:cNvPr id="2" name="Title 1"/>
+          <p:cNvSpPr>
+            <a:spLocks noGrp="1"/>
+          </p:cNvSpPr>
+          <p:nvPr>
+            <p:ph type="title"/>
+          </p:nvPr>
+        </p:nvSpPr>
+        <p:spPr/>
+        <p:txBody>
+          <a:bodyPr/>
+          <a:lstStyle/>
+          <a:p>
+            <a:pPr lvl="0" indent="0" marL="0">
+              <a:buNone/>
+            </a:pPr>
+            <a:r>
+              <a:rPr/>
+              <a:t>Textbooks and how to use them</a:t>
+            </a:r>
+          </a:p>
+        </p:txBody>
+      </p:sp>
+    </p:spTree>
+  </p:cSld>
+</p:sld>
+</file>
+
+<file path=ppt/slides/slide8.xml><?xml version="1.0" encoding="utf-8"?>
+<p:sld xmlns:a="http://schemas.openxmlformats.org/drawingml/2006/main" xmlns:r="http://schemas.openxmlformats.org/officeDocument/2006/relationships" xmlns:p="http://schemas.openxmlformats.org/presentationml/2006/main">
+  <p:cSld>
+    <p:spTree>
+      <p:nvGrpSpPr>
+        <p:cNvPr id="1" name=""/>
+        <p:cNvGrpSpPr/>
+        <p:nvPr/>
+      </p:nvGrpSpPr>
+      <p:grpSpPr>
+        <a:xfrm>
+          <a:off x="0" y="0"/>
+          <a:ext cx="0" cy="0"/>
+          <a:chOff x="0" y="0"/>
+          <a:chExt cx="0" cy="0"/>
+        </a:xfrm>
+      </p:grpSpPr>
+      <p:sp>
+        <p:nvSpPr>
+          <p:cNvPr id="2" name="Title 1"/>
+          <p:cNvSpPr>
+            <a:spLocks noGrp="1"/>
+          </p:cNvSpPr>
+          <p:nvPr>
+            <p:ph type="title"/>
+          </p:nvPr>
+        </p:nvSpPr>
+        <p:spPr/>
+        <p:txBody>
+          <a:bodyPr/>
+          <a:lstStyle/>
+          <a:p>
+            <a:pPr lvl="0" indent="0" marL="0">
+              <a:buNone/>
+            </a:pPr>
+            <a:r>
+              <a:rPr/>
+              <a:t>Policies you need to know from day one</a:t>
+            </a:r>
+          </a:p>
+        </p:txBody>
+      </p:sp>
+    </p:spTree>
+  </p:cSld>
+</p:sld>
+</file>
+
+<file path=ppt/slides/slide9.xml><?xml version="1.0" encoding="utf-8"?>
+<p:sld xmlns:a="http://schemas.openxmlformats.org/drawingml/2006/main" xmlns:r="http://schemas.openxmlformats.org/officeDocument/2006/relationships" xmlns:p="http://schemas.openxmlformats.org/presentationml/2006/main">
+  <p:cSld>
+    <p:spTree>
+      <p:nvGrpSpPr>
+        <p:cNvPr id="1" name=""/>
+        <p:cNvGrpSpPr/>
+        <p:nvPr/>
+      </p:nvGrpSpPr>
+      <p:grpSpPr>
+        <a:xfrm>
+          <a:off x="0" y="0"/>
+          <a:ext cx="0" cy="0"/>
+          <a:chOff x="0" y="0"/>
+          <a:chExt cx="0" cy="0"/>
+        </a:xfrm>
+      </p:grpSpPr>
+      <p:sp>
+        <p:nvSpPr>
+          <p:cNvPr id="2" name="Title 1"/>
+          <p:cNvSpPr>
+            <a:spLocks noGrp="1"/>
+          </p:cNvSpPr>
+          <p:nvPr>
+            <p:ph type="title"/>
+          </p:nvPr>
+        </p:nvSpPr>
+        <p:spPr/>
+        <p:txBody>
+          <a:bodyPr/>
+          <a:lstStyle/>
+          <a:p>
+            <a:pPr lvl="0" indent="0" marL="0">
+              <a:buNone/>
+            </a:pPr>
+            <a:r>
+              <a:rPr/>
+              <a:t>Objectives</a:t>
+            </a:r>
+          </a:p>
+        </p:txBody>
+      </p:sp>
     </p:spTree>
   </p:cSld>
 </p:sld>

</xml_diff>